<commit_message>
Fig. 5 design draft v2: detail from Table 3, work in progress, and gaps
Data groups follow Table 3; each layer shows what is recommended today,
NWBEPs/BEPs and other work in progress (dashed), and data without a
standard (grey). Status from the Standards4BBQS forum slides (Oct 2026).

Co-Authored-By: Claude Opus 5.5 <noreply@anthropic.com>
</commit_message>
<xml_diff>
--- a/figures/fig5_bbqs_stack/fig5_bbqs_stack_design.pptx
+++ b/figures/fig5_bbqs_stack/fig5_bbqs_stack_design.pptx
@@ -10,8 +10,8 @@
   <p:notesMasterIdLst>
     <p:notesMasterId r:id="rId3"/>
   </p:notesMasterIdLst>
-  <p:sldSz cx="12192000" cy="6858000"/>
-  <p:notesSz cx="6858000" cy="12192000"/>
+  <p:sldSz cx="12191695" cy="8503920"/>
+  <p:notesSz cx="8503920" cy="12191695"/>
   <p:defaultTextStyle>
     <a:lvl1pPr marL="0" algn="l" defTabSz="914400" rtl="0" eaLnBrk="1" latinLnBrk="0" hangingPunct="1">
       <a:defRPr sz="1800" kern="1200">
@@ -502,10 +502,11 @@
           <a:p>
             <a:r>
               <a:rPr lang="en-US" dirty="0"/>
-              <a:t>Fig. 5 design draft (spec: draft/12_figures_tables.md).
-Rows: the five stacked layers in Table 1 order (1 data formats at the bottom to 5 data archives at the top), styled like the steps of Fig. 2. Schema languages (6) are shown as a box over rows 2-3, as in Fig. 2, listing which language defines which BBQS standard.
-Paths: typical BBQS data climb from raw data (grey, as Level 0 in Fig. 2) through the recommended technologies to EMBER: video + pose + ephys -&gt; HDF5/Zarr + MP4 -&gt; NWB -&gt; DANDI layout -&gt; EMBER; MRI + EEG + events -&gt; NIfTI + JSON/TSV -&gt; BIDS (+ HED) -&gt; EMBER; questionnaires and task responses -&gt; CSV + JSON -&gt; Psych-DS -&gt; EMBER.
-Arrows pass rows without a BBQS technology (e.g., BIDS and Psych-DS paths cross the file organization row; the Psych-DS path has no terminology).</a:t>
+              <a:t>Fig. 5 design draft v2 (spec: draft/12_figures_tables.md). Sources: Table 3, BBQS standards guideline, Standards4BBQS forum slides (Oct 2026).
+Rows: the five stacked layers in Table 1 order; schema languages (6) as a box over rows 2-3, as in Fig. 2.
+Columns: BBQS data grouped by the standard Table 3 recommends (NWB, BIDS, Psych-DS) and data without a recommended standard (grey, dashed).
+Status: solid = recommended for BBQS today; dashed = extension or proposal in progress (NWBEPs, BEPs, Neuro Termsets, BIDS media PR #2367, Psych-DS extension process); grey dashed = needs a standard.
+Paths: slate arrows from each data group to EMBER. Column D has no path.</a:t>
             </a:r>
             <a:endParaRPr lang="en-US" dirty="0"/>
           </a:p>
@@ -880,14 +881,415 @@
       </p:grpSpPr>
       <p:sp>
         <p:nvSpPr>
-          <p:cNvPr id="2" name="Layer 1: Data formats"/>
-          <p:cNvSpPr/>
-          <p:nvPr/>
-        </p:nvSpPr>
-        <p:spPr>
-          <a:xfrm>
-            <a:off x="274320" y="4937760"/>
-            <a:ext cx="11640312" cy="1051560"/>
+          <p:cNvPr id="2" name="Legend ok"/>
+          <p:cNvSpPr/>
+          <p:nvPr/>
+        </p:nvSpPr>
+        <p:spPr>
+          <a:xfrm>
+            <a:off x="2148840" y="128016"/>
+            <a:ext cx="457200" cy="274320"/>
+          </a:xfrm>
+          <a:prstGeom prst="roundRect">
+            <a:avLst>
+              <a:gd name="adj" fmla="val 20000"/>
+            </a:avLst>
+          </a:prstGeom>
+          <a:solidFill>
+            <a:srgbClr val="FFFFFF"/>
+          </a:solidFill>
+          <a:ln w="15875">
+            <a:solidFill>
+              <a:srgbClr val="D55E00"/>
+            </a:solidFill>
+            <a:prstDash val="solid"/>
+          </a:ln>
+        </p:spPr>
+      </p:sp>
+      <p:sp>
+        <p:nvSpPr>
+          <p:cNvPr id="3" name="Text 1"/>
+          <p:cNvSpPr txBox="1"/>
+          <p:nvPr/>
+        </p:nvSpPr>
+        <p:spPr>
+          <a:xfrm>
+            <a:off x="2148840" y="128016"/>
+            <a:ext cx="457200" cy="274320"/>
+          </a:xfrm>
+          <a:prstGeom prst="rect">
+            <a:avLst/>
+          </a:prstGeom>
+          <a:noFill/>
+          <a:ln/>
+        </p:spPr>
+        <p:txBody>
+          <a:bodyPr wrap="square" lIns="25400" tIns="63500" rIns="63500" bIns="25400" rtlCol="0" anchor="ctr"/>
+          <a:lstStyle/>
+          <a:p>
+            <a:pPr algn="ctr" indent="0" marL="0">
+              <a:buNone/>
+            </a:pPr>
+            <a:endParaRPr lang="en-US" sz="1000" dirty="0"/>
+          </a:p>
+        </p:txBody>
+      </p:sp>
+      <p:sp>
+        <p:nvSpPr>
+          <p:cNvPr id="4" name="Shape 2"/>
+          <p:cNvSpPr/>
+          <p:nvPr/>
+        </p:nvSpPr>
+        <p:spPr>
+          <a:xfrm>
+            <a:off x="2148840" y="128016"/>
+            <a:ext cx="457200" cy="274320"/>
+          </a:xfrm>
+          <a:prstGeom prst="roundRect">
+            <a:avLst>
+              <a:gd name="adj" fmla="val 20000"/>
+            </a:avLst>
+          </a:prstGeom>
+          <a:solidFill>
+            <a:srgbClr val="FFFFFF"/>
+          </a:solidFill>
+          <a:ln w="15875">
+            <a:solidFill>
+              <a:srgbClr val="8A96A3"/>
+            </a:solidFill>
+            <a:prstDash val="solid"/>
+          </a:ln>
+        </p:spPr>
+      </p:sp>
+      <p:sp>
+        <p:nvSpPr>
+          <p:cNvPr id="5" name="Text 3"/>
+          <p:cNvSpPr txBox="1"/>
+          <p:nvPr/>
+        </p:nvSpPr>
+        <p:spPr>
+          <a:xfrm>
+            <a:off x="2697480" y="128016"/>
+            <a:ext cx="1600200" cy="274320"/>
+          </a:xfrm>
+          <a:prstGeom prst="rect">
+            <a:avLst/>
+          </a:prstGeom>
+          <a:noFill/>
+          <a:ln/>
+        </p:spPr>
+        <p:txBody>
+          <a:bodyPr wrap="square" lIns="0" tIns="0" rIns="0" bIns="0" rtlCol="0" anchor="ctr"/>
+          <a:lstStyle/>
+          <a:p>
+            <a:pPr indent="0" marL="0">
+              <a:buNone/>
+            </a:pPr>
+            <a:r>
+              <a:rPr lang="en-US" sz="1050" dirty="0">
+                <a:solidFill>
+                  <a:srgbClr val="1F2933"/>
+                </a:solidFill>
+                <a:latin typeface="Arial" pitchFamily="34" charset="0"/>
+                <a:ea typeface="Arial" pitchFamily="34" charset="-122"/>
+                <a:cs typeface="Arial" pitchFamily="34" charset="-120"/>
+              </a:rPr>
+              <a:t>Recommended for BBQS</a:t>
+            </a:r>
+            <a:endParaRPr lang="en-US" sz="1050" dirty="0"/>
+          </a:p>
+        </p:txBody>
+      </p:sp>
+      <p:sp>
+        <p:nvSpPr>
+          <p:cNvPr id="6" name="Legend wip"/>
+          <p:cNvSpPr/>
+          <p:nvPr/>
+        </p:nvSpPr>
+        <p:spPr>
+          <a:xfrm>
+            <a:off x="4572000" y="128016"/>
+            <a:ext cx="457200" cy="274320"/>
+          </a:xfrm>
+          <a:prstGeom prst="roundRect">
+            <a:avLst>
+              <a:gd name="adj" fmla="val 20000"/>
+            </a:avLst>
+          </a:prstGeom>
+          <a:solidFill>
+            <a:srgbClr val="FFFFFF"/>
+          </a:solidFill>
+          <a:ln w="15875">
+            <a:solidFill>
+              <a:srgbClr val="D55E00"/>
+            </a:solidFill>
+            <a:prstDash val="dash"/>
+          </a:ln>
+        </p:spPr>
+      </p:sp>
+      <p:sp>
+        <p:nvSpPr>
+          <p:cNvPr id="7" name="Text 5"/>
+          <p:cNvSpPr txBox="1"/>
+          <p:nvPr/>
+        </p:nvSpPr>
+        <p:spPr>
+          <a:xfrm>
+            <a:off x="4572000" y="128016"/>
+            <a:ext cx="457200" cy="274320"/>
+          </a:xfrm>
+          <a:prstGeom prst="rect">
+            <a:avLst/>
+          </a:prstGeom>
+          <a:noFill/>
+          <a:ln/>
+        </p:spPr>
+        <p:txBody>
+          <a:bodyPr wrap="square" lIns="25400" tIns="63500" rIns="63500" bIns="25400" rtlCol="0" anchor="ctr"/>
+          <a:lstStyle/>
+          <a:p>
+            <a:pPr algn="ctr" indent="0" marL="0">
+              <a:buNone/>
+            </a:pPr>
+            <a:endParaRPr lang="en-US" sz="1000" dirty="0"/>
+          </a:p>
+        </p:txBody>
+      </p:sp>
+      <p:sp>
+        <p:nvSpPr>
+          <p:cNvPr id="8" name="Shape 6"/>
+          <p:cNvSpPr/>
+          <p:nvPr/>
+        </p:nvSpPr>
+        <p:spPr>
+          <a:xfrm>
+            <a:off x="4572000" y="128016"/>
+            <a:ext cx="457200" cy="274320"/>
+          </a:xfrm>
+          <a:prstGeom prst="roundRect">
+            <a:avLst>
+              <a:gd name="adj" fmla="val 20000"/>
+            </a:avLst>
+          </a:prstGeom>
+          <a:solidFill>
+            <a:srgbClr val="FFFFFF"/>
+          </a:solidFill>
+          <a:ln w="15875">
+            <a:solidFill>
+              <a:srgbClr val="8A96A3"/>
+            </a:solidFill>
+            <a:prstDash val="dash"/>
+          </a:ln>
+        </p:spPr>
+      </p:sp>
+      <p:sp>
+        <p:nvSpPr>
+          <p:cNvPr id="9" name="Text 7"/>
+          <p:cNvSpPr txBox="1"/>
+          <p:nvPr/>
+        </p:nvSpPr>
+        <p:spPr>
+          <a:xfrm>
+            <a:off x="5120640" y="128016"/>
+            <a:ext cx="2377440" cy="274320"/>
+          </a:xfrm>
+          <a:prstGeom prst="rect">
+            <a:avLst/>
+          </a:prstGeom>
+          <a:noFill/>
+          <a:ln/>
+        </p:spPr>
+        <p:txBody>
+          <a:bodyPr wrap="square" lIns="0" tIns="0" rIns="0" bIns="0" rtlCol="0" anchor="ctr"/>
+          <a:lstStyle/>
+          <a:p>
+            <a:pPr indent="0" marL="0">
+              <a:buNone/>
+            </a:pPr>
+            <a:r>
+              <a:rPr lang="en-US" sz="1050" dirty="0">
+                <a:solidFill>
+                  <a:srgbClr val="1F2933"/>
+                </a:solidFill>
+                <a:latin typeface="Arial" pitchFamily="34" charset="0"/>
+                <a:ea typeface="Arial" pitchFamily="34" charset="-122"/>
+                <a:cs typeface="Arial" pitchFamily="34" charset="-120"/>
+              </a:rPr>
+              <a:t>In progress (extension or proposal)</a:t>
+            </a:r>
+            <a:endParaRPr lang="en-US" sz="1050" dirty="0"/>
+          </a:p>
+        </p:txBody>
+      </p:sp>
+      <p:sp>
+        <p:nvSpPr>
+          <p:cNvPr id="10" name="Legend gap"/>
+          <p:cNvSpPr/>
+          <p:nvPr/>
+        </p:nvSpPr>
+        <p:spPr>
+          <a:xfrm>
+            <a:off x="7772400" y="128016"/>
+            <a:ext cx="457200" cy="274320"/>
+          </a:xfrm>
+          <a:prstGeom prst="roundRect">
+            <a:avLst>
+              <a:gd name="adj" fmla="val 20000"/>
+            </a:avLst>
+          </a:prstGeom>
+          <a:solidFill>
+            <a:srgbClr val="8A96A3">
+              <a:alpha val="15000"/>
+            </a:srgbClr>
+          </a:solidFill>
+          <a:ln w="15875">
+            <a:solidFill>
+              <a:srgbClr val="8A96A3"/>
+            </a:solidFill>
+            <a:prstDash val="dash"/>
+          </a:ln>
+        </p:spPr>
+      </p:sp>
+      <p:sp>
+        <p:nvSpPr>
+          <p:cNvPr id="11" name="Text 9"/>
+          <p:cNvSpPr txBox="1"/>
+          <p:nvPr/>
+        </p:nvSpPr>
+        <p:spPr>
+          <a:xfrm>
+            <a:off x="7772400" y="128016"/>
+            <a:ext cx="457200" cy="274320"/>
+          </a:xfrm>
+          <a:prstGeom prst="rect">
+            <a:avLst/>
+          </a:prstGeom>
+          <a:noFill/>
+          <a:ln/>
+        </p:spPr>
+        <p:txBody>
+          <a:bodyPr wrap="square" lIns="25400" tIns="63500" rIns="63500" bIns="25400" rtlCol="0" anchor="ctr"/>
+          <a:lstStyle/>
+          <a:p>
+            <a:pPr algn="ctr" indent="0" marL="0">
+              <a:buNone/>
+            </a:pPr>
+            <a:endParaRPr lang="en-US" sz="1000" dirty="0"/>
+          </a:p>
+        </p:txBody>
+      </p:sp>
+      <p:sp>
+        <p:nvSpPr>
+          <p:cNvPr id="12" name="Text 10"/>
+          <p:cNvSpPr txBox="1"/>
+          <p:nvPr/>
+        </p:nvSpPr>
+        <p:spPr>
+          <a:xfrm>
+            <a:off x="8321040" y="128016"/>
+            <a:ext cx="1188720" cy="274320"/>
+          </a:xfrm>
+          <a:prstGeom prst="rect">
+            <a:avLst/>
+          </a:prstGeom>
+          <a:noFill/>
+          <a:ln/>
+        </p:spPr>
+        <p:txBody>
+          <a:bodyPr wrap="square" lIns="0" tIns="0" rIns="0" bIns="0" rtlCol="0" anchor="ctr"/>
+          <a:lstStyle/>
+          <a:p>
+            <a:pPr indent="0" marL="0">
+              <a:buNone/>
+            </a:pPr>
+            <a:r>
+              <a:rPr lang="en-US" sz="1050" dirty="0">
+                <a:solidFill>
+                  <a:srgbClr val="1F2933"/>
+                </a:solidFill>
+                <a:latin typeface="Arial" pitchFamily="34" charset="0"/>
+                <a:ea typeface="Arial" pitchFamily="34" charset="-122"/>
+                <a:cs typeface="Arial" pitchFamily="34" charset="-120"/>
+              </a:rPr>
+              <a:t>Needs a standard</a:t>
+            </a:r>
+            <a:endParaRPr lang="en-US" sz="1050" dirty="0"/>
+          </a:p>
+        </p:txBody>
+      </p:sp>
+      <p:sp>
+        <p:nvSpPr>
+          <p:cNvPr id="13" name="Shape 11"/>
+          <p:cNvSpPr/>
+          <p:nvPr/>
+        </p:nvSpPr>
+        <p:spPr>
+          <a:xfrm>
+            <a:off x="9784080" y="265176"/>
+            <a:ext cx="502920" cy="0"/>
+          </a:xfrm>
+          <a:prstGeom prst="line">
+            <a:avLst/>
+          </a:prstGeom>
+          <a:noFill/>
+          <a:ln w="28575">
+            <a:solidFill>
+              <a:srgbClr val="44546A"/>
+            </a:solidFill>
+            <a:prstDash val="solid"/>
+            <a:tailEnd type="triangle"/>
+          </a:ln>
+        </p:spPr>
+      </p:sp>
+      <p:sp>
+        <p:nvSpPr>
+          <p:cNvPr id="14" name="Text 12"/>
+          <p:cNvSpPr txBox="1"/>
+          <p:nvPr/>
+        </p:nvSpPr>
+        <p:spPr>
+          <a:xfrm>
+            <a:off x="10378440" y="128016"/>
+            <a:ext cx="2011680" cy="274320"/>
+          </a:xfrm>
+          <a:prstGeom prst="rect">
+            <a:avLst/>
+          </a:prstGeom>
+          <a:noFill/>
+          <a:ln/>
+        </p:spPr>
+        <p:txBody>
+          <a:bodyPr wrap="square" lIns="0" tIns="0" rIns="0" bIns="0" rtlCol="0" anchor="ctr"/>
+          <a:lstStyle/>
+          <a:p>
+            <a:pPr indent="0" marL="0">
+              <a:buNone/>
+            </a:pPr>
+            <a:r>
+              <a:rPr lang="en-US" sz="1050" dirty="0">
+                <a:solidFill>
+                  <a:srgbClr val="1F2933"/>
+                </a:solidFill>
+                <a:latin typeface="Arial" pitchFamily="34" charset="0"/>
+                <a:ea typeface="Arial" pitchFamily="34" charset="-122"/>
+                <a:cs typeface="Arial" pitchFamily="34" charset="-120"/>
+              </a:rPr>
+              <a:t>Typical path to the archive</a:t>
+            </a:r>
+            <a:endParaRPr lang="en-US" sz="1050" dirty="0"/>
+          </a:p>
+        </p:txBody>
+      </p:sp>
+      <p:sp>
+        <p:nvSpPr>
+          <p:cNvPr id="15" name="Layer 1: Data formats"/>
+          <p:cNvSpPr/>
+          <p:nvPr/>
+        </p:nvSpPr>
+        <p:spPr>
+          <a:xfrm>
+            <a:off x="274320" y="6446520"/>
+            <a:ext cx="11640312" cy="804672"/>
           </a:xfrm>
           <a:prstGeom prst="rect">
             <a:avLst/>
@@ -907,13 +1309,13 @@
       </p:sp>
       <p:sp>
         <p:nvSpPr>
-          <p:cNvPr id="3" name="Tread 1"/>
-          <p:cNvSpPr/>
-          <p:nvPr/>
-        </p:nvSpPr>
-        <p:spPr>
-          <a:xfrm>
-            <a:off x="274320" y="4937760"/>
+          <p:cNvPr id="16" name="Tread 1"/>
+          <p:cNvSpPr/>
+          <p:nvPr/>
+        </p:nvSpPr>
+        <p:spPr>
+          <a:xfrm>
+            <a:off x="274320" y="6446520"/>
             <a:ext cx="11640312" cy="73152"/>
           </a:xfrm>
           <a:prstGeom prst="rect">
@@ -932,13 +1334,13 @@
       </p:sp>
       <p:sp>
         <p:nvSpPr>
-          <p:cNvPr id="4" name="Badge 1"/>
-          <p:cNvSpPr/>
-          <p:nvPr/>
-        </p:nvSpPr>
-        <p:spPr>
-          <a:xfrm>
-            <a:off x="411480" y="5184648"/>
+          <p:cNvPr id="17" name="Badge 1"/>
+          <p:cNvSpPr/>
+          <p:nvPr/>
+        </p:nvSpPr>
+        <p:spPr>
+          <a:xfrm>
+            <a:off x="384048" y="6629400"/>
             <a:ext cx="292608" cy="292608"/>
           </a:xfrm>
           <a:prstGeom prst="ellipse">
@@ -957,13 +1359,13 @@
       </p:sp>
       <p:sp>
         <p:nvSpPr>
-          <p:cNvPr id="5" name="Text 3"/>
+          <p:cNvPr id="18" name="Text 16"/>
           <p:cNvSpPr txBox="1"/>
           <p:nvPr/>
         </p:nvSpPr>
         <p:spPr>
           <a:xfrm>
-            <a:off x="411480" y="5184648"/>
+            <a:off x="384048" y="6629400"/>
             <a:ext cx="292608" cy="292608"/>
           </a:xfrm>
           <a:prstGeom prst="rect">
@@ -996,14 +1398,14 @@
       </p:sp>
       <p:sp>
         <p:nvSpPr>
-          <p:cNvPr id="6" name="Text 4"/>
+          <p:cNvPr id="19" name="Text 17"/>
           <p:cNvSpPr txBox="1"/>
           <p:nvPr/>
         </p:nvSpPr>
         <p:spPr>
           <a:xfrm>
-            <a:off x="795528" y="5184648"/>
-            <a:ext cx="1783080" cy="182880"/>
+            <a:off x="731520" y="6629400"/>
+            <a:ext cx="1371600" cy="548640"/>
           </a:xfrm>
           <a:prstGeom prst="rect">
             <a:avLst/>
@@ -1016,10 +1418,13 @@
           <a:lstStyle/>
           <a:p>
             <a:pPr indent="0" marL="0">
-              <a:buNone/>
-            </a:pPr>
-            <a:r>
-              <a:rPr lang="en-US" sz="1200" b="1" dirty="0">
+              <a:spcAft>
+                <a:spcPts val="300"/>
+              </a:spcAft>
+              <a:buNone/>
+            </a:pPr>
+            <a:r>
+              <a:rPr lang="en-US" sz="1150" b="1" dirty="0">
                 <a:solidFill>
                   <a:srgbClr val="1F2933"/>
                 </a:solidFill>
@@ -1029,36 +1434,17 @@
               </a:rPr>
               <a:t>Data formats</a:t>
             </a:r>
-            <a:endParaRPr lang="en-US" sz="1200" dirty="0"/>
-          </a:p>
-        </p:txBody>
-      </p:sp>
-      <p:sp>
-        <p:nvSpPr>
-          <p:cNvPr id="7" name="Text 5"/>
-          <p:cNvSpPr txBox="1"/>
-          <p:nvPr/>
-        </p:nvSpPr>
-        <p:spPr>
-          <a:xfrm>
-            <a:off x="795528" y="5440680"/>
-            <a:ext cx="1783080" cy="201168"/>
-          </a:xfrm>
-          <a:prstGeom prst="rect">
-            <a:avLst/>
-          </a:prstGeom>
-          <a:noFill/>
-          <a:ln/>
-        </p:spPr>
-        <p:txBody>
-          <a:bodyPr wrap="square" lIns="0" tIns="0" rIns="0" bIns="0" rtlCol="0" anchor="t"/>
-          <a:lstStyle/>
+            <a:endParaRPr lang="en-US" sz="1150" dirty="0"/>
+          </a:p>
           <a:p>
             <a:pPr indent="0" marL="0">
-              <a:buNone/>
-            </a:pPr>
-            <a:r>
-              <a:rPr lang="en-US" sz="1050" i="1" dirty="0">
+              <a:spcAft>
+                <a:spcPts val="300"/>
+              </a:spcAft>
+              <a:buNone/>
+            </a:pPr>
+            <a:r>
+              <a:rPr lang="en-US" sz="1000" i="1" dirty="0">
                 <a:solidFill>
                   <a:srgbClr val="5B6770"/>
                 </a:solidFill>
@@ -1068,20 +1454,20 @@
               </a:rPr>
               <a:t>Map data to storage</a:t>
             </a:r>
-            <a:endParaRPr lang="en-US" sz="1050" dirty="0"/>
-          </a:p>
-        </p:txBody>
-      </p:sp>
-      <p:sp>
-        <p:nvSpPr>
-          <p:cNvPr id="8" name="Layer 2: File organization standards"/>
-          <p:cNvSpPr/>
-          <p:nvPr/>
-        </p:nvSpPr>
-        <p:spPr>
-          <a:xfrm>
-            <a:off x="274320" y="3794760"/>
-            <a:ext cx="11640312" cy="1051560"/>
+            <a:endParaRPr lang="en-US" sz="1150" dirty="0"/>
+          </a:p>
+        </p:txBody>
+      </p:sp>
+      <p:sp>
+        <p:nvSpPr>
+          <p:cNvPr id="20" name="Layer 2: File organization standards"/>
+          <p:cNvSpPr/>
+          <p:nvPr/>
+        </p:nvSpPr>
+        <p:spPr>
+          <a:xfrm>
+            <a:off x="274320" y="4526280"/>
+            <a:ext cx="11640312" cy="1828800"/>
           </a:xfrm>
           <a:prstGeom prst="rect">
             <a:avLst/>
@@ -1101,13 +1487,13 @@
       </p:sp>
       <p:sp>
         <p:nvSpPr>
-          <p:cNvPr id="9" name="Tread 2"/>
-          <p:cNvSpPr/>
-          <p:nvPr/>
-        </p:nvSpPr>
-        <p:spPr>
-          <a:xfrm>
-            <a:off x="274320" y="3794760"/>
+          <p:cNvPr id="21" name="Tread 2"/>
+          <p:cNvSpPr/>
+          <p:nvPr/>
+        </p:nvSpPr>
+        <p:spPr>
+          <a:xfrm>
+            <a:off x="274320" y="4526280"/>
             <a:ext cx="11640312" cy="73152"/>
           </a:xfrm>
           <a:prstGeom prst="rect">
@@ -1126,13 +1512,13 @@
       </p:sp>
       <p:sp>
         <p:nvSpPr>
-          <p:cNvPr id="10" name="Badge 2"/>
-          <p:cNvSpPr/>
-          <p:nvPr/>
-        </p:nvSpPr>
-        <p:spPr>
-          <a:xfrm>
-            <a:off x="411480" y="4041648"/>
+          <p:cNvPr id="22" name="Badge 2"/>
+          <p:cNvSpPr/>
+          <p:nvPr/>
+        </p:nvSpPr>
+        <p:spPr>
+          <a:xfrm>
+            <a:off x="384048" y="4709160"/>
             <a:ext cx="292608" cy="292608"/>
           </a:xfrm>
           <a:prstGeom prst="ellipse">
@@ -1151,13 +1537,13 @@
       </p:sp>
       <p:sp>
         <p:nvSpPr>
-          <p:cNvPr id="11" name="Text 9"/>
+          <p:cNvPr id="23" name="Text 21"/>
           <p:cNvSpPr txBox="1"/>
           <p:nvPr/>
         </p:nvSpPr>
         <p:spPr>
           <a:xfrm>
-            <a:off x="411480" y="4041648"/>
+            <a:off x="384048" y="4709160"/>
             <a:ext cx="292608" cy="292608"/>
           </a:xfrm>
           <a:prstGeom prst="rect">
@@ -1190,14 +1576,14 @@
       </p:sp>
       <p:sp>
         <p:nvSpPr>
-          <p:cNvPr id="12" name="Text 10"/>
+          <p:cNvPr id="24" name="Text 22"/>
           <p:cNvSpPr txBox="1"/>
           <p:nvPr/>
         </p:nvSpPr>
         <p:spPr>
           <a:xfrm>
-            <a:off x="795528" y="4041648"/>
-            <a:ext cx="1783080" cy="365760"/>
+            <a:off x="731520" y="4709160"/>
+            <a:ext cx="1371600" cy="1572768"/>
           </a:xfrm>
           <a:prstGeom prst="rect">
             <a:avLst/>
@@ -1210,10 +1596,13 @@
           <a:lstStyle/>
           <a:p>
             <a:pPr indent="0" marL="0">
-              <a:buNone/>
-            </a:pPr>
-            <a:r>
-              <a:rPr lang="en-US" sz="1200" b="1" dirty="0">
+              <a:spcAft>
+                <a:spcPts val="300"/>
+              </a:spcAft>
+              <a:buNone/>
+            </a:pPr>
+            <a:r>
+              <a:rPr lang="en-US" sz="1150" b="1" dirty="0">
                 <a:solidFill>
                   <a:srgbClr val="1F2933"/>
                 </a:solidFill>
@@ -1223,36 +1612,17 @@
               </a:rPr>
               <a:t>File organization standards</a:t>
             </a:r>
-            <a:endParaRPr lang="en-US" sz="1200" dirty="0"/>
-          </a:p>
-        </p:txBody>
-      </p:sp>
-      <p:sp>
-        <p:nvSpPr>
-          <p:cNvPr id="13" name="Text 11"/>
-          <p:cNvSpPr txBox="1"/>
-          <p:nvPr/>
-        </p:nvSpPr>
-        <p:spPr>
-          <a:xfrm>
-            <a:off x="795528" y="4480560"/>
-            <a:ext cx="1783080" cy="201168"/>
-          </a:xfrm>
-          <a:prstGeom prst="rect">
-            <a:avLst/>
-          </a:prstGeom>
-          <a:noFill/>
-          <a:ln/>
-        </p:spPr>
-        <p:txBody>
-          <a:bodyPr wrap="square" lIns="0" tIns="0" rIns="0" bIns="0" rtlCol="0" anchor="t"/>
-          <a:lstStyle/>
+            <a:endParaRPr lang="en-US" sz="1150" dirty="0"/>
+          </a:p>
           <a:p>
             <a:pPr indent="0" marL="0">
-              <a:buNone/>
-            </a:pPr>
-            <a:r>
-              <a:rPr lang="en-US" sz="1050" i="1" dirty="0">
+              <a:spcAft>
+                <a:spcPts val="300"/>
+              </a:spcAft>
+              <a:buNone/>
+            </a:pPr>
+            <a:r>
+              <a:rPr lang="en-US" sz="1000" i="1" dirty="0">
                 <a:solidFill>
                   <a:srgbClr val="5B6770"/>
                 </a:solidFill>
@@ -1262,20 +1632,20 @@
               </a:rPr>
               <a:t>Organize data within a file</a:t>
             </a:r>
-            <a:endParaRPr lang="en-US" sz="1050" dirty="0"/>
-          </a:p>
-        </p:txBody>
-      </p:sp>
-      <p:sp>
-        <p:nvSpPr>
-          <p:cNvPr id="14" name="Layer 3: Dataset organization standards"/>
-          <p:cNvSpPr/>
-          <p:nvPr/>
-        </p:nvSpPr>
-        <p:spPr>
-          <a:xfrm>
-            <a:off x="274320" y="2651760"/>
-            <a:ext cx="11640312" cy="1051560"/>
+            <a:endParaRPr lang="en-US" sz="1150" dirty="0"/>
+          </a:p>
+        </p:txBody>
+      </p:sp>
+      <p:sp>
+        <p:nvSpPr>
+          <p:cNvPr id="25" name="Layer 3: Dataset organization standards"/>
+          <p:cNvSpPr/>
+          <p:nvPr/>
+        </p:nvSpPr>
+        <p:spPr>
+          <a:xfrm>
+            <a:off x="274320" y="2679192"/>
+            <a:ext cx="11640312" cy="1755648"/>
           </a:xfrm>
           <a:prstGeom prst="rect">
             <a:avLst/>
@@ -1295,13 +1665,13 @@
       </p:sp>
       <p:sp>
         <p:nvSpPr>
-          <p:cNvPr id="15" name="Tread 3"/>
-          <p:cNvSpPr/>
-          <p:nvPr/>
-        </p:nvSpPr>
-        <p:spPr>
-          <a:xfrm>
-            <a:off x="274320" y="2651760"/>
+          <p:cNvPr id="26" name="Tread 3"/>
+          <p:cNvSpPr/>
+          <p:nvPr/>
+        </p:nvSpPr>
+        <p:spPr>
+          <a:xfrm>
+            <a:off x="274320" y="2679192"/>
             <a:ext cx="11640312" cy="73152"/>
           </a:xfrm>
           <a:prstGeom prst="rect">
@@ -1320,13 +1690,13 @@
       </p:sp>
       <p:sp>
         <p:nvSpPr>
-          <p:cNvPr id="16" name="Badge 3"/>
-          <p:cNvSpPr/>
-          <p:nvPr/>
-        </p:nvSpPr>
-        <p:spPr>
-          <a:xfrm>
-            <a:off x="411480" y="2898648"/>
+          <p:cNvPr id="27" name="Badge 3"/>
+          <p:cNvSpPr/>
+          <p:nvPr/>
+        </p:nvSpPr>
+        <p:spPr>
+          <a:xfrm>
+            <a:off x="384048" y="2862072"/>
             <a:ext cx="292608" cy="292608"/>
           </a:xfrm>
           <a:prstGeom prst="ellipse">
@@ -1345,13 +1715,13 @@
       </p:sp>
       <p:sp>
         <p:nvSpPr>
-          <p:cNvPr id="17" name="Text 15"/>
+          <p:cNvPr id="28" name="Text 26"/>
           <p:cNvSpPr txBox="1"/>
           <p:nvPr/>
         </p:nvSpPr>
         <p:spPr>
           <a:xfrm>
-            <a:off x="411480" y="2898648"/>
+            <a:off x="384048" y="2862072"/>
             <a:ext cx="292608" cy="292608"/>
           </a:xfrm>
           <a:prstGeom prst="rect">
@@ -1384,14 +1754,14 @@
       </p:sp>
       <p:sp>
         <p:nvSpPr>
-          <p:cNvPr id="18" name="Text 16"/>
+          <p:cNvPr id="29" name="Text 27"/>
           <p:cNvSpPr txBox="1"/>
           <p:nvPr/>
         </p:nvSpPr>
         <p:spPr>
           <a:xfrm>
-            <a:off x="795528" y="2898648"/>
-            <a:ext cx="1783080" cy="365760"/>
+            <a:off x="731520" y="2862072"/>
+            <a:ext cx="1371600" cy="1499616"/>
           </a:xfrm>
           <a:prstGeom prst="rect">
             <a:avLst/>
@@ -1404,10 +1774,13 @@
           <a:lstStyle/>
           <a:p>
             <a:pPr indent="0" marL="0">
-              <a:buNone/>
-            </a:pPr>
-            <a:r>
-              <a:rPr lang="en-US" sz="1200" b="1" dirty="0">
+              <a:spcAft>
+                <a:spcPts val="300"/>
+              </a:spcAft>
+              <a:buNone/>
+            </a:pPr>
+            <a:r>
+              <a:rPr lang="en-US" sz="1150" b="1" dirty="0">
                 <a:solidFill>
                   <a:srgbClr val="1F2933"/>
                 </a:solidFill>
@@ -1417,36 +1790,17 @@
               </a:rPr>
               <a:t>Dataset organization standards</a:t>
             </a:r>
-            <a:endParaRPr lang="en-US" sz="1200" dirty="0"/>
-          </a:p>
-        </p:txBody>
-      </p:sp>
-      <p:sp>
-        <p:nvSpPr>
-          <p:cNvPr id="19" name="Text 17"/>
-          <p:cNvSpPr txBox="1"/>
-          <p:nvPr/>
-        </p:nvSpPr>
-        <p:spPr>
-          <a:xfrm>
-            <a:off x="795528" y="3337560"/>
-            <a:ext cx="1783080" cy="201168"/>
-          </a:xfrm>
-          <a:prstGeom prst="rect">
-            <a:avLst/>
-          </a:prstGeom>
-          <a:noFill/>
-          <a:ln/>
-        </p:spPr>
-        <p:txBody>
-          <a:bodyPr wrap="square" lIns="0" tIns="0" rIns="0" bIns="0" rtlCol="0" anchor="t"/>
-          <a:lstStyle/>
+            <a:endParaRPr lang="en-US" sz="1150" dirty="0"/>
+          </a:p>
           <a:p>
             <a:pPr indent="0" marL="0">
-              <a:buNone/>
-            </a:pPr>
-            <a:r>
-              <a:rPr lang="en-US" sz="1050" i="1" dirty="0">
+              <a:spcAft>
+                <a:spcPts val="300"/>
+              </a:spcAft>
+              <a:buNone/>
+            </a:pPr>
+            <a:r>
+              <a:rPr lang="en-US" sz="1000" i="1" dirty="0">
                 <a:solidFill>
                   <a:srgbClr val="5B6770"/>
                 </a:solidFill>
@@ -1456,20 +1810,20 @@
               </a:rPr>
               <a:t>Organize collections of files</a:t>
             </a:r>
-            <a:endParaRPr lang="en-US" sz="1050" dirty="0"/>
-          </a:p>
-        </p:txBody>
-      </p:sp>
-      <p:sp>
-        <p:nvSpPr>
-          <p:cNvPr id="20" name="Layer 4: Ontologies &amp; terminologies"/>
-          <p:cNvSpPr/>
-          <p:nvPr/>
-        </p:nvSpPr>
-        <p:spPr>
-          <a:xfrm>
-            <a:off x="274320" y="1508760"/>
-            <a:ext cx="11640312" cy="1051560"/>
+            <a:endParaRPr lang="en-US" sz="1150" dirty="0"/>
+          </a:p>
+        </p:txBody>
+      </p:sp>
+      <p:sp>
+        <p:nvSpPr>
+          <p:cNvPr id="30" name="Layer 4: Ontologies &amp; terminologies"/>
+          <p:cNvSpPr/>
+          <p:nvPr/>
+        </p:nvSpPr>
+        <p:spPr>
+          <a:xfrm>
+            <a:off x="274320" y="1399032"/>
+            <a:ext cx="11640312" cy="1188720"/>
           </a:xfrm>
           <a:prstGeom prst="rect">
             <a:avLst/>
@@ -1489,13 +1843,13 @@
       </p:sp>
       <p:sp>
         <p:nvSpPr>
-          <p:cNvPr id="21" name="Tread 4"/>
-          <p:cNvSpPr/>
-          <p:nvPr/>
-        </p:nvSpPr>
-        <p:spPr>
-          <a:xfrm>
-            <a:off x="274320" y="1508760"/>
+          <p:cNvPr id="31" name="Tread 4"/>
+          <p:cNvSpPr/>
+          <p:nvPr/>
+        </p:nvSpPr>
+        <p:spPr>
+          <a:xfrm>
+            <a:off x="274320" y="1399032"/>
             <a:ext cx="11640312" cy="73152"/>
           </a:xfrm>
           <a:prstGeom prst="rect">
@@ -1514,13 +1868,13 @@
       </p:sp>
       <p:sp>
         <p:nvSpPr>
-          <p:cNvPr id="22" name="Badge 4"/>
-          <p:cNvSpPr/>
-          <p:nvPr/>
-        </p:nvSpPr>
-        <p:spPr>
-          <a:xfrm>
-            <a:off x="411480" y="1755648"/>
+          <p:cNvPr id="32" name="Badge 4"/>
+          <p:cNvSpPr/>
+          <p:nvPr/>
+        </p:nvSpPr>
+        <p:spPr>
+          <a:xfrm>
+            <a:off x="384048" y="1581912"/>
             <a:ext cx="292608" cy="292608"/>
           </a:xfrm>
           <a:prstGeom prst="ellipse">
@@ -1539,13 +1893,13 @@
       </p:sp>
       <p:sp>
         <p:nvSpPr>
-          <p:cNvPr id="23" name="Text 21"/>
+          <p:cNvPr id="33" name="Text 31"/>
           <p:cNvSpPr txBox="1"/>
           <p:nvPr/>
         </p:nvSpPr>
         <p:spPr>
           <a:xfrm>
-            <a:off x="411480" y="1755648"/>
+            <a:off x="384048" y="1581912"/>
             <a:ext cx="292608" cy="292608"/>
           </a:xfrm>
           <a:prstGeom prst="rect">
@@ -1578,14 +1932,14 @@
       </p:sp>
       <p:sp>
         <p:nvSpPr>
-          <p:cNvPr id="24" name="Text 22"/>
+          <p:cNvPr id="34" name="Text 32"/>
           <p:cNvSpPr txBox="1"/>
           <p:nvPr/>
         </p:nvSpPr>
         <p:spPr>
           <a:xfrm>
-            <a:off x="795528" y="1755648"/>
-            <a:ext cx="1783080" cy="365760"/>
+            <a:off x="731520" y="1581912"/>
+            <a:ext cx="1371600" cy="932688"/>
           </a:xfrm>
           <a:prstGeom prst="rect">
             <a:avLst/>
@@ -1598,10 +1952,13 @@
           <a:lstStyle/>
           <a:p>
             <a:pPr indent="0" marL="0">
-              <a:buNone/>
-            </a:pPr>
-            <a:r>
-              <a:rPr lang="en-US" sz="1200" b="1" dirty="0">
+              <a:spcAft>
+                <a:spcPts val="300"/>
+              </a:spcAft>
+              <a:buNone/>
+            </a:pPr>
+            <a:r>
+              <a:rPr lang="en-US" sz="1150" b="1" dirty="0">
                 <a:solidFill>
                   <a:srgbClr val="1F2933"/>
                 </a:solidFill>
@@ -1611,36 +1968,17 @@
               </a:rPr>
               <a:t>Ontologies &amp; terminologies</a:t>
             </a:r>
-            <a:endParaRPr lang="en-US" sz="1200" dirty="0"/>
-          </a:p>
-        </p:txBody>
-      </p:sp>
-      <p:sp>
-        <p:nvSpPr>
-          <p:cNvPr id="25" name="Text 23"/>
-          <p:cNvSpPr txBox="1"/>
-          <p:nvPr/>
-        </p:nvSpPr>
-        <p:spPr>
-          <a:xfrm>
-            <a:off x="795528" y="2194560"/>
-            <a:ext cx="1783080" cy="201168"/>
-          </a:xfrm>
-          <a:prstGeom prst="rect">
-            <a:avLst/>
-          </a:prstGeom>
-          <a:noFill/>
-          <a:ln/>
-        </p:spPr>
-        <p:txBody>
-          <a:bodyPr wrap="square" lIns="0" tIns="0" rIns="0" bIns="0" rtlCol="0" anchor="t"/>
-          <a:lstStyle/>
+            <a:endParaRPr lang="en-US" sz="1150" dirty="0"/>
+          </a:p>
           <a:p>
             <a:pPr indent="0" marL="0">
-              <a:buNone/>
-            </a:pPr>
-            <a:r>
-              <a:rPr lang="en-US" sz="1050" i="1" dirty="0">
+              <a:spcAft>
+                <a:spcPts val="300"/>
+              </a:spcAft>
+              <a:buNone/>
+            </a:pPr>
+            <a:r>
+              <a:rPr lang="en-US" sz="1000" i="1" dirty="0">
                 <a:solidFill>
                   <a:srgbClr val="5B6770"/>
                 </a:solidFill>
@@ -1650,20 +1988,20 @@
               </a:rPr>
               <a:t>Define the meaning of terms</a:t>
             </a:r>
-            <a:endParaRPr lang="en-US" sz="1050" dirty="0"/>
-          </a:p>
-        </p:txBody>
-      </p:sp>
-      <p:sp>
-        <p:nvSpPr>
-          <p:cNvPr id="26" name="Layer 5: Data archives"/>
-          <p:cNvSpPr/>
-          <p:nvPr/>
-        </p:nvSpPr>
-        <p:spPr>
-          <a:xfrm>
-            <a:off x="274320" y="365760"/>
-            <a:ext cx="11640312" cy="1051560"/>
+            <a:endParaRPr lang="en-US" sz="1150" dirty="0"/>
+          </a:p>
+        </p:txBody>
+      </p:sp>
+      <p:sp>
+        <p:nvSpPr>
+          <p:cNvPr id="35" name="Layer 5: Data archives"/>
+          <p:cNvSpPr/>
+          <p:nvPr/>
+        </p:nvSpPr>
+        <p:spPr>
+          <a:xfrm>
+            <a:off x="274320" y="539496"/>
+            <a:ext cx="11640312" cy="768096"/>
           </a:xfrm>
           <a:prstGeom prst="rect">
             <a:avLst/>
@@ -1683,13 +2021,13 @@
       </p:sp>
       <p:sp>
         <p:nvSpPr>
-          <p:cNvPr id="27" name="Tread 5"/>
-          <p:cNvSpPr/>
-          <p:nvPr/>
-        </p:nvSpPr>
-        <p:spPr>
-          <a:xfrm>
-            <a:off x="274320" y="365760"/>
+          <p:cNvPr id="36" name="Tread 5"/>
+          <p:cNvSpPr/>
+          <p:nvPr/>
+        </p:nvSpPr>
+        <p:spPr>
+          <a:xfrm>
+            <a:off x="274320" y="539496"/>
             <a:ext cx="11640312" cy="73152"/>
           </a:xfrm>
           <a:prstGeom prst="rect">
@@ -1708,13 +2046,13 @@
       </p:sp>
       <p:sp>
         <p:nvSpPr>
-          <p:cNvPr id="28" name="Badge 5"/>
-          <p:cNvSpPr/>
-          <p:nvPr/>
-        </p:nvSpPr>
-        <p:spPr>
-          <a:xfrm>
-            <a:off x="411480" y="612648"/>
+          <p:cNvPr id="37" name="Badge 5"/>
+          <p:cNvSpPr/>
+          <p:nvPr/>
+        </p:nvSpPr>
+        <p:spPr>
+          <a:xfrm>
+            <a:off x="384048" y="722376"/>
             <a:ext cx="292608" cy="292608"/>
           </a:xfrm>
           <a:prstGeom prst="ellipse">
@@ -1733,13 +2071,13 @@
       </p:sp>
       <p:sp>
         <p:nvSpPr>
-          <p:cNvPr id="29" name="Text 27"/>
+          <p:cNvPr id="38" name="Text 36"/>
           <p:cNvSpPr txBox="1"/>
           <p:nvPr/>
         </p:nvSpPr>
         <p:spPr>
           <a:xfrm>
-            <a:off x="411480" y="612648"/>
+            <a:off x="384048" y="722376"/>
             <a:ext cx="292608" cy="292608"/>
           </a:xfrm>
           <a:prstGeom prst="rect">
@@ -1772,14 +2110,14 @@
       </p:sp>
       <p:sp>
         <p:nvSpPr>
-          <p:cNvPr id="30" name="Text 28"/>
+          <p:cNvPr id="39" name="Text 37"/>
           <p:cNvSpPr txBox="1"/>
           <p:nvPr/>
         </p:nvSpPr>
         <p:spPr>
           <a:xfrm>
-            <a:off x="795528" y="612648"/>
-            <a:ext cx="1783080" cy="182880"/>
+            <a:off x="731520" y="722376"/>
+            <a:ext cx="1371600" cy="512064"/>
           </a:xfrm>
           <a:prstGeom prst="rect">
             <a:avLst/>
@@ -1792,10 +2130,13 @@
           <a:lstStyle/>
           <a:p>
             <a:pPr indent="0" marL="0">
-              <a:buNone/>
-            </a:pPr>
-            <a:r>
-              <a:rPr lang="en-US" sz="1200" b="1" dirty="0">
+              <a:spcAft>
+                <a:spcPts val="300"/>
+              </a:spcAft>
+              <a:buNone/>
+            </a:pPr>
+            <a:r>
+              <a:rPr lang="en-US" sz="1150" b="1" dirty="0">
                 <a:solidFill>
                   <a:srgbClr val="1F2933"/>
                 </a:solidFill>
@@ -1805,20 +2146,40 @@
               </a:rPr>
               <a:t>Data archives</a:t>
             </a:r>
-            <a:endParaRPr lang="en-US" sz="1200" dirty="0"/>
-          </a:p>
-        </p:txBody>
-      </p:sp>
-      <p:sp>
-        <p:nvSpPr>
-          <p:cNvPr id="31" name="Text 29"/>
+            <a:endParaRPr lang="en-US" sz="1150" dirty="0"/>
+          </a:p>
+          <a:p>
+            <a:pPr indent="0" marL="0">
+              <a:spcAft>
+                <a:spcPts val="300"/>
+              </a:spcAft>
+              <a:buNone/>
+            </a:pPr>
+            <a:r>
+              <a:rPr lang="en-US" sz="1000" i="1" dirty="0">
+                <a:solidFill>
+                  <a:srgbClr val="5B6770"/>
+                </a:solidFill>
+                <a:latin typeface="Arial" pitchFamily="34" charset="0"/>
+                <a:ea typeface="Arial" pitchFamily="34" charset="-122"/>
+                <a:cs typeface="Arial" pitchFamily="34" charset="-120"/>
+              </a:rPr>
+              <a:t>Publish, share, and discover</a:t>
+            </a:r>
+            <a:endParaRPr lang="en-US" sz="1150" dirty="0"/>
+          </a:p>
+        </p:txBody>
+      </p:sp>
+      <p:sp>
+        <p:nvSpPr>
+          <p:cNvPr id="40" name="Text 38"/>
           <p:cNvSpPr txBox="1"/>
           <p:nvPr/>
         </p:nvSpPr>
         <p:spPr>
           <a:xfrm>
-            <a:off x="795528" y="868680"/>
-            <a:ext cx="1783080" cy="201168"/>
+            <a:off x="320040" y="7479792"/>
+            <a:ext cx="1783080" cy="914400"/>
           </a:xfrm>
           <a:prstGeom prst="rect">
             <a:avLst/>
@@ -1827,14 +2188,31 @@
           <a:ln/>
         </p:spPr>
         <p:txBody>
-          <a:bodyPr wrap="square" lIns="0" tIns="0" rIns="0" bIns="0" rtlCol="0" anchor="t"/>
+          <a:bodyPr wrap="square" lIns="0" tIns="0" rIns="0" bIns="0" rtlCol="0" anchor="ctr"/>
           <a:lstStyle/>
           <a:p>
             <a:pPr indent="0" marL="0">
               <a:buNone/>
             </a:pPr>
             <a:r>
-              <a:rPr lang="en-US" sz="1050" i="1" dirty="0">
+              <a:rPr lang="en-US" sz="1150" b="1" dirty="0">
+                <a:solidFill>
+                  <a:srgbClr val="1F2933"/>
+                </a:solidFill>
+                <a:latin typeface="Arial" pitchFamily="34" charset="0"/>
+                <a:ea typeface="Arial" pitchFamily="34" charset="-122"/>
+                <a:cs typeface="Arial" pitchFamily="34" charset="-120"/>
+              </a:rPr>
+              <a:t>BBQS data</a:t>
+            </a:r>
+            <a:endParaRPr lang="en-US" sz="1150" dirty="0"/>
+          </a:p>
+          <a:p>
+            <a:pPr indent="0" marL="0">
+              <a:buNone/>
+            </a:pPr>
+            <a:r>
+              <a:rPr lang="en-US" sz="1000" i="1" dirty="0">
                 <a:solidFill>
                   <a:srgbClr val="5B6770"/>
                 </a:solidFill>
@@ -1842,22 +2220,22 @@
                 <a:ea typeface="Arial" pitchFamily="34" charset="-122"/>
                 <a:cs typeface="Arial" pitchFamily="34" charset="-120"/>
               </a:rPr>
-              <a:t>Publish, share, and discover</a:t>
-            </a:r>
-            <a:endParaRPr lang="en-US" sz="1050" dirty="0"/>
-          </a:p>
-        </p:txBody>
-      </p:sp>
-      <p:sp>
-        <p:nvSpPr>
-          <p:cNvPr id="32" name="Raw data A"/>
-          <p:cNvSpPr/>
-          <p:nvPr/>
-        </p:nvSpPr>
-        <p:spPr>
-          <a:xfrm>
-            <a:off x="2788920" y="6172200"/>
-            <a:ext cx="1920240" cy="438912"/>
+              <a:t>Grouped by the recommended standard (Table 3)</a:t>
+            </a:r>
+            <a:endParaRPr lang="en-US" sz="1150" dirty="0"/>
+          </a:p>
+        </p:txBody>
+      </p:sp>
+      <p:sp>
+        <p:nvSpPr>
+          <p:cNvPr id="41" name="Raw data A"/>
+          <p:cNvSpPr/>
+          <p:nvPr/>
+        </p:nvSpPr>
+        <p:spPr>
+          <a:xfrm>
+            <a:off x="2148840" y="7479792"/>
+            <a:ext cx="2926080" cy="914400"/>
           </a:xfrm>
           <a:prstGeom prst="rect">
             <a:avLst/>
@@ -1877,14 +2255,14 @@
       </p:sp>
       <p:sp>
         <p:nvSpPr>
-          <p:cNvPr id="33" name="Text 31"/>
+          <p:cNvPr id="42" name="Text 40"/>
           <p:cNvSpPr txBox="1"/>
           <p:nvPr/>
         </p:nvSpPr>
         <p:spPr>
           <a:xfrm>
-            <a:off x="2788920" y="6172200"/>
-            <a:ext cx="1920240" cy="438912"/>
+            <a:off x="2148840" y="7479792"/>
+            <a:ext cx="2926080" cy="914400"/>
           </a:xfrm>
           <a:prstGeom prst="rect">
             <a:avLst/>
@@ -1893,14 +2271,14 @@
           <a:ln/>
         </p:spPr>
         <p:txBody>
-          <a:bodyPr wrap="square" lIns="0" tIns="0" rIns="0" bIns="0" rtlCol="0" anchor="ctr"/>
-          <a:lstStyle/>
-          <a:p>
-            <a:pPr algn="ctr" indent="0" marL="0">
-              <a:buNone/>
-            </a:pPr>
-            <a:r>
-              <a:rPr lang="en-US" sz="1150" b="1" dirty="0">
+          <a:bodyPr wrap="square" lIns="25400" tIns="76200" rIns="76200" bIns="25400" rtlCol="0" anchor="ctr"/>
+          <a:lstStyle/>
+          <a:p>
+            <a:pPr algn="ctr" indent="0" marL="0">
+              <a:buNone/>
+            </a:pPr>
+            <a:r>
+              <a:rPr lang="en-US" sz="1100" b="1" dirty="0">
                 <a:solidFill>
                   <a:srgbClr val="1F2933"/>
                 </a:solidFill>
@@ -1908,22 +2286,39 @@
                 <a:ea typeface="Arial" pitchFamily="34" charset="-122"/>
                 <a:cs typeface="Arial" pitchFamily="34" charset="-120"/>
               </a:rPr>
-              <a:t>Video · pose · ephys</a:t>
-            </a:r>
-            <a:endParaRPr lang="en-US" sz="1150" dirty="0"/>
-          </a:p>
-        </p:txBody>
-      </p:sp>
-      <p:sp>
-        <p:nvSpPr>
-          <p:cNvPr id="34" name="Raw data B"/>
-          <p:cNvSpPr/>
-          <p:nvPr/>
-        </p:nvSpPr>
-        <p:spPr>
-          <a:xfrm>
-            <a:off x="5029200" y="6172200"/>
-            <a:ext cx="1920240" cy="438912"/>
+              <a:t>Neurophysiology + synchronized behavior</a:t>
+            </a:r>
+            <a:endParaRPr lang="en-US" sz="1100" dirty="0"/>
+          </a:p>
+          <a:p>
+            <a:pPr algn="ctr" indent="0" marL="0">
+              <a:buNone/>
+            </a:pPr>
+            <a:r>
+              <a:rPr lang="en-US" sz="950" dirty="0">
+                <a:solidFill>
+                  <a:srgbClr val="1F2933"/>
+                </a:solidFill>
+                <a:latin typeface="Arial" pitchFamily="34" charset="0"/>
+                <a:ea typeface="Arial" pitchFamily="34" charset="-122"/>
+                <a:cs typeface="Arial" pitchFamily="34" charset="-120"/>
+              </a:rPr>
+              <a:t>Ephys · optical physiology · stimulation · video · pose · eye tracking · wearables · audio · tasks &amp; events</a:t>
+            </a:r>
+            <a:endParaRPr lang="en-US" sz="1100" dirty="0"/>
+          </a:p>
+        </p:txBody>
+      </p:sp>
+      <p:sp>
+        <p:nvSpPr>
+          <p:cNvPr id="43" name="Raw data B"/>
+          <p:cNvSpPr/>
+          <p:nvPr/>
+        </p:nvSpPr>
+        <p:spPr>
+          <a:xfrm>
+            <a:off x="5166360" y="7479792"/>
+            <a:ext cx="2926080" cy="914400"/>
           </a:xfrm>
           <a:prstGeom prst="rect">
             <a:avLst/>
@@ -1943,14 +2338,14 @@
       </p:sp>
       <p:sp>
         <p:nvSpPr>
-          <p:cNvPr id="35" name="Text 33"/>
+          <p:cNvPr id="44" name="Text 42"/>
           <p:cNvSpPr txBox="1"/>
           <p:nvPr/>
         </p:nvSpPr>
         <p:spPr>
           <a:xfrm>
-            <a:off x="5029200" y="6172200"/>
-            <a:ext cx="1920240" cy="438912"/>
+            <a:off x="5166360" y="7479792"/>
+            <a:ext cx="2926080" cy="914400"/>
           </a:xfrm>
           <a:prstGeom prst="rect">
             <a:avLst/>
@@ -1959,14 +2354,14 @@
           <a:ln/>
         </p:spPr>
         <p:txBody>
-          <a:bodyPr wrap="square" lIns="0" tIns="0" rIns="0" bIns="0" rtlCol="0" anchor="ctr"/>
-          <a:lstStyle/>
-          <a:p>
-            <a:pPr algn="ctr" indent="0" marL="0">
-              <a:buNone/>
-            </a:pPr>
-            <a:r>
-              <a:rPr lang="en-US" sz="1150" b="1" dirty="0">
+          <a:bodyPr wrap="square" lIns="25400" tIns="76200" rIns="76200" bIns="25400" rtlCol="0" anchor="ctr"/>
+          <a:lstStyle/>
+          <a:p>
+            <a:pPr algn="ctr" indent="0" marL="0">
+              <a:buNone/>
+            </a:pPr>
+            <a:r>
+              <a:rPr lang="en-US" sz="1100" b="1" dirty="0">
                 <a:solidFill>
                   <a:srgbClr val="1F2933"/>
                 </a:solidFill>
@@ -1974,22 +2369,39 @@
                 <a:ea typeface="Arial" pitchFamily="34" charset="-122"/>
                 <a:cs typeface="Arial" pitchFamily="34" charset="-120"/>
               </a:rPr>
-              <a:t>MRI · EEG · events</a:t>
-            </a:r>
-            <a:endParaRPr lang="en-US" sz="1150" dirty="0"/>
-          </a:p>
-        </p:txBody>
-      </p:sp>
-      <p:sp>
-        <p:nvSpPr>
-          <p:cNvPr id="36" name="Raw data C"/>
-          <p:cNvSpPr/>
-          <p:nvPr/>
-        </p:nvSpPr>
-        <p:spPr>
-          <a:xfrm>
-            <a:off x="7269480" y="6172200"/>
-            <a:ext cx="1920240" cy="438912"/>
+              <a:t>Imaging, EEG &amp; multi-session studies</a:t>
+            </a:r>
+            <a:endParaRPr lang="en-US" sz="1100" dirty="0"/>
+          </a:p>
+          <a:p>
+            <a:pPr algn="ctr" indent="0" marL="0">
+              <a:buNone/>
+            </a:pPr>
+            <a:r>
+              <a:rPr lang="en-US" sz="950" dirty="0">
+                <a:solidFill>
+                  <a:srgbClr val="1F2933"/>
+                </a:solidFill>
+                <a:latin typeface="Arial" pitchFamily="34" charset="0"/>
+                <a:ea typeface="Arial" pitchFamily="34" charset="-122"/>
+                <a:cs typeface="Arial" pitchFamily="34" charset="-120"/>
+              </a:rPr>
+              <a:t>MRI · fMRI · PET · EEG / MEG / iEEG · motion capture · physiology · task events</a:t>
+            </a:r>
+            <a:endParaRPr lang="en-US" sz="1100" dirty="0"/>
+          </a:p>
+        </p:txBody>
+      </p:sp>
+      <p:sp>
+        <p:nvSpPr>
+          <p:cNvPr id="45" name="Raw data C"/>
+          <p:cNvSpPr/>
+          <p:nvPr/>
+        </p:nvSpPr>
+        <p:spPr>
+          <a:xfrm>
+            <a:off x="8183880" y="7479792"/>
+            <a:ext cx="1463040" cy="914400"/>
           </a:xfrm>
           <a:prstGeom prst="rect">
             <a:avLst/>
@@ -2009,14 +2421,14 @@
       </p:sp>
       <p:sp>
         <p:nvSpPr>
-          <p:cNvPr id="37" name="Text 35"/>
+          <p:cNvPr id="46" name="Text 44"/>
           <p:cNvSpPr txBox="1"/>
           <p:nvPr/>
         </p:nvSpPr>
         <p:spPr>
           <a:xfrm>
-            <a:off x="7269480" y="6172200"/>
-            <a:ext cx="1920240" cy="438912"/>
+            <a:off x="8183880" y="7479792"/>
+            <a:ext cx="1463040" cy="914400"/>
           </a:xfrm>
           <a:prstGeom prst="rect">
             <a:avLst/>
@@ -2025,14 +2437,14 @@
           <a:ln/>
         </p:spPr>
         <p:txBody>
-          <a:bodyPr wrap="square" lIns="0" tIns="0" rIns="0" bIns="0" rtlCol="0" anchor="ctr"/>
-          <a:lstStyle/>
-          <a:p>
-            <a:pPr algn="ctr" indent="0" marL="0">
-              <a:buNone/>
-            </a:pPr>
-            <a:r>
-              <a:rPr lang="en-US" sz="1150" b="1" dirty="0">
+          <a:bodyPr wrap="square" lIns="25400" tIns="76200" rIns="76200" bIns="25400" rtlCol="0" anchor="ctr"/>
+          <a:lstStyle/>
+          <a:p>
+            <a:pPr algn="ctr" indent="0" marL="0">
+              <a:buNone/>
+            </a:pPr>
+            <a:r>
+              <a:rPr lang="en-US" sz="1100" b="1" dirty="0">
                 <a:solidFill>
                   <a:srgbClr val="1F2933"/>
                 </a:solidFill>
@@ -2040,22 +2452,122 @@
                 <a:ea typeface="Arial" pitchFamily="34" charset="-122"/>
                 <a:cs typeface="Arial" pitchFamily="34" charset="-120"/>
               </a:rPr>
-              <a:t>Questionnaires · tasks</a:t>
-            </a:r>
-            <a:endParaRPr lang="en-US" sz="1150" dirty="0"/>
-          </a:p>
-        </p:txBody>
-      </p:sp>
-      <p:sp>
-        <p:nvSpPr>
-          <p:cNvPr id="38" name="Path A"/>
+              <a:t>Tabular behavior</a:t>
+            </a:r>
+            <a:endParaRPr lang="en-US" sz="1100" dirty="0"/>
+          </a:p>
+          <a:p>
+            <a:pPr algn="ctr" indent="0" marL="0">
+              <a:buNone/>
+            </a:pPr>
+            <a:r>
+              <a:rPr lang="en-US" sz="950" dirty="0">
+                <a:solidFill>
+                  <a:srgbClr val="1F2933"/>
+                </a:solidFill>
+                <a:latin typeface="Arial" pitchFamily="34" charset="0"/>
+                <a:ea typeface="Arial" pitchFamily="34" charset="-122"/>
+                <a:cs typeface="Arial" pitchFamily="34" charset="-120"/>
+              </a:rPr>
+              <a:t>Questionnaires, surveys, task responses</a:t>
+            </a:r>
+            <a:endParaRPr lang="en-US" sz="1100" dirty="0"/>
+          </a:p>
+        </p:txBody>
+      </p:sp>
+      <p:sp>
+        <p:nvSpPr>
+          <p:cNvPr id="47" name="Raw data D (no standard)"/>
+          <p:cNvSpPr/>
+          <p:nvPr/>
+        </p:nvSpPr>
+        <p:spPr>
+          <a:xfrm>
+            <a:off x="9738360" y="7479792"/>
+            <a:ext cx="2057400" cy="914400"/>
+          </a:xfrm>
+          <a:prstGeom prst="rect">
+            <a:avLst/>
+          </a:prstGeom>
+          <a:solidFill>
+            <a:srgbClr val="8A96A3">
+              <a:alpha val="15000"/>
+            </a:srgbClr>
+          </a:solidFill>
+          <a:ln w="15875">
+            <a:solidFill>
+              <a:srgbClr val="8A96A3"/>
+            </a:solidFill>
+            <a:prstDash val="dash"/>
+          </a:ln>
+        </p:spPr>
+      </p:sp>
+      <p:sp>
+        <p:nvSpPr>
+          <p:cNvPr id="48" name="Text 46"/>
+          <p:cNvSpPr txBox="1"/>
+          <p:nvPr/>
+        </p:nvSpPr>
+        <p:spPr>
+          <a:xfrm>
+            <a:off x="9738360" y="7479792"/>
+            <a:ext cx="2057400" cy="914400"/>
+          </a:xfrm>
+          <a:prstGeom prst="rect">
+            <a:avLst/>
+          </a:prstGeom>
+          <a:noFill/>
+          <a:ln/>
+        </p:spPr>
+        <p:txBody>
+          <a:bodyPr wrap="square" lIns="25400" tIns="76200" rIns="76200" bIns="25400" rtlCol="0" anchor="ctr"/>
+          <a:lstStyle/>
+          <a:p>
+            <a:pPr algn="ctr" indent="0" marL="0">
+              <a:buNone/>
+            </a:pPr>
+            <a:r>
+              <a:rPr lang="en-US" sz="1100" b="1" dirty="0">
+                <a:solidFill>
+                  <a:srgbClr val="1F2933"/>
+                </a:solidFill>
+                <a:latin typeface="Arial" pitchFamily="34" charset="0"/>
+                <a:ea typeface="Arial" pitchFamily="34" charset="-122"/>
+                <a:cs typeface="Arial" pitchFamily="34" charset="-120"/>
+              </a:rPr>
+              <a:t>No standard yet</a:t>
+            </a:r>
+            <a:endParaRPr lang="en-US" sz="1100" dirty="0"/>
+          </a:p>
+          <a:p>
+            <a:pPr algn="ctr" indent="0" marL="0">
+              <a:buNone/>
+            </a:pPr>
+            <a:r>
+              <a:rPr lang="en-US" sz="950" dirty="0">
+                <a:solidFill>
+                  <a:srgbClr val="1F2933"/>
+                </a:solidFill>
+                <a:latin typeface="Arial" pitchFamily="34" charset="0"/>
+                <a:ea typeface="Arial" pitchFamily="34" charset="-122"/>
+                <a:cs typeface="Arial" pitchFamily="34" charset="-120"/>
+              </a:rPr>
+              <a:t>Social interactions · feeding · facial expressions · home-cage monitoring · VR · force plates · EMG</a:t>
+            </a:r>
+            <a:endParaRPr lang="en-US" sz="1100" dirty="0"/>
+          </a:p>
+        </p:txBody>
+      </p:sp>
+      <p:sp>
+        <p:nvSpPr>
+          <p:cNvPr id="49" name="Path A"/>
           <p:cNvSpPr/>
           <p:nvPr/>
         </p:nvSpPr>
         <p:spPr>
           <a:xfrm flipV="1">
-            <a:off x="3749040" y="1165860"/>
-            <a:ext cx="0" cy="5006340"/>
+            <a:off x="3611880" y="1170432"/>
+            <a:ext cx="0" cy="6309360"/>
           </a:xfrm>
           <a:prstGeom prst="line">
             <a:avLst/>
@@ -2072,14 +2584,14 @@
       </p:sp>
       <p:sp>
         <p:nvSpPr>
-          <p:cNvPr id="39" name="Path B"/>
+          <p:cNvPr id="50" name="Path B"/>
           <p:cNvSpPr/>
           <p:nvPr/>
         </p:nvSpPr>
         <p:spPr>
           <a:xfrm flipV="1">
-            <a:off x="5989320" y="1165860"/>
-            <a:ext cx="0" cy="5006340"/>
+            <a:off x="6629400" y="1170432"/>
+            <a:ext cx="0" cy="6309360"/>
           </a:xfrm>
           <a:prstGeom prst="line">
             <a:avLst/>
@@ -2096,14 +2608,14 @@
       </p:sp>
       <p:sp>
         <p:nvSpPr>
-          <p:cNvPr id="40" name="Path C"/>
+          <p:cNvPr id="51" name="Path C"/>
           <p:cNvSpPr/>
           <p:nvPr/>
         </p:nvSpPr>
         <p:spPr>
           <a:xfrm flipV="1">
-            <a:off x="8229600" y="1165860"/>
-            <a:ext cx="0" cy="5006340"/>
+            <a:off x="8915400" y="1170432"/>
+            <a:ext cx="0" cy="6309360"/>
           </a:xfrm>
           <a:prstGeom prst="line">
             <a:avLst/>
@@ -2120,18 +2632,18 @@
       </p:sp>
       <p:sp>
         <p:nvSpPr>
-          <p:cNvPr id="41" name="Formats A"/>
-          <p:cNvSpPr/>
-          <p:nvPr/>
-        </p:nvSpPr>
-        <p:spPr>
-          <a:xfrm>
-            <a:off x="2788920" y="5298948"/>
-            <a:ext cx="1920240" cy="402336"/>
+          <p:cNvPr id="52" name="Formats A"/>
+          <p:cNvSpPr/>
+          <p:nvPr/>
+        </p:nvSpPr>
+        <p:spPr>
+          <a:xfrm>
+            <a:off x="2148840" y="6720840"/>
+            <a:ext cx="2926080" cy="329184"/>
           </a:xfrm>
           <a:prstGeom prst="roundRect">
             <a:avLst>
-              <a:gd name="adj" fmla="val 18182"/>
+              <a:gd name="adj" fmla="val 16667"/>
             </a:avLst>
           </a:prstGeom>
           <a:solidFill>
@@ -2147,14 +2659,14 @@
       </p:sp>
       <p:sp>
         <p:nvSpPr>
-          <p:cNvPr id="42" name="Text 40"/>
+          <p:cNvPr id="53" name="Text 51"/>
           <p:cNvSpPr txBox="1"/>
           <p:nvPr/>
         </p:nvSpPr>
         <p:spPr>
           <a:xfrm>
-            <a:off x="2788920" y="5298948"/>
-            <a:ext cx="1920240" cy="402336"/>
+            <a:off x="2148840" y="6720840"/>
+            <a:ext cx="2926080" cy="329184"/>
           </a:xfrm>
           <a:prstGeom prst="rect">
             <a:avLst/>
@@ -2163,14 +2675,14 @@
           <a:ln/>
         </p:spPr>
         <p:txBody>
-          <a:bodyPr wrap="square" lIns="508" tIns="508" rIns="508" bIns="508" rtlCol="0" anchor="ctr"/>
-          <a:lstStyle/>
-          <a:p>
-            <a:pPr algn="ctr" indent="0" marL="0">
-              <a:buNone/>
-            </a:pPr>
-            <a:r>
-              <a:rPr lang="en-US" sz="1200" b="1" dirty="0">
+          <a:bodyPr wrap="square" lIns="25400" tIns="63500" rIns="63500" bIns="25400" rtlCol="0" anchor="ctr"/>
+          <a:lstStyle/>
+          <a:p>
+            <a:pPr algn="ctr" indent="0" marL="0">
+              <a:buNone/>
+            </a:pPr>
+            <a:r>
+              <a:rPr lang="en-US" sz="1100" b="1" dirty="0">
                 <a:solidFill>
                   <a:srgbClr val="1F2933"/>
                 </a:solidFill>
@@ -2178,26 +2690,40 @@
                 <a:ea typeface="Arial" pitchFamily="34" charset="-122"/>
                 <a:cs typeface="Arial" pitchFamily="34" charset="-120"/>
               </a:rPr>
-              <a:t>HDF5 / Zarr · MP4</a:t>
-            </a:r>
-            <a:endParaRPr lang="en-US" sz="1200" dirty="0"/>
-          </a:p>
-        </p:txBody>
-      </p:sp>
-      <p:sp>
-        <p:nvSpPr>
-          <p:cNvPr id="43" name="Formats B"/>
-          <p:cNvSpPr/>
-          <p:nvPr/>
-        </p:nvSpPr>
-        <p:spPr>
-          <a:xfrm>
-            <a:off x="5029200" y="5298948"/>
-            <a:ext cx="1920240" cy="402336"/>
+              <a:t>HDF5 · Zarr · MP4 </a:t>
+            </a:r>
+            <a:pPr algn="ctr" indent="0" marL="0">
+              <a:buNone/>
+            </a:pPr>
+            <a:r>
+              <a:rPr lang="en-US" sz="950" i="1" dirty="0">
+                <a:solidFill>
+                  <a:srgbClr val="5B6770"/>
+                </a:solidFill>
+                <a:latin typeface="Arial" pitchFamily="34" charset="0"/>
+                <a:ea typeface="Arial" pitchFamily="34" charset="-122"/>
+                <a:cs typeface="Arial" pitchFamily="34" charset="-120"/>
+              </a:rPr>
+              <a:t>(video linked from NWB)</a:t>
+            </a:r>
+            <a:endParaRPr lang="en-US" sz="1000" dirty="0"/>
+          </a:p>
+        </p:txBody>
+      </p:sp>
+      <p:sp>
+        <p:nvSpPr>
+          <p:cNvPr id="54" name="Formats B"/>
+          <p:cNvSpPr/>
+          <p:nvPr/>
+        </p:nvSpPr>
+        <p:spPr>
+          <a:xfrm>
+            <a:off x="5166360" y="6611112"/>
+            <a:ext cx="2926080" cy="274320"/>
           </a:xfrm>
           <a:prstGeom prst="roundRect">
             <a:avLst>
-              <a:gd name="adj" fmla="val 18182"/>
+              <a:gd name="adj" fmla="val 20000"/>
             </a:avLst>
           </a:prstGeom>
           <a:solidFill>
@@ -2213,14 +2739,14 @@
       </p:sp>
       <p:sp>
         <p:nvSpPr>
-          <p:cNvPr id="44" name="Text 42"/>
+          <p:cNvPr id="55" name="Text 53"/>
           <p:cNvSpPr txBox="1"/>
           <p:nvPr/>
         </p:nvSpPr>
         <p:spPr>
           <a:xfrm>
-            <a:off x="5029200" y="5298948"/>
-            <a:ext cx="1920240" cy="402336"/>
+            <a:off x="5166360" y="6611112"/>
+            <a:ext cx="2926080" cy="274320"/>
           </a:xfrm>
           <a:prstGeom prst="rect">
             <a:avLst/>
@@ -2229,14 +2755,14 @@
           <a:ln/>
         </p:spPr>
         <p:txBody>
-          <a:bodyPr wrap="square" lIns="508" tIns="508" rIns="508" bIns="508" rtlCol="0" anchor="ctr"/>
-          <a:lstStyle/>
-          <a:p>
-            <a:pPr algn="ctr" indent="0" marL="0">
-              <a:buNone/>
-            </a:pPr>
-            <a:r>
-              <a:rPr lang="en-US" sz="1200" b="1" dirty="0">
+          <a:bodyPr wrap="square" lIns="25400" tIns="63500" rIns="63500" bIns="25400" rtlCol="0" anchor="ctr"/>
+          <a:lstStyle/>
+          <a:p>
+            <a:pPr algn="ctr" indent="0" marL="0">
+              <a:buNone/>
+            </a:pPr>
+            <a:r>
+              <a:rPr lang="en-US" sz="1050" b="1" dirty="0">
                 <a:solidFill>
                   <a:srgbClr val="1F2933"/>
                 </a:solidFill>
@@ -2244,26 +2770,26 @@
                 <a:ea typeface="Arial" pitchFamily="34" charset="-122"/>
                 <a:cs typeface="Arial" pitchFamily="34" charset="-120"/>
               </a:rPr>
-              <a:t>NIfTI · JSON / TSV</a:t>
-            </a:r>
-            <a:endParaRPr lang="en-US" sz="1200" dirty="0"/>
-          </a:p>
-        </p:txBody>
-      </p:sp>
-      <p:sp>
-        <p:nvSpPr>
-          <p:cNvPr id="45" name="Formats C"/>
-          <p:cNvSpPr/>
-          <p:nvPr/>
-        </p:nvSpPr>
-        <p:spPr>
-          <a:xfrm>
-            <a:off x="7269480" y="5298948"/>
-            <a:ext cx="1920240" cy="402336"/>
+              <a:t>NIfTI · JSON / TSV · EDF · OME-Zarr</a:t>
+            </a:r>
+            <a:endParaRPr lang="en-US" sz="1000" dirty="0"/>
+          </a:p>
+        </p:txBody>
+      </p:sp>
+      <p:sp>
+        <p:nvSpPr>
+          <p:cNvPr id="56" name="Formats B media"/>
+          <p:cNvSpPr/>
+          <p:nvPr/>
+        </p:nvSpPr>
+        <p:spPr>
+          <a:xfrm>
+            <a:off x="5166360" y="6903720"/>
+            <a:ext cx="2926080" cy="256032"/>
           </a:xfrm>
           <a:prstGeom prst="roundRect">
             <a:avLst>
-              <a:gd name="adj" fmla="val 18182"/>
+              <a:gd name="adj" fmla="val 21429"/>
             </a:avLst>
           </a:prstGeom>
           <a:solidFill>
@@ -2273,20 +2799,20 @@
             <a:solidFill>
               <a:srgbClr val="E69F00"/>
             </a:solidFill>
-            <a:prstDash val="solid"/>
-          </a:ln>
-        </p:spPr>
-      </p:sp>
-      <p:sp>
-        <p:nvSpPr>
-          <p:cNvPr id="46" name="Text 44"/>
+            <a:prstDash val="dash"/>
+          </a:ln>
+        </p:spPr>
+      </p:sp>
+      <p:sp>
+        <p:nvSpPr>
+          <p:cNvPr id="57" name="Text 55"/>
           <p:cNvSpPr txBox="1"/>
           <p:nvPr/>
         </p:nvSpPr>
         <p:spPr>
           <a:xfrm>
-            <a:off x="7269480" y="5298948"/>
-            <a:ext cx="1920240" cy="402336"/>
+            <a:off x="5166360" y="6903720"/>
+            <a:ext cx="2926080" cy="256032"/>
           </a:xfrm>
           <a:prstGeom prst="rect">
             <a:avLst/>
@@ -2295,14 +2821,14 @@
           <a:ln/>
         </p:spPr>
         <p:txBody>
-          <a:bodyPr wrap="square" lIns="508" tIns="508" rIns="508" bIns="508" rtlCol="0" anchor="ctr"/>
-          <a:lstStyle/>
-          <a:p>
-            <a:pPr algn="ctr" indent="0" marL="0">
-              <a:buNone/>
-            </a:pPr>
-            <a:r>
-              <a:rPr lang="en-US" sz="1200" b="1" dirty="0">
+          <a:bodyPr wrap="square" lIns="25400" tIns="63500" rIns="63500" bIns="25400" rtlCol="0" anchor="ctr"/>
+          <a:lstStyle/>
+          <a:p>
+            <a:pPr algn="ctr" indent="0" marL="0">
+              <a:buNone/>
+            </a:pPr>
+            <a:r>
+              <a:rPr lang="en-US" sz="950" dirty="0">
                 <a:solidFill>
                   <a:srgbClr val="1F2933"/>
                 </a:solidFill>
@@ -2310,26 +2836,40 @@
                 <a:ea typeface="Arial" pitchFamily="34" charset="-122"/>
                 <a:cs typeface="Arial" pitchFamily="34" charset="-120"/>
               </a:rPr>
-              <a:t>CSV · JSON</a:t>
-            </a:r>
-            <a:endParaRPr lang="en-US" sz="1200" dirty="0"/>
-          </a:p>
-        </p:txBody>
-      </p:sp>
-      <p:sp>
-        <p:nvSpPr>
-          <p:cNvPr id="47" name="NWB"/>
-          <p:cNvSpPr/>
-          <p:nvPr/>
-        </p:nvSpPr>
-        <p:spPr>
-          <a:xfrm>
-            <a:off x="2788920" y="4155948"/>
-            <a:ext cx="1920240" cy="402336"/>
+              <a:t>Audio, video, and image files </a:t>
+            </a:r>
+            <a:pPr algn="ctr" indent="0" marL="0">
+              <a:buNone/>
+            </a:pPr>
+            <a:r>
+              <a:rPr lang="en-US" sz="950" i="1" dirty="0">
+                <a:solidFill>
+                  <a:srgbClr val="5B6770"/>
+                </a:solidFill>
+                <a:latin typeface="Arial" pitchFamily="34" charset="0"/>
+                <a:ea typeface="Arial" pitchFamily="34" charset="-122"/>
+                <a:cs typeface="Arial" pitchFamily="34" charset="-120"/>
+              </a:rPr>
+              <a:t>(BIDS PR #2367)</a:t>
+            </a:r>
+            <a:endParaRPr lang="en-US" sz="1000" dirty="0"/>
+          </a:p>
+        </p:txBody>
+      </p:sp>
+      <p:sp>
+        <p:nvSpPr>
+          <p:cNvPr id="58" name="Formats C"/>
+          <p:cNvSpPr/>
+          <p:nvPr/>
+        </p:nvSpPr>
+        <p:spPr>
+          <a:xfrm>
+            <a:off x="8183880" y="6720840"/>
+            <a:ext cx="1463040" cy="329184"/>
           </a:xfrm>
           <a:prstGeom prst="roundRect">
             <a:avLst>
-              <a:gd name="adj" fmla="val 18182"/>
+              <a:gd name="adj" fmla="val 16667"/>
             </a:avLst>
           </a:prstGeom>
           <a:solidFill>
@@ -2337,7 +2877,7 @@
           </a:solidFill>
           <a:ln w="15875">
             <a:solidFill>
-              <a:srgbClr val="D55E00"/>
+              <a:srgbClr val="E69F00"/>
             </a:solidFill>
             <a:prstDash val="solid"/>
           </a:ln>
@@ -2345,14 +2885,14 @@
       </p:sp>
       <p:sp>
         <p:nvSpPr>
-          <p:cNvPr id="48" name="Text 46"/>
+          <p:cNvPr id="59" name="Text 57"/>
           <p:cNvSpPr txBox="1"/>
           <p:nvPr/>
         </p:nvSpPr>
         <p:spPr>
           <a:xfrm>
-            <a:off x="2788920" y="4155948"/>
-            <a:ext cx="1920240" cy="402336"/>
+            <a:off x="8183880" y="6720840"/>
+            <a:ext cx="1463040" cy="329184"/>
           </a:xfrm>
           <a:prstGeom prst="rect">
             <a:avLst/>
@@ -2361,14 +2901,14 @@
           <a:ln/>
         </p:spPr>
         <p:txBody>
-          <a:bodyPr wrap="square" lIns="508" tIns="508" rIns="508" bIns="508" rtlCol="0" anchor="ctr"/>
-          <a:lstStyle/>
-          <a:p>
-            <a:pPr algn="ctr" indent="0" marL="0">
-              <a:buNone/>
-            </a:pPr>
-            <a:r>
-              <a:rPr lang="en-US" sz="1200" b="1" dirty="0">
+          <a:bodyPr wrap="square" lIns="25400" tIns="63500" rIns="63500" bIns="25400" rtlCol="0" anchor="ctr"/>
+          <a:lstStyle/>
+          <a:p>
+            <a:pPr algn="ctr" indent="0" marL="0">
+              <a:buNone/>
+            </a:pPr>
+            <a:r>
+              <a:rPr lang="en-US" sz="1100" b="1" dirty="0">
                 <a:solidFill>
                   <a:srgbClr val="1F2933"/>
                 </a:solidFill>
@@ -2376,26 +2916,26 @@
                 <a:ea typeface="Arial" pitchFamily="34" charset="-122"/>
                 <a:cs typeface="Arial" pitchFamily="34" charset="-120"/>
               </a:rPr>
-              <a:t>NWB</a:t>
-            </a:r>
-            <a:endParaRPr lang="en-US" sz="1200" dirty="0"/>
-          </a:p>
-        </p:txBody>
-      </p:sp>
-      <p:sp>
-        <p:nvSpPr>
-          <p:cNvPr id="49" name="DANDI layout"/>
-          <p:cNvSpPr/>
-          <p:nvPr/>
-        </p:nvSpPr>
-        <p:spPr>
-          <a:xfrm>
-            <a:off x="2788920" y="3012948"/>
-            <a:ext cx="1920240" cy="402336"/>
+              <a:t>CSV · JSON</a:t>
+            </a:r>
+            <a:endParaRPr lang="en-US" sz="1000" dirty="0"/>
+          </a:p>
+        </p:txBody>
+      </p:sp>
+      <p:sp>
+        <p:nvSpPr>
+          <p:cNvPr id="60" name="NWB core"/>
+          <p:cNvSpPr/>
+          <p:nvPr/>
+        </p:nvSpPr>
+        <p:spPr>
+          <a:xfrm>
+            <a:off x="2148840" y="4690872"/>
+            <a:ext cx="2926080" cy="841248"/>
           </a:xfrm>
           <a:prstGeom prst="roundRect">
             <a:avLst>
-              <a:gd name="adj" fmla="val 18182"/>
+              <a:gd name="adj" fmla="val 6522"/>
             </a:avLst>
           </a:prstGeom>
           <a:solidFill>
@@ -2403,7 +2943,7 @@
           </a:solidFill>
           <a:ln w="15875">
             <a:solidFill>
-              <a:srgbClr val="009E73"/>
+              <a:srgbClr val="D55E00"/>
             </a:solidFill>
             <a:prstDash val="solid"/>
           </a:ln>
@@ -2411,14 +2951,14 @@
       </p:sp>
       <p:sp>
         <p:nvSpPr>
-          <p:cNvPr id="50" name="Text 48"/>
+          <p:cNvPr id="61" name="Text 59"/>
           <p:cNvSpPr txBox="1"/>
           <p:nvPr/>
         </p:nvSpPr>
         <p:spPr>
           <a:xfrm>
-            <a:off x="2788920" y="3012948"/>
-            <a:ext cx="1920240" cy="402336"/>
+            <a:off x="2148840" y="4690872"/>
+            <a:ext cx="2926080" cy="841248"/>
           </a:xfrm>
           <a:prstGeom prst="rect">
             <a:avLst/>
@@ -2427,7 +2967,7 @@
           <a:ln/>
         </p:spPr>
         <p:txBody>
-          <a:bodyPr wrap="square" lIns="508" tIns="508" rIns="508" bIns="508" rtlCol="0" anchor="ctr"/>
+          <a:bodyPr wrap="square" lIns="25400" tIns="63500" rIns="63500" bIns="25400" rtlCol="0" anchor="ctr"/>
           <a:lstStyle/>
           <a:p>
             <a:pPr algn="ctr" indent="0" marL="0">
@@ -2442,26 +2982,60 @@
                 <a:ea typeface="Arial" pitchFamily="34" charset="-122"/>
                 <a:cs typeface="Arial" pitchFamily="34" charset="-120"/>
               </a:rPr>
-              <a:t>DANDI layout</a:t>
-            </a:r>
-            <a:endParaRPr lang="en-US" sz="1200" dirty="0"/>
-          </a:p>
-        </p:txBody>
-      </p:sp>
-      <p:sp>
-        <p:nvSpPr>
-          <p:cNvPr id="51" name="BIDS"/>
-          <p:cNvSpPr/>
-          <p:nvPr/>
-        </p:nvSpPr>
-        <p:spPr>
-          <a:xfrm>
-            <a:off x="5029200" y="3012948"/>
-            <a:ext cx="1920240" cy="402336"/>
+              <a:t>NWB</a:t>
+            </a:r>
+            <a:endParaRPr lang="en-US" sz="1000" dirty="0"/>
+          </a:p>
+          <a:p>
+            <a:pPr algn="ctr" indent="0" marL="0">
+              <a:buNone/>
+            </a:pPr>
+            <a:r>
+              <a:rPr lang="en-US" sz="950" dirty="0">
+                <a:solidFill>
+                  <a:srgbClr val="1F2933"/>
+                </a:solidFill>
+                <a:latin typeface="Arial" pitchFamily="34" charset="0"/>
+                <a:ea typeface="Arial" pitchFamily="34" charset="-122"/>
+                <a:cs typeface="Arial" pitchFamily="34" charset="-120"/>
+              </a:rPr>
+              <a:t>Ephys · ophys · stimulation · behavior · video links · events (EventsTable, MeaningsTable)</a:t>
+            </a:r>
+            <a:endParaRPr lang="en-US" sz="1000" dirty="0"/>
+          </a:p>
+          <a:p>
+            <a:pPr algn="ctr" indent="0" marL="0">
+              <a:buNone/>
+            </a:pPr>
+            <a:r>
+              <a:rPr lang="en-US" sz="950" i="1" dirty="0">
+                <a:solidFill>
+                  <a:srgbClr val="5B6770"/>
+                </a:solidFill>
+                <a:latin typeface="Arial" pitchFamily="34" charset="0"/>
+                <a:ea typeface="Arial" pitchFamily="34" charset="-122"/>
+                <a:cs typeface="Arial" pitchFamily="34" charset="-120"/>
+              </a:rPr>
+              <a:t>Extensions in use: pose · structured behavior · ethogram · wearables · fiber photometry</a:t>
+            </a:r>
+            <a:endParaRPr lang="en-US" sz="1000" dirty="0"/>
+          </a:p>
+        </p:txBody>
+      </p:sp>
+      <p:sp>
+        <p:nvSpPr>
+          <p:cNvPr id="62" name="NWB WIP ndx-pose → core"/>
+          <p:cNvSpPr/>
+          <p:nvPr/>
+        </p:nvSpPr>
+        <p:spPr>
+          <a:xfrm>
+            <a:off x="2148840" y="5605272"/>
+            <a:ext cx="1417320" cy="347472"/>
           </a:xfrm>
           <a:prstGeom prst="roundRect">
             <a:avLst>
-              <a:gd name="adj" fmla="val 18182"/>
+              <a:gd name="adj" fmla="val 15789"/>
             </a:avLst>
           </a:prstGeom>
           <a:solidFill>
@@ -2469,22 +3043,22 @@
           </a:solidFill>
           <a:ln w="15875">
             <a:solidFill>
-              <a:srgbClr val="009E73"/>
-            </a:solidFill>
-            <a:prstDash val="solid"/>
-          </a:ln>
-        </p:spPr>
-      </p:sp>
-      <p:sp>
-        <p:nvSpPr>
-          <p:cNvPr id="52" name="Text 50"/>
+              <a:srgbClr val="D55E00"/>
+            </a:solidFill>
+            <a:prstDash val="dash"/>
+          </a:ln>
+        </p:spPr>
+      </p:sp>
+      <p:sp>
+        <p:nvSpPr>
+          <p:cNvPr id="63" name="Text 61"/>
           <p:cNvSpPr txBox="1"/>
           <p:nvPr/>
         </p:nvSpPr>
         <p:spPr>
           <a:xfrm>
-            <a:off x="5029200" y="3012948"/>
-            <a:ext cx="1920240" cy="402336"/>
+            <a:off x="2148840" y="5605272"/>
+            <a:ext cx="1417320" cy="347472"/>
           </a:xfrm>
           <a:prstGeom prst="rect">
             <a:avLst/>
@@ -2493,14 +3067,14 @@
           <a:ln/>
         </p:spPr>
         <p:txBody>
-          <a:bodyPr wrap="square" lIns="508" tIns="508" rIns="508" bIns="508" rtlCol="0" anchor="ctr"/>
-          <a:lstStyle/>
-          <a:p>
-            <a:pPr algn="ctr" indent="0" marL="0">
-              <a:buNone/>
-            </a:pPr>
-            <a:r>
-              <a:rPr lang="en-US" sz="1200" b="1" dirty="0">
+          <a:bodyPr wrap="square" lIns="25400" tIns="63500" rIns="63500" bIns="25400" rtlCol="0" anchor="ctr"/>
+          <a:lstStyle/>
+          <a:p>
+            <a:pPr algn="ctr" indent="0" marL="0">
+              <a:buNone/>
+            </a:pPr>
+            <a:r>
+              <a:rPr lang="en-US" sz="1000" b="1" dirty="0">
                 <a:solidFill>
                   <a:srgbClr val="1F2933"/>
                 </a:solidFill>
@@ -2508,26 +3082,43 @@
                 <a:ea typeface="Arial" pitchFamily="34" charset="-122"/>
                 <a:cs typeface="Arial" pitchFamily="34" charset="-120"/>
               </a:rPr>
-              <a:t>BIDS</a:t>
-            </a:r>
-            <a:endParaRPr lang="en-US" sz="1200" dirty="0"/>
-          </a:p>
-        </p:txBody>
-      </p:sp>
-      <p:sp>
-        <p:nvSpPr>
-          <p:cNvPr id="53" name="Psych-DS"/>
-          <p:cNvSpPr/>
-          <p:nvPr/>
-        </p:nvSpPr>
-        <p:spPr>
-          <a:xfrm>
-            <a:off x="7269480" y="3012948"/>
-            <a:ext cx="1920240" cy="402336"/>
+              <a:t>ndx-pose → core</a:t>
+            </a:r>
+            <a:endParaRPr lang="en-US" sz="1000" dirty="0"/>
+          </a:p>
+          <a:p>
+            <a:pPr algn="ctr" indent="0" marL="0">
+              <a:buNone/>
+            </a:pPr>
+            <a:r>
+              <a:rPr lang="en-US" sz="900" i="1" dirty="0">
+                <a:solidFill>
+                  <a:srgbClr val="5B6770"/>
+                </a:solidFill>
+                <a:latin typeface="Arial" pitchFamily="34" charset="0"/>
+                <a:ea typeface="Arial" pitchFamily="34" charset="-122"/>
+                <a:cs typeface="Arial" pitchFamily="34" charset="-120"/>
+              </a:rPr>
+              <a:t>NWBEP in preparation</a:t>
+            </a:r>
+            <a:endParaRPr lang="en-US" sz="1000" dirty="0"/>
+          </a:p>
+        </p:txBody>
+      </p:sp>
+      <p:sp>
+        <p:nvSpPr>
+          <p:cNvPr id="64" name="NWB WIP ndx-hed → core"/>
+          <p:cNvSpPr/>
+          <p:nvPr/>
+        </p:nvSpPr>
+        <p:spPr>
+          <a:xfrm>
+            <a:off x="3657600" y="5605272"/>
+            <a:ext cx="1417320" cy="347472"/>
           </a:xfrm>
           <a:prstGeom prst="roundRect">
             <a:avLst>
-              <a:gd name="adj" fmla="val 18182"/>
+              <a:gd name="adj" fmla="val 15789"/>
             </a:avLst>
           </a:prstGeom>
           <a:solidFill>
@@ -2535,22 +3126,22 @@
           </a:solidFill>
           <a:ln w="15875">
             <a:solidFill>
-              <a:srgbClr val="009E73"/>
-            </a:solidFill>
-            <a:prstDash val="solid"/>
-          </a:ln>
-        </p:spPr>
-      </p:sp>
-      <p:sp>
-        <p:nvSpPr>
-          <p:cNvPr id="54" name="Text 52"/>
+              <a:srgbClr val="D55E00"/>
+            </a:solidFill>
+            <a:prstDash val="dash"/>
+          </a:ln>
+        </p:spPr>
+      </p:sp>
+      <p:sp>
+        <p:nvSpPr>
+          <p:cNvPr id="65" name="Text 63"/>
           <p:cNvSpPr txBox="1"/>
           <p:nvPr/>
         </p:nvSpPr>
         <p:spPr>
           <a:xfrm>
-            <a:off x="7269480" y="3012948"/>
-            <a:ext cx="1920240" cy="402336"/>
+            <a:off x="3657600" y="5605272"/>
+            <a:ext cx="1417320" cy="347472"/>
           </a:xfrm>
           <a:prstGeom prst="rect">
             <a:avLst/>
@@ -2559,14 +3150,14 @@
           <a:ln/>
         </p:spPr>
         <p:txBody>
-          <a:bodyPr wrap="square" lIns="508" tIns="508" rIns="508" bIns="508" rtlCol="0" anchor="ctr"/>
-          <a:lstStyle/>
-          <a:p>
-            <a:pPr algn="ctr" indent="0" marL="0">
-              <a:buNone/>
-            </a:pPr>
-            <a:r>
-              <a:rPr lang="en-US" sz="1200" b="1" dirty="0">
+          <a:bodyPr wrap="square" lIns="25400" tIns="63500" rIns="63500" bIns="25400" rtlCol="0" anchor="ctr"/>
+          <a:lstStyle/>
+          <a:p>
+            <a:pPr algn="ctr" indent="0" marL="0">
+              <a:buNone/>
+            </a:pPr>
+            <a:r>
+              <a:rPr lang="en-US" sz="1000" b="1" dirty="0">
                 <a:solidFill>
                   <a:srgbClr val="1F2933"/>
                 </a:solidFill>
@@ -2574,26 +3165,43 @@
                 <a:ea typeface="Arial" pitchFamily="34" charset="-122"/>
                 <a:cs typeface="Arial" pitchFamily="34" charset="-120"/>
               </a:rPr>
-              <a:t>Psych-DS</a:t>
-            </a:r>
-            <a:endParaRPr lang="en-US" sz="1200" dirty="0"/>
-          </a:p>
-        </p:txBody>
-      </p:sp>
-      <p:sp>
-        <p:nvSpPr>
-          <p:cNvPr id="55" name="Terminologies"/>
-          <p:cNvSpPr/>
-          <p:nvPr/>
-        </p:nvSpPr>
-        <p:spPr>
-          <a:xfrm>
-            <a:off x="2788920" y="1687068"/>
-            <a:ext cx="4160520" cy="347472"/>
+              <a:t>ndx-hed → core</a:t>
+            </a:r>
+            <a:endParaRPr lang="en-US" sz="1000" dirty="0"/>
+          </a:p>
+          <a:p>
+            <a:pPr algn="ctr" indent="0" marL="0">
+              <a:buNone/>
+            </a:pPr>
+            <a:r>
+              <a:rPr lang="en-US" sz="900" i="1" dirty="0">
+                <a:solidFill>
+                  <a:srgbClr val="5B6770"/>
+                </a:solidFill>
+                <a:latin typeface="Arial" pitchFamily="34" charset="0"/>
+                <a:ea typeface="Arial" pitchFamily="34" charset="-122"/>
+                <a:cs typeface="Arial" pitchFamily="34" charset="-120"/>
+              </a:rPr>
+              <a:t>approved</a:t>
+            </a:r>
+            <a:endParaRPr lang="en-US" sz="1000" dirty="0"/>
+          </a:p>
+        </p:txBody>
+      </p:sp>
+      <p:sp>
+        <p:nvSpPr>
+          <p:cNvPr id="66" name="NWB WIP ndx-multisubjects"/>
+          <p:cNvSpPr/>
+          <p:nvPr/>
+        </p:nvSpPr>
+        <p:spPr>
+          <a:xfrm>
+            <a:off x="2148840" y="6007608"/>
+            <a:ext cx="1417320" cy="347472"/>
           </a:xfrm>
           <a:prstGeom prst="roundRect">
             <a:avLst>
-              <a:gd name="adj" fmla="val 21053"/>
+              <a:gd name="adj" fmla="val 15789"/>
             </a:avLst>
           </a:prstGeom>
           <a:solidFill>
@@ -2601,22 +3209,22 @@
           </a:solidFill>
           <a:ln w="15875">
             <a:solidFill>
-              <a:srgbClr val="CC79A7"/>
-            </a:solidFill>
-            <a:prstDash val="solid"/>
-          </a:ln>
-        </p:spPr>
-      </p:sp>
-      <p:sp>
-        <p:nvSpPr>
-          <p:cNvPr id="56" name="Text 54"/>
+              <a:srgbClr val="D55E00"/>
+            </a:solidFill>
+            <a:prstDash val="dash"/>
+          </a:ln>
+        </p:spPr>
+      </p:sp>
+      <p:sp>
+        <p:nvSpPr>
+          <p:cNvPr id="67" name="Text 65"/>
           <p:cNvSpPr txBox="1"/>
           <p:nvPr/>
         </p:nvSpPr>
         <p:spPr>
           <a:xfrm>
-            <a:off x="2788920" y="1687068"/>
-            <a:ext cx="4160520" cy="347472"/>
+            <a:off x="2148840" y="6007608"/>
+            <a:ext cx="1417320" cy="347472"/>
           </a:xfrm>
           <a:prstGeom prst="rect">
             <a:avLst/>
@@ -2625,14 +3233,14 @@
           <a:ln/>
         </p:spPr>
         <p:txBody>
-          <a:bodyPr wrap="square" lIns="508" tIns="508" rIns="508" bIns="508" rtlCol="0" anchor="ctr"/>
-          <a:lstStyle/>
-          <a:p>
-            <a:pPr algn="ctr" indent="0" marL="0">
-              <a:buNone/>
-            </a:pPr>
-            <a:r>
-              <a:rPr lang="en-US" sz="1200" b="1" dirty="0">
+          <a:bodyPr wrap="square" lIns="25400" tIns="63500" rIns="63500" bIns="25400" rtlCol="0" anchor="ctr"/>
+          <a:lstStyle/>
+          <a:p>
+            <a:pPr algn="ctr" indent="0" marL="0">
+              <a:buNone/>
+            </a:pPr>
+            <a:r>
+              <a:rPr lang="en-US" sz="1000" b="1" dirty="0">
                 <a:solidFill>
                   <a:srgbClr val="1F2933"/>
                 </a:solidFill>
@@ -2640,26 +3248,43 @@
                 <a:ea typeface="Arial" pitchFamily="34" charset="-122"/>
                 <a:cs typeface="Arial" pitchFamily="34" charset="-120"/>
               </a:rPr>
-              <a:t>NCBI Taxonomy · brain atlases · Cell Ontology</a:t>
-            </a:r>
-            <a:endParaRPr lang="en-US" sz="1200" dirty="0"/>
-          </a:p>
-        </p:txBody>
-      </p:sp>
-      <p:sp>
-        <p:nvSpPr>
-          <p:cNvPr id="57" name="HED"/>
-          <p:cNvSpPr/>
-          <p:nvPr/>
-        </p:nvSpPr>
-        <p:spPr>
-          <a:xfrm>
-            <a:off x="2788920" y="2107692"/>
-            <a:ext cx="4160520" cy="347472"/>
+              <a:t>ndx-multisubjects</a:t>
+            </a:r>
+            <a:endParaRPr lang="en-US" sz="1000" dirty="0"/>
+          </a:p>
+          <a:p>
+            <a:pPr algn="ctr" indent="0" marL="0">
+              <a:buNone/>
+            </a:pPr>
+            <a:r>
+              <a:rPr lang="en-US" sz="900" i="1" dirty="0">
+                <a:solidFill>
+                  <a:srgbClr val="5B6770"/>
+                </a:solidFill>
+                <a:latin typeface="Arial" pitchFamily="34" charset="0"/>
+                <a:ea typeface="Arial" pitchFamily="34" charset="-122"/>
+                <a:cs typeface="Arial" pitchFamily="34" charset="-120"/>
+              </a:rPr>
+              <a:t>NWBEP in preparation</a:t>
+            </a:r>
+            <a:endParaRPr lang="en-US" sz="1000" dirty="0"/>
+          </a:p>
+        </p:txBody>
+      </p:sp>
+      <p:sp>
+        <p:nvSpPr>
+          <p:cNvPr id="68" name="NWB WIP NWBEP004"/>
+          <p:cNvSpPr/>
+          <p:nvPr/>
+        </p:nvSpPr>
+        <p:spPr>
+          <a:xfrm>
+            <a:off x="3657600" y="6007608"/>
+            <a:ext cx="1417320" cy="347472"/>
           </a:xfrm>
           <a:prstGeom prst="roundRect">
             <a:avLst>
-              <a:gd name="adj" fmla="val 21053"/>
+              <a:gd name="adj" fmla="val 15789"/>
             </a:avLst>
           </a:prstGeom>
           <a:solidFill>
@@ -2667,22 +3292,22 @@
           </a:solidFill>
           <a:ln w="15875">
             <a:solidFill>
-              <a:srgbClr val="CC79A7"/>
-            </a:solidFill>
-            <a:prstDash val="solid"/>
-          </a:ln>
-        </p:spPr>
-      </p:sp>
-      <p:sp>
-        <p:nvSpPr>
-          <p:cNvPr id="58" name="Text 56"/>
+              <a:srgbClr val="D55E00"/>
+            </a:solidFill>
+            <a:prstDash val="dash"/>
+          </a:ln>
+        </p:spPr>
+      </p:sp>
+      <p:sp>
+        <p:nvSpPr>
+          <p:cNvPr id="69" name="Text 67"/>
           <p:cNvSpPr txBox="1"/>
           <p:nvPr/>
         </p:nvSpPr>
         <p:spPr>
           <a:xfrm>
-            <a:off x="2788920" y="2107692"/>
-            <a:ext cx="4160520" cy="347472"/>
+            <a:off x="3657600" y="6007608"/>
+            <a:ext cx="1417320" cy="347472"/>
           </a:xfrm>
           <a:prstGeom prst="rect">
             <a:avLst/>
@@ -2691,14 +3316,14 @@
           <a:ln/>
         </p:spPr>
         <p:txBody>
-          <a:bodyPr wrap="square" lIns="508" tIns="508" rIns="508" bIns="508" rtlCol="0" anchor="ctr"/>
-          <a:lstStyle/>
-          <a:p>
-            <a:pPr algn="ctr" indent="0" marL="0">
-              <a:buNone/>
-            </a:pPr>
-            <a:r>
-              <a:rPr lang="en-US" sz="1200" b="1" dirty="0">
+          <a:bodyPr wrap="square" lIns="25400" tIns="63500" rIns="63500" bIns="25400" rtlCol="0" anchor="ctr"/>
+          <a:lstStyle/>
+          <a:p>
+            <a:pPr algn="ctr" indent="0" marL="0">
+              <a:buNone/>
+            </a:pPr>
+            <a:r>
+              <a:rPr lang="en-US" sz="1000" b="1" dirty="0">
                 <a:solidFill>
                   <a:srgbClr val="1F2933"/>
                 </a:solidFill>
@@ -2706,13 +3331,16 @@
                 <a:ea typeface="Arial" pitchFamily="34" charset="-122"/>
                 <a:cs typeface="Arial" pitchFamily="34" charset="-120"/>
               </a:rPr>
-              <a:t>HED </a:t>
-            </a:r>
-            <a:pPr algn="ctr" indent="0" marL="0">
-              <a:buNone/>
-            </a:pPr>
-            <a:r>
-              <a:rPr lang="en-US" sz="1050" b="1" i="1" dirty="0">
+              <a:t>NWBEP004</a:t>
+            </a:r>
+            <a:endParaRPr lang="en-US" sz="1000" dirty="0"/>
+          </a:p>
+          <a:p>
+            <a:pPr algn="ctr" indent="0" marL="0">
+              <a:buNone/>
+            </a:pPr>
+            <a:r>
+              <a:rPr lang="en-US" sz="900" i="1" dirty="0">
                 <a:solidFill>
                   <a:srgbClr val="5B6770"/>
                 </a:solidFill>
@@ -2720,26 +3348,65 @@
                 <a:ea typeface="Arial" pitchFamily="34" charset="-122"/>
                 <a:cs typeface="Arial" pitchFamily="34" charset="-120"/>
               </a:rPr>
-              <a:t>event annotations in BIDS and NWB</a:t>
-            </a:r>
-            <a:endParaRPr lang="en-US" sz="1200" dirty="0"/>
-          </a:p>
-        </p:txBody>
-      </p:sp>
-      <p:sp>
-        <p:nvSpPr>
-          <p:cNvPr id="59" name="EMBER"/>
-          <p:cNvSpPr/>
-          <p:nvPr/>
-        </p:nvSpPr>
-        <p:spPr>
-          <a:xfrm>
-            <a:off x="2788920" y="690372"/>
-            <a:ext cx="6400800" cy="475488"/>
+              <a:t>microscopy · approved</a:t>
+            </a:r>
+            <a:endParaRPr lang="en-US" sz="1000" dirty="0"/>
+          </a:p>
+        </p:txBody>
+      </p:sp>
+      <p:sp>
+        <p:nvSpPr>
+          <p:cNvPr id="70" name="Text 68"/>
+          <p:cNvSpPr txBox="1"/>
+          <p:nvPr/>
+        </p:nvSpPr>
+        <p:spPr>
+          <a:xfrm>
+            <a:off x="6766560" y="5239512"/>
+            <a:ext cx="1234440" cy="640080"/>
+          </a:xfrm>
+          <a:prstGeom prst="rect">
+            <a:avLst/>
+          </a:prstGeom>
+          <a:noFill/>
+          <a:ln/>
+        </p:spPr>
+        <p:txBody>
+          <a:bodyPr wrap="square" lIns="0" tIns="0" rIns="0" bIns="0" rtlCol="0" anchor="ctr"/>
+          <a:lstStyle/>
+          <a:p>
+            <a:pPr algn="l" indent="0" marL="0">
+              <a:buNone/>
+            </a:pPr>
+            <a:r>
+              <a:rPr lang="en-US" sz="950" i="1" dirty="0">
+                <a:solidFill>
+                  <a:srgbClr val="5B6770"/>
+                </a:solidFill>
+                <a:latin typeface="Arial" pitchFamily="34" charset="0"/>
+                <a:ea typeface="Arial" pitchFamily="34" charset="-122"/>
+                <a:cs typeface="Arial" pitchFamily="34" charset="-120"/>
+              </a:rPr>
+              <a:t>BIDS can include NWB files (iEEG; microelectrode ephys via BEP032)</a:t>
+            </a:r>
+            <a:endParaRPr lang="en-US" sz="950" dirty="0"/>
+          </a:p>
+        </p:txBody>
+      </p:sp>
+      <p:sp>
+        <p:nvSpPr>
+          <p:cNvPr id="71" name="DANDI layout"/>
+          <p:cNvSpPr/>
+          <p:nvPr/>
+        </p:nvSpPr>
+        <p:spPr>
+          <a:xfrm>
+            <a:off x="2148840" y="2843784"/>
+            <a:ext cx="2926080" cy="457200"/>
           </a:xfrm>
           <a:prstGeom prst="roundRect">
             <a:avLst>
-              <a:gd name="adj" fmla="val 15385"/>
+              <a:gd name="adj" fmla="val 12000"/>
             </a:avLst>
           </a:prstGeom>
           <a:solidFill>
@@ -2747,7 +3414,7 @@
           </a:solidFill>
           <a:ln w="15875">
             <a:solidFill>
-              <a:srgbClr val="0072B2"/>
+              <a:srgbClr val="009E73"/>
             </a:solidFill>
             <a:prstDash val="solid"/>
           </a:ln>
@@ -2755,14 +3422,14 @@
       </p:sp>
       <p:sp>
         <p:nvSpPr>
-          <p:cNvPr id="60" name="Text 58"/>
+          <p:cNvPr id="72" name="Text 70"/>
           <p:cNvSpPr txBox="1"/>
           <p:nvPr/>
         </p:nvSpPr>
         <p:spPr>
           <a:xfrm>
-            <a:off x="2788920" y="690372"/>
-            <a:ext cx="6400800" cy="475488"/>
+            <a:off x="2148840" y="2843784"/>
+            <a:ext cx="2926080" cy="457200"/>
           </a:xfrm>
           <a:prstGeom prst="rect">
             <a:avLst/>
@@ -2771,14 +3438,14 @@
           <a:ln/>
         </p:spPr>
         <p:txBody>
-          <a:bodyPr wrap="square" lIns="508" tIns="508" rIns="508" bIns="508" rtlCol="0" anchor="ctr"/>
-          <a:lstStyle/>
-          <a:p>
-            <a:pPr algn="ctr" indent="0" marL="0">
-              <a:buNone/>
-            </a:pPr>
-            <a:r>
-              <a:rPr lang="en-US" sz="1200" b="1" dirty="0">
+          <a:bodyPr wrap="square" lIns="25400" tIns="63500" rIns="63500" bIns="25400" rtlCol="0" anchor="ctr"/>
+          <a:lstStyle/>
+          <a:p>
+            <a:pPr algn="ctr" indent="0" marL="0">
+              <a:buNone/>
+            </a:pPr>
+            <a:r>
+              <a:rPr lang="en-US" sz="1100" b="1" dirty="0">
                 <a:solidFill>
                   <a:srgbClr val="1F2933"/>
                 </a:solidFill>
@@ -2786,13 +3453,16 @@
                 <a:ea typeface="Arial" pitchFamily="34" charset="-122"/>
                 <a:cs typeface="Arial" pitchFamily="34" charset="-120"/>
               </a:rPr>
-              <a:t>EMBER   </a:t>
-            </a:r>
-            <a:pPr algn="ctr" indent="0" marL="0">
-              <a:buNone/>
-            </a:pPr>
-            <a:r>
-              <a:rPr lang="en-US" sz="1050" b="1" i="1" dirty="0">
+              <a:t>DANDI layout</a:t>
+            </a:r>
+            <a:endParaRPr lang="en-US" sz="1000" dirty="0"/>
+          </a:p>
+          <a:p>
+            <a:pPr algn="ctr" indent="0" marL="0">
+              <a:buNone/>
+            </a:pPr>
+            <a:r>
+              <a:rPr lang="en-US" sz="950" i="1" dirty="0">
                 <a:solidFill>
                   <a:srgbClr val="5B6770"/>
                 </a:solidFill>
@@ -2800,26 +3470,26 @@
                 <a:ea typeface="Arial" pitchFamily="34" charset="-122"/>
                 <a:cs typeface="Arial" pitchFamily="34" charset="-120"/>
               </a:rPr>
-              <a:t>accepts NWB, DANDI-layout, BIDS, and Psych-DS datasets</a:t>
-            </a:r>
-            <a:endParaRPr lang="en-US" sz="1200" dirty="0"/>
-          </a:p>
-        </p:txBody>
-      </p:sp>
-      <p:sp>
-        <p:nvSpPr>
-          <p:cNvPr id="61" name="Schema languages"/>
-          <p:cNvSpPr/>
-          <p:nvPr/>
-        </p:nvSpPr>
-        <p:spPr>
-          <a:xfrm>
-            <a:off x="9555480" y="3063240"/>
-            <a:ext cx="2212848" cy="1371600"/>
+              <a:t>one NWB file per subject and session</a:t>
+            </a:r>
+            <a:endParaRPr lang="en-US" sz="1000" dirty="0"/>
+          </a:p>
+        </p:txBody>
+      </p:sp>
+      <p:sp>
+        <p:nvSpPr>
+          <p:cNvPr id="73" name="BIDS"/>
+          <p:cNvSpPr/>
+          <p:nvPr/>
+        </p:nvSpPr>
+        <p:spPr>
+          <a:xfrm>
+            <a:off x="5166360" y="2843784"/>
+            <a:ext cx="2926080" cy="713232"/>
           </a:xfrm>
           <a:prstGeom prst="roundRect">
             <a:avLst>
-              <a:gd name="adj" fmla="val 5333"/>
+              <a:gd name="adj" fmla="val 7692"/>
             </a:avLst>
           </a:prstGeom>
           <a:solidFill>
@@ -2827,6 +3497,587 @@
           </a:solidFill>
           <a:ln w="15875">
             <a:solidFill>
+              <a:srgbClr val="009E73"/>
+            </a:solidFill>
+            <a:prstDash val="solid"/>
+          </a:ln>
+        </p:spPr>
+      </p:sp>
+      <p:sp>
+        <p:nvSpPr>
+          <p:cNvPr id="74" name="Text 72"/>
+          <p:cNvSpPr txBox="1"/>
+          <p:nvPr/>
+        </p:nvSpPr>
+        <p:spPr>
+          <a:xfrm>
+            <a:off x="5166360" y="2843784"/>
+            <a:ext cx="2926080" cy="713232"/>
+          </a:xfrm>
+          <a:prstGeom prst="rect">
+            <a:avLst/>
+          </a:prstGeom>
+          <a:noFill/>
+          <a:ln/>
+        </p:spPr>
+        <p:txBody>
+          <a:bodyPr wrap="square" lIns="25400" tIns="63500" rIns="63500" bIns="25400" rtlCol="0" anchor="ctr"/>
+          <a:lstStyle/>
+          <a:p>
+            <a:pPr algn="ctr" indent="0" marL="0">
+              <a:buNone/>
+            </a:pPr>
+            <a:r>
+              <a:rPr lang="en-US" sz="1200" b="1" dirty="0">
+                <a:solidFill>
+                  <a:srgbClr val="1F2933"/>
+                </a:solidFill>
+                <a:latin typeface="Arial" pitchFamily="34" charset="0"/>
+                <a:ea typeface="Arial" pitchFamily="34" charset="-122"/>
+                <a:cs typeface="Arial" pitchFamily="34" charset="-120"/>
+              </a:rPr>
+              <a:t>BIDS</a:t>
+            </a:r>
+            <a:endParaRPr lang="en-US" sz="1000" dirty="0"/>
+          </a:p>
+          <a:p>
+            <a:pPr algn="ctr" indent="0" marL="0">
+              <a:buNone/>
+            </a:pPr>
+            <a:r>
+              <a:rPr lang="en-US" sz="950" dirty="0">
+                <a:solidFill>
+                  <a:srgbClr val="1F2933"/>
+                </a:solidFill>
+                <a:latin typeface="Arial" pitchFamily="34" charset="0"/>
+                <a:ea typeface="Arial" pitchFamily="34" charset="-122"/>
+                <a:cs typeface="Arial" pitchFamily="34" charset="-120"/>
+              </a:rPr>
+              <a:t>MRI · PET · EEG / MEG / iEEG · microscopy · motion · physiology · behavior and task events · stimuli · rawbids/</a:t>
+            </a:r>
+            <a:endParaRPr lang="en-US" sz="1000" dirty="0"/>
+          </a:p>
+        </p:txBody>
+      </p:sp>
+      <p:sp>
+        <p:nvSpPr>
+          <p:cNvPr id="75" name="BIDS WIP BEP032"/>
+          <p:cNvSpPr/>
+          <p:nvPr/>
+        </p:nvSpPr>
+        <p:spPr>
+          <a:xfrm>
+            <a:off x="5166360" y="3630168"/>
+            <a:ext cx="1417320" cy="347472"/>
+          </a:xfrm>
+          <a:prstGeom prst="roundRect">
+            <a:avLst>
+              <a:gd name="adj" fmla="val 15789"/>
+            </a:avLst>
+          </a:prstGeom>
+          <a:solidFill>
+            <a:srgbClr val="FFFFFF"/>
+          </a:solidFill>
+          <a:ln w="15875">
+            <a:solidFill>
+              <a:srgbClr val="009E73"/>
+            </a:solidFill>
+            <a:prstDash val="dash"/>
+          </a:ln>
+        </p:spPr>
+      </p:sp>
+      <p:sp>
+        <p:nvSpPr>
+          <p:cNvPr id="76" name="Text 74"/>
+          <p:cNvSpPr txBox="1"/>
+          <p:nvPr/>
+        </p:nvSpPr>
+        <p:spPr>
+          <a:xfrm>
+            <a:off x="5166360" y="3630168"/>
+            <a:ext cx="1417320" cy="347472"/>
+          </a:xfrm>
+          <a:prstGeom prst="rect">
+            <a:avLst/>
+          </a:prstGeom>
+          <a:noFill/>
+          <a:ln/>
+        </p:spPr>
+        <p:txBody>
+          <a:bodyPr wrap="square" lIns="25400" tIns="63500" rIns="63500" bIns="25400" rtlCol="0" anchor="ctr"/>
+          <a:lstStyle/>
+          <a:p>
+            <a:pPr algn="ctr" indent="0" marL="0">
+              <a:buNone/>
+            </a:pPr>
+            <a:r>
+              <a:rPr lang="en-US" sz="1000" b="1" dirty="0">
+                <a:solidFill>
+                  <a:srgbClr val="1F2933"/>
+                </a:solidFill>
+                <a:latin typeface="Arial" pitchFamily="34" charset="0"/>
+                <a:ea typeface="Arial" pitchFamily="34" charset="-122"/>
+                <a:cs typeface="Arial" pitchFamily="34" charset="-120"/>
+              </a:rPr>
+              <a:t>BEP032</a:t>
+            </a:r>
+            <a:endParaRPr lang="en-US" sz="1000" dirty="0"/>
+          </a:p>
+          <a:p>
+            <a:pPr algn="ctr" indent="0" marL="0">
+              <a:buNone/>
+            </a:pPr>
+            <a:r>
+              <a:rPr lang="en-US" sz="900" i="1" dirty="0">
+                <a:solidFill>
+                  <a:srgbClr val="5B6770"/>
+                </a:solidFill>
+                <a:latin typeface="Arial" pitchFamily="34" charset="0"/>
+                <a:ea typeface="Arial" pitchFamily="34" charset="-122"/>
+                <a:cs typeface="Arial" pitchFamily="34" charset="-120"/>
+              </a:rPr>
+              <a:t>microelectrode ephys</a:t>
+            </a:r>
+            <a:endParaRPr lang="en-US" sz="1000" dirty="0"/>
+          </a:p>
+        </p:txBody>
+      </p:sp>
+      <p:sp>
+        <p:nvSpPr>
+          <p:cNvPr id="77" name="BIDS WIP BEP047"/>
+          <p:cNvSpPr/>
+          <p:nvPr/>
+        </p:nvSpPr>
+        <p:spPr>
+          <a:xfrm>
+            <a:off x="6675120" y="3630168"/>
+            <a:ext cx="1417320" cy="347472"/>
+          </a:xfrm>
+          <a:prstGeom prst="roundRect">
+            <a:avLst>
+              <a:gd name="adj" fmla="val 15789"/>
+            </a:avLst>
+          </a:prstGeom>
+          <a:solidFill>
+            <a:srgbClr val="FFFFFF"/>
+          </a:solidFill>
+          <a:ln w="15875">
+            <a:solidFill>
+              <a:srgbClr val="009E73"/>
+            </a:solidFill>
+            <a:prstDash val="dash"/>
+          </a:ln>
+        </p:spPr>
+      </p:sp>
+      <p:sp>
+        <p:nvSpPr>
+          <p:cNvPr id="78" name="Text 76"/>
+          <p:cNvSpPr txBox="1"/>
+          <p:nvPr/>
+        </p:nvSpPr>
+        <p:spPr>
+          <a:xfrm>
+            <a:off x="6675120" y="3630168"/>
+            <a:ext cx="1417320" cy="347472"/>
+          </a:xfrm>
+          <a:prstGeom prst="rect">
+            <a:avLst/>
+          </a:prstGeom>
+          <a:noFill/>
+          <a:ln/>
+        </p:spPr>
+        <p:txBody>
+          <a:bodyPr wrap="square" lIns="25400" tIns="63500" rIns="63500" bIns="25400" rtlCol="0" anchor="ctr"/>
+          <a:lstStyle/>
+          <a:p>
+            <a:pPr algn="ctr" indent="0" marL="0">
+              <a:buNone/>
+            </a:pPr>
+            <a:r>
+              <a:rPr lang="en-US" sz="1000" b="1" dirty="0">
+                <a:solidFill>
+                  <a:srgbClr val="1F2933"/>
+                </a:solidFill>
+                <a:latin typeface="Arial" pitchFamily="34" charset="0"/>
+                <a:ea typeface="Arial" pitchFamily="34" charset="-122"/>
+                <a:cs typeface="Arial" pitchFamily="34" charset="-120"/>
+              </a:rPr>
+              <a:t>BEP047</a:t>
+            </a:r>
+            <a:endParaRPr lang="en-US" sz="1000" dirty="0"/>
+          </a:p>
+          <a:p>
+            <a:pPr algn="ctr" indent="0" marL="0">
+              <a:buNone/>
+            </a:pPr>
+            <a:r>
+              <a:rPr lang="en-US" sz="900" i="1" dirty="0">
+                <a:solidFill>
+                  <a:srgbClr val="5B6770"/>
+                </a:solidFill>
+                <a:latin typeface="Arial" pitchFamily="34" charset="0"/>
+                <a:ea typeface="Arial" pitchFamily="34" charset="-122"/>
+                <a:cs typeface="Arial" pitchFamily="34" charset="-120"/>
+              </a:rPr>
+              <a:t>behavioral audio / video</a:t>
+            </a:r>
+            <a:endParaRPr lang="en-US" sz="1000" dirty="0"/>
+          </a:p>
+        </p:txBody>
+      </p:sp>
+      <p:sp>
+        <p:nvSpPr>
+          <p:cNvPr id="79" name="BIDS WIP BEP020 · BEP042"/>
+          <p:cNvSpPr/>
+          <p:nvPr/>
+        </p:nvSpPr>
+        <p:spPr>
+          <a:xfrm>
+            <a:off x="5166360" y="4032504"/>
+            <a:ext cx="1417320" cy="347472"/>
+          </a:xfrm>
+          <a:prstGeom prst="roundRect">
+            <a:avLst>
+              <a:gd name="adj" fmla="val 15789"/>
+            </a:avLst>
+          </a:prstGeom>
+          <a:solidFill>
+            <a:srgbClr val="FFFFFF"/>
+          </a:solidFill>
+          <a:ln w="15875">
+            <a:solidFill>
+              <a:srgbClr val="009E73"/>
+            </a:solidFill>
+            <a:prstDash val="dash"/>
+          </a:ln>
+        </p:spPr>
+      </p:sp>
+      <p:sp>
+        <p:nvSpPr>
+          <p:cNvPr id="80" name="Text 78"/>
+          <p:cNvSpPr txBox="1"/>
+          <p:nvPr/>
+        </p:nvSpPr>
+        <p:spPr>
+          <a:xfrm>
+            <a:off x="5166360" y="4032504"/>
+            <a:ext cx="1417320" cy="347472"/>
+          </a:xfrm>
+          <a:prstGeom prst="rect">
+            <a:avLst/>
+          </a:prstGeom>
+          <a:noFill/>
+          <a:ln/>
+        </p:spPr>
+        <p:txBody>
+          <a:bodyPr wrap="square" lIns="25400" tIns="63500" rIns="63500" bIns="25400" rtlCol="0" anchor="ctr"/>
+          <a:lstStyle/>
+          <a:p>
+            <a:pPr algn="ctr" indent="0" marL="0">
+              <a:buNone/>
+            </a:pPr>
+            <a:r>
+              <a:rPr lang="en-US" sz="1000" b="1" dirty="0">
+                <a:solidFill>
+                  <a:srgbClr val="1F2933"/>
+                </a:solidFill>
+                <a:latin typeface="Arial" pitchFamily="34" charset="0"/>
+                <a:ea typeface="Arial" pitchFamily="34" charset="-122"/>
+                <a:cs typeface="Arial" pitchFamily="34" charset="-120"/>
+              </a:rPr>
+              <a:t>BEP020 · BEP042</a:t>
+            </a:r>
+            <a:endParaRPr lang="en-US" sz="1000" dirty="0"/>
+          </a:p>
+          <a:p>
+            <a:pPr algn="ctr" indent="0" marL="0">
+              <a:buNone/>
+            </a:pPr>
+            <a:r>
+              <a:rPr lang="en-US" sz="900" i="1" dirty="0">
+                <a:solidFill>
+                  <a:srgbClr val="5B6770"/>
+                </a:solidFill>
+                <a:latin typeface="Arial" pitchFamily="34" charset="0"/>
+                <a:ea typeface="Arial" pitchFamily="34" charset="-122"/>
+                <a:cs typeface="Arial" pitchFamily="34" charset="-120"/>
+              </a:rPr>
+              <a:t>eye tracking · EMG</a:t>
+            </a:r>
+            <a:endParaRPr lang="en-US" sz="1000" dirty="0"/>
+          </a:p>
+        </p:txBody>
+      </p:sp>
+      <p:sp>
+        <p:nvSpPr>
+          <p:cNvPr id="81" name="BIDS WIP Multi-subject BEP"/>
+          <p:cNvSpPr/>
+          <p:nvPr/>
+        </p:nvSpPr>
+        <p:spPr>
+          <a:xfrm>
+            <a:off x="6675120" y="4032504"/>
+            <a:ext cx="1417320" cy="347472"/>
+          </a:xfrm>
+          <a:prstGeom prst="roundRect">
+            <a:avLst>
+              <a:gd name="adj" fmla="val 15789"/>
+            </a:avLst>
+          </a:prstGeom>
+          <a:solidFill>
+            <a:srgbClr val="FFFFFF"/>
+          </a:solidFill>
+          <a:ln w="15875">
+            <a:solidFill>
+              <a:srgbClr val="009E73"/>
+            </a:solidFill>
+            <a:prstDash val="dash"/>
+          </a:ln>
+        </p:spPr>
+      </p:sp>
+      <p:sp>
+        <p:nvSpPr>
+          <p:cNvPr id="82" name="Text 80"/>
+          <p:cNvSpPr txBox="1"/>
+          <p:nvPr/>
+        </p:nvSpPr>
+        <p:spPr>
+          <a:xfrm>
+            <a:off x="6675120" y="4032504"/>
+            <a:ext cx="1417320" cy="347472"/>
+          </a:xfrm>
+          <a:prstGeom prst="rect">
+            <a:avLst/>
+          </a:prstGeom>
+          <a:noFill/>
+          <a:ln/>
+        </p:spPr>
+        <p:txBody>
+          <a:bodyPr wrap="square" lIns="25400" tIns="63500" rIns="63500" bIns="25400" rtlCol="0" anchor="ctr"/>
+          <a:lstStyle/>
+          <a:p>
+            <a:pPr algn="ctr" indent="0" marL="0">
+              <a:buNone/>
+            </a:pPr>
+            <a:r>
+              <a:rPr lang="en-US" sz="1000" b="1" dirty="0">
+                <a:solidFill>
+                  <a:srgbClr val="1F2933"/>
+                </a:solidFill>
+                <a:latin typeface="Arial" pitchFamily="34" charset="0"/>
+                <a:ea typeface="Arial" pitchFamily="34" charset="-122"/>
+                <a:cs typeface="Arial" pitchFamily="34" charset="-120"/>
+              </a:rPr>
+              <a:t>Multi-subject BEP</a:t>
+            </a:r>
+            <a:endParaRPr lang="en-US" sz="1000" dirty="0"/>
+          </a:p>
+          <a:p>
+            <a:pPr algn="ctr" indent="0" marL="0">
+              <a:buNone/>
+            </a:pPr>
+            <a:r>
+              <a:rPr lang="en-US" sz="900" i="1" dirty="0">
+                <a:solidFill>
+                  <a:srgbClr val="5B6770"/>
+                </a:solidFill>
+                <a:latin typeface="Arial" pitchFamily="34" charset="0"/>
+                <a:ea typeface="Arial" pitchFamily="34" charset="-122"/>
+                <a:cs typeface="Arial" pitchFamily="34" charset="-120"/>
+              </a:rPr>
+              <a:t>planned</a:t>
+            </a:r>
+            <a:endParaRPr lang="en-US" sz="1000" dirty="0"/>
+          </a:p>
+        </p:txBody>
+      </p:sp>
+      <p:sp>
+        <p:nvSpPr>
+          <p:cNvPr id="83" name="Psych-DS"/>
+          <p:cNvSpPr/>
+          <p:nvPr/>
+        </p:nvSpPr>
+        <p:spPr>
+          <a:xfrm>
+            <a:off x="8183880" y="2843784"/>
+            <a:ext cx="1463040" cy="713232"/>
+          </a:xfrm>
+          <a:prstGeom prst="roundRect">
+            <a:avLst>
+              <a:gd name="adj" fmla="val 7692"/>
+            </a:avLst>
+          </a:prstGeom>
+          <a:solidFill>
+            <a:srgbClr val="FFFFFF"/>
+          </a:solidFill>
+          <a:ln w="15875">
+            <a:solidFill>
+              <a:srgbClr val="009E73"/>
+            </a:solidFill>
+            <a:prstDash val="solid"/>
+          </a:ln>
+        </p:spPr>
+      </p:sp>
+      <p:sp>
+        <p:nvSpPr>
+          <p:cNvPr id="84" name="Text 82"/>
+          <p:cNvSpPr txBox="1"/>
+          <p:nvPr/>
+        </p:nvSpPr>
+        <p:spPr>
+          <a:xfrm>
+            <a:off x="8183880" y="2843784"/>
+            <a:ext cx="1463040" cy="713232"/>
+          </a:xfrm>
+          <a:prstGeom prst="rect">
+            <a:avLst/>
+          </a:prstGeom>
+          <a:noFill/>
+          <a:ln/>
+        </p:spPr>
+        <p:txBody>
+          <a:bodyPr wrap="square" lIns="25400" tIns="63500" rIns="63500" bIns="25400" rtlCol="0" anchor="ctr"/>
+          <a:lstStyle/>
+          <a:p>
+            <a:pPr algn="ctr" indent="0" marL="0">
+              <a:buNone/>
+            </a:pPr>
+            <a:r>
+              <a:rPr lang="en-US" sz="1200" b="1" dirty="0">
+                <a:solidFill>
+                  <a:srgbClr val="1F2933"/>
+                </a:solidFill>
+                <a:latin typeface="Arial" pitchFamily="34" charset="0"/>
+                <a:ea typeface="Arial" pitchFamily="34" charset="-122"/>
+                <a:cs typeface="Arial" pitchFamily="34" charset="-120"/>
+              </a:rPr>
+              <a:t>Psych-DS</a:t>
+            </a:r>
+            <a:endParaRPr lang="en-US" sz="1000" dirty="0"/>
+          </a:p>
+          <a:p>
+            <a:pPr algn="ctr" indent="0" marL="0">
+              <a:buNone/>
+            </a:pPr>
+            <a:r>
+              <a:rPr lang="en-US" sz="950" i="1" dirty="0">
+                <a:solidFill>
+                  <a:srgbClr val="5B6770"/>
+                </a:solidFill>
+                <a:latin typeface="Arial" pitchFamily="34" charset="0"/>
+                <a:ea typeface="Arial" pitchFamily="34" charset="-122"/>
+                <a:cs typeface="Arial" pitchFamily="34" charset="-120"/>
+              </a:rPr>
+              <a:t>every variable defined in JSON</a:t>
+            </a:r>
+            <a:endParaRPr lang="en-US" sz="1000" dirty="0"/>
+          </a:p>
+        </p:txBody>
+      </p:sp>
+      <p:sp>
+        <p:nvSpPr>
+          <p:cNvPr id="85" name="Psych-DS WIP"/>
+          <p:cNvSpPr/>
+          <p:nvPr/>
+        </p:nvSpPr>
+        <p:spPr>
+          <a:xfrm>
+            <a:off x="8183880" y="3630168"/>
+            <a:ext cx="1463040" cy="749808"/>
+          </a:xfrm>
+          <a:prstGeom prst="roundRect">
+            <a:avLst>
+              <a:gd name="adj" fmla="val 7317"/>
+            </a:avLst>
+          </a:prstGeom>
+          <a:solidFill>
+            <a:srgbClr val="FFFFFF"/>
+          </a:solidFill>
+          <a:ln w="15875">
+            <a:solidFill>
+              <a:srgbClr val="009E73"/>
+            </a:solidFill>
+            <a:prstDash val="dash"/>
+          </a:ln>
+        </p:spPr>
+      </p:sp>
+      <p:sp>
+        <p:nvSpPr>
+          <p:cNvPr id="86" name="Text 84"/>
+          <p:cNvSpPr txBox="1"/>
+          <p:nvPr/>
+        </p:nvSpPr>
+        <p:spPr>
+          <a:xfrm>
+            <a:off x="8183880" y="3630168"/>
+            <a:ext cx="1463040" cy="749808"/>
+          </a:xfrm>
+          <a:prstGeom prst="rect">
+            <a:avLst/>
+          </a:prstGeom>
+          <a:noFill/>
+          <a:ln/>
+        </p:spPr>
+        <p:txBody>
+          <a:bodyPr wrap="square" lIns="25400" tIns="63500" rIns="63500" bIns="25400" rtlCol="0" anchor="ctr"/>
+          <a:lstStyle/>
+          <a:p>
+            <a:pPr algn="ctr" indent="0" marL="0">
+              <a:buNone/>
+            </a:pPr>
+            <a:r>
+              <a:rPr lang="en-US" sz="1000" b="1" dirty="0">
+                <a:solidFill>
+                  <a:srgbClr val="1F2933"/>
+                </a:solidFill>
+                <a:latin typeface="Arial" pitchFamily="34" charset="0"/>
+                <a:ea typeface="Arial" pitchFamily="34" charset="-122"/>
+                <a:cs typeface="Arial" pitchFamily="34" charset="-120"/>
+              </a:rPr>
+              <a:t>Extensions</a:t>
+            </a:r>
+            <a:endParaRPr lang="en-US" sz="1000" dirty="0"/>
+          </a:p>
+          <a:p>
+            <a:pPr algn="ctr" indent="0" marL="0">
+              <a:buNone/>
+            </a:pPr>
+            <a:r>
+              <a:rPr lang="en-US" sz="900" i="1" dirty="0">
+                <a:solidFill>
+                  <a:srgbClr val="5B6770"/>
+                </a:solidFill>
+                <a:latin typeface="Arial" pitchFamily="34" charset="0"/>
+                <a:ea typeface="Arial" pitchFamily="34" charset="-122"/>
+                <a:cs typeface="Arial" pitchFamily="34" charset="-120"/>
+              </a:rPr>
+              <a:t>process in development</a:t>
+            </a:r>
+            <a:endParaRPr lang="en-US" sz="1000" dirty="0"/>
+          </a:p>
+        </p:txBody>
+      </p:sp>
+      <p:sp>
+        <p:nvSpPr>
+          <p:cNvPr id="87" name="Schema languages"/>
+          <p:cNvSpPr/>
+          <p:nvPr/>
+        </p:nvSpPr>
+        <p:spPr>
+          <a:xfrm>
+            <a:off x="9738360" y="3680460"/>
+            <a:ext cx="2057400" cy="1600200"/>
+          </a:xfrm>
+          <a:prstGeom prst="roundRect">
+            <a:avLst>
+              <a:gd name="adj" fmla="val 4571"/>
+            </a:avLst>
+          </a:prstGeom>
+          <a:solidFill>
+            <a:srgbClr val="FFFFFF"/>
+          </a:solidFill>
+          <a:ln w="15875">
+            <a:solidFill>
               <a:srgbClr val="56B4E9"/>
             </a:solidFill>
             <a:prstDash val="solid"/>
@@ -2835,13 +4086,13 @@
       </p:sp>
       <p:sp>
         <p:nvSpPr>
-          <p:cNvPr id="62" name="Badge 6"/>
-          <p:cNvSpPr/>
-          <p:nvPr/>
-        </p:nvSpPr>
-        <p:spPr>
-          <a:xfrm>
-            <a:off x="9665208" y="3191256"/>
+          <p:cNvPr id="88" name="Badge 6"/>
+          <p:cNvSpPr/>
+          <p:nvPr/>
+        </p:nvSpPr>
+        <p:spPr>
+          <a:xfrm>
+            <a:off x="9848088" y="3808476"/>
             <a:ext cx="292608" cy="292608"/>
           </a:xfrm>
           <a:prstGeom prst="ellipse">
@@ -2860,13 +4111,13 @@
       </p:sp>
       <p:sp>
         <p:nvSpPr>
-          <p:cNvPr id="63" name="Text 61"/>
+          <p:cNvPr id="89" name="Text 87"/>
           <p:cNvSpPr txBox="1"/>
           <p:nvPr/>
         </p:nvSpPr>
         <p:spPr>
           <a:xfrm>
-            <a:off x="9665208" y="3191256"/>
+            <a:off x="9848088" y="3808476"/>
             <a:ext cx="292608" cy="292608"/>
           </a:xfrm>
           <a:prstGeom prst="rect">
@@ -2899,14 +4150,14 @@
       </p:sp>
       <p:sp>
         <p:nvSpPr>
-          <p:cNvPr id="64" name="Text 62"/>
+          <p:cNvPr id="90" name="Text 88"/>
           <p:cNvSpPr txBox="1"/>
           <p:nvPr/>
         </p:nvSpPr>
         <p:spPr>
           <a:xfrm>
-            <a:off x="10030968" y="3154680"/>
-            <a:ext cx="1664208" cy="365760"/>
+            <a:off x="10213848" y="3771900"/>
+            <a:ext cx="1508760" cy="365760"/>
           </a:xfrm>
           <a:prstGeom prst="rect">
             <a:avLst/>
@@ -2922,7 +4173,7 @@
               <a:buNone/>
             </a:pPr>
             <a:r>
-              <a:rPr lang="en-US" sz="1200" b="1" dirty="0">
+              <a:rPr lang="en-US" sz="1150" b="1" dirty="0">
                 <a:solidFill>
                   <a:srgbClr val="1F2933"/>
                 </a:solidFill>
@@ -2932,20 +4183,20 @@
               </a:rPr>
               <a:t>Schema languages</a:t>
             </a:r>
-            <a:endParaRPr lang="en-US" sz="1200" dirty="0"/>
-          </a:p>
-        </p:txBody>
-      </p:sp>
-      <p:sp>
-        <p:nvSpPr>
-          <p:cNvPr id="65" name="Text 63"/>
+            <a:endParaRPr lang="en-US" sz="1150" dirty="0"/>
+          </a:p>
+        </p:txBody>
+      </p:sp>
+      <p:sp>
+        <p:nvSpPr>
+          <p:cNvPr id="91" name="Text 89"/>
           <p:cNvSpPr txBox="1"/>
           <p:nvPr/>
         </p:nvSpPr>
         <p:spPr>
           <a:xfrm>
-            <a:off x="9692640" y="3630168"/>
-            <a:ext cx="1984248" cy="685800"/>
+            <a:off x="9875520" y="4229100"/>
+            <a:ext cx="1828800" cy="960120"/>
           </a:xfrm>
           <a:prstGeom prst="rect">
             <a:avLst/>
@@ -2959,12 +4210,12 @@
           <a:p>
             <a:pPr indent="0" marL="0">
               <a:spcAft>
-                <a:spcPts val="700"/>
+                <a:spcPts val="600"/>
               </a:spcAft>
               <a:buNone/>
             </a:pPr>
             <a:r>
-              <a:rPr lang="en-US" sz="1150" b="1" dirty="0">
+              <a:rPr lang="en-US" sz="1050" b="1" dirty="0">
                 <a:solidFill>
                   <a:srgbClr val="1F2933"/>
                 </a:solidFill>
@@ -2976,12 +4227,12 @@
             </a:r>
             <a:pPr indent="0" marL="0">
               <a:spcAft>
-                <a:spcPts val="700"/>
+                <a:spcPts val="600"/>
               </a:spcAft>
               <a:buNone/>
             </a:pPr>
             <a:r>
-              <a:rPr lang="en-US" sz="1150" i="1" dirty="0">
+              <a:rPr lang="en-US" sz="1050" i="1" dirty="0">
                 <a:solidFill>
                   <a:srgbClr val="5B6770"/>
                 </a:solidFill>
@@ -2993,12 +4244,12 @@
             </a:r>
             <a:pPr indent="0" marL="0">
               <a:spcAft>
-                <a:spcPts val="700"/>
+                <a:spcPts val="600"/>
               </a:spcAft>
               <a:buNone/>
             </a:pPr>
             <a:r>
-              <a:rPr lang="en-US" sz="1150" b="1" dirty="0">
+              <a:rPr lang="en-US" sz="1050" b="1" dirty="0">
                 <a:solidFill>
                   <a:srgbClr val="1F2933"/>
                 </a:solidFill>
@@ -3008,17 +4259,17 @@
               </a:rPr>
               <a:t>NWB</a:t>
             </a:r>
-            <a:endParaRPr lang="en-US" sz="1150" dirty="0"/>
+            <a:endParaRPr lang="en-US" sz="1050" dirty="0"/>
           </a:p>
           <a:p>
             <a:pPr indent="0" marL="0">
               <a:spcAft>
-                <a:spcPts val="700"/>
+                <a:spcPts val="600"/>
               </a:spcAft>
               <a:buNone/>
             </a:pPr>
             <a:r>
-              <a:rPr lang="en-US" sz="1150" b="1" dirty="0">
+              <a:rPr lang="en-US" sz="1050" b="1" dirty="0">
                 <a:solidFill>
                   <a:srgbClr val="1F2933"/>
                 </a:solidFill>
@@ -3030,12 +4281,12 @@
             </a:r>
             <a:pPr indent="0" marL="0">
               <a:spcAft>
-                <a:spcPts val="700"/>
+                <a:spcPts val="600"/>
               </a:spcAft>
               <a:buNone/>
             </a:pPr>
             <a:r>
-              <a:rPr lang="en-US" sz="1150" i="1" dirty="0">
+              <a:rPr lang="en-US" sz="1050" i="1" dirty="0">
                 <a:solidFill>
                   <a:srgbClr val="5B6770"/>
                 </a:solidFill>
@@ -3047,12 +4298,12 @@
             </a:r>
             <a:pPr indent="0" marL="0">
               <a:spcAft>
-                <a:spcPts val="700"/>
+                <a:spcPts val="600"/>
               </a:spcAft>
               <a:buNone/>
             </a:pPr>
             <a:r>
-              <a:rPr lang="en-US" sz="1150" b="1" dirty="0">
+              <a:rPr lang="en-US" sz="1050" b="1" dirty="0">
                 <a:solidFill>
                   <a:srgbClr val="1F2933"/>
                 </a:solidFill>
@@ -3062,17 +4313,17 @@
               </a:rPr>
               <a:t>BIDS</a:t>
             </a:r>
-            <a:endParaRPr lang="en-US" sz="1150" dirty="0"/>
+            <a:endParaRPr lang="en-US" sz="1050" dirty="0"/>
           </a:p>
           <a:p>
             <a:pPr indent="0" marL="0">
               <a:spcAft>
-                <a:spcPts val="700"/>
+                <a:spcPts val="600"/>
               </a:spcAft>
               <a:buNone/>
             </a:pPr>
             <a:r>
-              <a:rPr lang="en-US" sz="1150" b="1" dirty="0">
+              <a:rPr lang="en-US" sz="1050" b="1" dirty="0">
                 <a:solidFill>
                   <a:srgbClr val="1F2933"/>
                 </a:solidFill>
@@ -3084,12 +4335,12 @@
             </a:r>
             <a:pPr indent="0" marL="0">
               <a:spcAft>
-                <a:spcPts val="700"/>
+                <a:spcPts val="600"/>
               </a:spcAft>
               <a:buNone/>
             </a:pPr>
             <a:r>
-              <a:rPr lang="en-US" sz="1150" i="1" dirty="0">
+              <a:rPr lang="en-US" sz="1050" i="1" dirty="0">
                 <a:solidFill>
                   <a:srgbClr val="5B6770"/>
                 </a:solidFill>
@@ -3101,12 +4352,12 @@
             </a:r>
             <a:pPr indent="0" marL="0">
               <a:spcAft>
-                <a:spcPts val="700"/>
+                <a:spcPts val="600"/>
               </a:spcAft>
               <a:buNone/>
             </a:pPr>
             <a:r>
-              <a:rPr lang="en-US" sz="1150" b="1" dirty="0">
+              <a:rPr lang="en-US" sz="1050" b="1" dirty="0">
                 <a:solidFill>
                   <a:srgbClr val="1F2933"/>
                 </a:solidFill>
@@ -3114,9 +4365,400 @@
                 <a:ea typeface="Arial" pitchFamily="34" charset="-122"/>
                 <a:cs typeface="Arial" pitchFamily="34" charset="-120"/>
               </a:rPr>
-              <a:t>Psych-DS</a:t>
-            </a:r>
-            <a:endParaRPr lang="en-US" sz="1150" dirty="0"/>
+              <a:t>Psych-DS, Neuro Termsets</a:t>
+            </a:r>
+            <a:endParaRPr lang="en-US" sz="1050" dirty="0"/>
+          </a:p>
+        </p:txBody>
+      </p:sp>
+      <p:sp>
+        <p:nvSpPr>
+          <p:cNvPr id="92" name="HED"/>
+          <p:cNvSpPr/>
+          <p:nvPr/>
+        </p:nvSpPr>
+        <p:spPr>
+          <a:xfrm>
+            <a:off x="2148840" y="1563624"/>
+            <a:ext cx="5943600" cy="292608"/>
+          </a:xfrm>
+          <a:prstGeom prst="roundRect">
+            <a:avLst>
+              <a:gd name="adj" fmla="val 18750"/>
+            </a:avLst>
+          </a:prstGeom>
+          <a:solidFill>
+            <a:srgbClr val="FFFFFF"/>
+          </a:solidFill>
+          <a:ln w="15875">
+            <a:solidFill>
+              <a:srgbClr val="CC79A7"/>
+            </a:solidFill>
+            <a:prstDash val="solid"/>
+          </a:ln>
+        </p:spPr>
+      </p:sp>
+      <p:sp>
+        <p:nvSpPr>
+          <p:cNvPr id="93" name="Text 91"/>
+          <p:cNvSpPr txBox="1"/>
+          <p:nvPr/>
+        </p:nvSpPr>
+        <p:spPr>
+          <a:xfrm>
+            <a:off x="2148840" y="1563624"/>
+            <a:ext cx="5943600" cy="292608"/>
+          </a:xfrm>
+          <a:prstGeom prst="rect">
+            <a:avLst/>
+          </a:prstGeom>
+          <a:noFill/>
+          <a:ln/>
+        </p:spPr>
+        <p:txBody>
+          <a:bodyPr wrap="square" lIns="25400" tIns="63500" rIns="63500" bIns="25400" rtlCol="0" anchor="ctr"/>
+          <a:lstStyle/>
+          <a:p>
+            <a:pPr algn="ctr" indent="0" marL="0">
+              <a:buNone/>
+            </a:pPr>
+            <a:r>
+              <a:rPr lang="en-US" sz="1100" b="1" dirty="0">
+                <a:solidFill>
+                  <a:srgbClr val="1F2933"/>
+                </a:solidFill>
+                <a:latin typeface="Arial" pitchFamily="34" charset="0"/>
+                <a:ea typeface="Arial" pitchFamily="34" charset="-122"/>
+                <a:cs typeface="Arial" pitchFamily="34" charset="-120"/>
+              </a:rPr>
+              <a:t>HED </a:t>
+            </a:r>
+            <a:pPr algn="ctr" indent="0" marL="0">
+              <a:buNone/>
+            </a:pPr>
+            <a:r>
+              <a:rPr lang="en-US" sz="950" i="1" dirty="0">
+                <a:solidFill>
+                  <a:srgbClr val="5B6770"/>
+                </a:solidFill>
+                <a:latin typeface="Arial" pitchFamily="34" charset="0"/>
+                <a:ea typeface="Arial" pitchFamily="34" charset="-122"/>
+                <a:cs typeface="Arial" pitchFamily="34" charset="-120"/>
+              </a:rPr>
+              <a:t>event annotations in BIDS, and in NWB via ndx-hed</a:t>
+            </a:r>
+            <a:endParaRPr lang="en-US" sz="1000" dirty="0"/>
+          </a:p>
+        </p:txBody>
+      </p:sp>
+      <p:sp>
+        <p:nvSpPr>
+          <p:cNvPr id="94" name="Terminologies"/>
+          <p:cNvSpPr/>
+          <p:nvPr/>
+        </p:nvSpPr>
+        <p:spPr>
+          <a:xfrm>
+            <a:off x="2148840" y="1911096"/>
+            <a:ext cx="5943600" cy="292608"/>
+          </a:xfrm>
+          <a:prstGeom prst="roundRect">
+            <a:avLst>
+              <a:gd name="adj" fmla="val 18750"/>
+            </a:avLst>
+          </a:prstGeom>
+          <a:solidFill>
+            <a:srgbClr val="FFFFFF"/>
+          </a:solidFill>
+          <a:ln w="15875">
+            <a:solidFill>
+              <a:srgbClr val="CC79A7"/>
+            </a:solidFill>
+            <a:prstDash val="solid"/>
+          </a:ln>
+        </p:spPr>
+      </p:sp>
+      <p:sp>
+        <p:nvSpPr>
+          <p:cNvPr id="95" name="Text 93"/>
+          <p:cNvSpPr txBox="1"/>
+          <p:nvPr/>
+        </p:nvSpPr>
+        <p:spPr>
+          <a:xfrm>
+            <a:off x="2148840" y="1911096"/>
+            <a:ext cx="5943600" cy="292608"/>
+          </a:xfrm>
+          <a:prstGeom prst="rect">
+            <a:avLst/>
+          </a:prstGeom>
+          <a:noFill/>
+          <a:ln/>
+        </p:spPr>
+        <p:txBody>
+          <a:bodyPr wrap="square" lIns="25400" tIns="63500" rIns="63500" bIns="25400" rtlCol="0" anchor="ctr"/>
+          <a:lstStyle/>
+          <a:p>
+            <a:pPr algn="ctr" indent="0" marL="0">
+              <a:buNone/>
+            </a:pPr>
+            <a:r>
+              <a:rPr lang="en-US" sz="1100" b="1" dirty="0">
+                <a:solidFill>
+                  <a:srgbClr val="1F2933"/>
+                </a:solidFill>
+                <a:latin typeface="Arial" pitchFamily="34" charset="0"/>
+                <a:ea typeface="Arial" pitchFamily="34" charset="-122"/>
+                <a:cs typeface="Arial" pitchFamily="34" charset="-120"/>
+              </a:rPr>
+              <a:t>NCBI Taxonomy · UBERON · Allen atlases · Cell Ontology · RRID · ORCID · ROR</a:t>
+            </a:r>
+            <a:endParaRPr lang="en-US" sz="1000" dirty="0"/>
+          </a:p>
+        </p:txBody>
+      </p:sp>
+      <p:sp>
+        <p:nvSpPr>
+          <p:cNvPr id="96" name="Neuro Termsets"/>
+          <p:cNvSpPr/>
+          <p:nvPr/>
+        </p:nvSpPr>
+        <p:spPr>
+          <a:xfrm>
+            <a:off x="2148840" y="2258568"/>
+            <a:ext cx="5943600" cy="292608"/>
+          </a:xfrm>
+          <a:prstGeom prst="roundRect">
+            <a:avLst>
+              <a:gd name="adj" fmla="val 18750"/>
+            </a:avLst>
+          </a:prstGeom>
+          <a:solidFill>
+            <a:srgbClr val="FFFFFF"/>
+          </a:solidFill>
+          <a:ln w="15875">
+            <a:solidFill>
+              <a:srgbClr val="CC79A7"/>
+            </a:solidFill>
+            <a:prstDash val="dash"/>
+          </a:ln>
+        </p:spPr>
+      </p:sp>
+      <p:sp>
+        <p:nvSpPr>
+          <p:cNvPr id="97" name="Text 95"/>
+          <p:cNvSpPr txBox="1"/>
+          <p:nvPr/>
+        </p:nvSpPr>
+        <p:spPr>
+          <a:xfrm>
+            <a:off x="2148840" y="2258568"/>
+            <a:ext cx="5943600" cy="292608"/>
+          </a:xfrm>
+          <a:prstGeom prst="rect">
+            <a:avLst/>
+          </a:prstGeom>
+          <a:noFill/>
+          <a:ln/>
+        </p:spPr>
+        <p:txBody>
+          <a:bodyPr wrap="square" lIns="25400" tIns="63500" rIns="63500" bIns="25400" rtlCol="0" anchor="ctr"/>
+          <a:lstStyle/>
+          <a:p>
+            <a:pPr algn="ctr" indent="0" marL="0">
+              <a:buNone/>
+            </a:pPr>
+            <a:r>
+              <a:rPr lang="en-US" sz="1100" b="1" dirty="0">
+                <a:solidFill>
+                  <a:srgbClr val="1F2933"/>
+                </a:solidFill>
+                <a:latin typeface="Arial" pitchFamily="34" charset="0"/>
+                <a:ea typeface="Arial" pitchFamily="34" charset="-122"/>
+                <a:cs typeface="Arial" pitchFamily="34" charset="-120"/>
+              </a:rPr>
+              <a:t>Neuro Termsets </a:t>
+            </a:r>
+            <a:pPr algn="ctr" indent="0" marL="0">
+              <a:buNone/>
+            </a:pPr>
+            <a:r>
+              <a:rPr lang="en-US" sz="950" i="1" dirty="0">
+                <a:solidFill>
+                  <a:srgbClr val="5B6770"/>
+                </a:solidFill>
+                <a:latin typeface="Arial" pitchFamily="34" charset="0"/>
+                <a:ea typeface="Arial" pitchFamily="34" charset="-122"/>
+                <a:cs typeface="Arial" pitchFamily="34" charset="-120"/>
+              </a:rPr>
+              <a:t>shared term sets that validate NWB metadata and fill HERD; BIDS planned</a:t>
+            </a:r>
+            <a:endParaRPr lang="en-US" sz="1000" dirty="0"/>
+          </a:p>
+        </p:txBody>
+      </p:sp>
+      <p:sp>
+        <p:nvSpPr>
+          <p:cNvPr id="98" name="Behavior vocabulary gap"/>
+          <p:cNvSpPr/>
+          <p:nvPr/>
+        </p:nvSpPr>
+        <p:spPr>
+          <a:xfrm>
+            <a:off x="9738360" y="1737360"/>
+            <a:ext cx="2057400" cy="640080"/>
+          </a:xfrm>
+          <a:prstGeom prst="roundRect">
+            <a:avLst>
+              <a:gd name="adj" fmla="val 8571"/>
+            </a:avLst>
+          </a:prstGeom>
+          <a:solidFill>
+            <a:srgbClr val="8A96A3">
+              <a:alpha val="15000"/>
+            </a:srgbClr>
+          </a:solidFill>
+          <a:ln w="15875">
+            <a:solidFill>
+              <a:srgbClr val="8A96A3"/>
+            </a:solidFill>
+            <a:prstDash val="dash"/>
+          </a:ln>
+        </p:spPr>
+      </p:sp>
+      <p:sp>
+        <p:nvSpPr>
+          <p:cNvPr id="99" name="Text 97"/>
+          <p:cNvSpPr txBox="1"/>
+          <p:nvPr/>
+        </p:nvSpPr>
+        <p:spPr>
+          <a:xfrm>
+            <a:off x="9738360" y="1737360"/>
+            <a:ext cx="2057400" cy="640080"/>
+          </a:xfrm>
+          <a:prstGeom prst="rect">
+            <a:avLst/>
+          </a:prstGeom>
+          <a:noFill/>
+          <a:ln/>
+        </p:spPr>
+        <p:txBody>
+          <a:bodyPr wrap="square" lIns="25400" tIns="63500" rIns="63500" bIns="25400" rtlCol="0" anchor="ctr"/>
+          <a:lstStyle/>
+          <a:p>
+            <a:pPr algn="ctr" indent="0" marL="0">
+              <a:buNone/>
+            </a:pPr>
+            <a:r>
+              <a:rPr lang="en-US" sz="1050" b="1" dirty="0">
+                <a:solidFill>
+                  <a:srgbClr val="1F2933"/>
+                </a:solidFill>
+                <a:latin typeface="Arial" pitchFamily="34" charset="0"/>
+                <a:ea typeface="Arial" pitchFamily="34" charset="-122"/>
+                <a:cs typeface="Arial" pitchFamily="34" charset="-120"/>
+              </a:rPr>
+              <a:t>Behavior labels</a:t>
+            </a:r>
+            <a:endParaRPr lang="en-US" sz="1000" dirty="0"/>
+          </a:p>
+          <a:p>
+            <a:pPr algn="ctr" indent="0" marL="0">
+              <a:buNone/>
+            </a:pPr>
+            <a:r>
+              <a:rPr lang="en-US" sz="950" dirty="0">
+                <a:solidFill>
+                  <a:srgbClr val="1F2933"/>
+                </a:solidFill>
+                <a:latin typeface="Arial" pitchFamily="34" charset="0"/>
+                <a:ea typeface="Arial" pitchFamily="34" charset="-122"/>
+                <a:cs typeface="Arial" pitchFamily="34" charset="-120"/>
+              </a:rPr>
+              <a:t>no shared vocabulary in use</a:t>
+            </a:r>
+            <a:endParaRPr lang="en-US" sz="1000" dirty="0"/>
+          </a:p>
+        </p:txBody>
+      </p:sp>
+      <p:sp>
+        <p:nvSpPr>
+          <p:cNvPr id="100" name="EMBER"/>
+          <p:cNvSpPr/>
+          <p:nvPr/>
+        </p:nvSpPr>
+        <p:spPr>
+          <a:xfrm>
+            <a:off x="2148840" y="749808"/>
+            <a:ext cx="9646920" cy="420624"/>
+          </a:xfrm>
+          <a:prstGeom prst="roundRect">
+            <a:avLst>
+              <a:gd name="adj" fmla="val 13043"/>
+            </a:avLst>
+          </a:prstGeom>
+          <a:solidFill>
+            <a:srgbClr val="FFFFFF"/>
+          </a:solidFill>
+          <a:ln w="15875">
+            <a:solidFill>
+              <a:srgbClr val="0072B2"/>
+            </a:solidFill>
+            <a:prstDash val="solid"/>
+          </a:ln>
+        </p:spPr>
+      </p:sp>
+      <p:sp>
+        <p:nvSpPr>
+          <p:cNvPr id="101" name="Text 99"/>
+          <p:cNvSpPr txBox="1"/>
+          <p:nvPr/>
+        </p:nvSpPr>
+        <p:spPr>
+          <a:xfrm>
+            <a:off x="2148840" y="749808"/>
+            <a:ext cx="9646920" cy="420624"/>
+          </a:xfrm>
+          <a:prstGeom prst="rect">
+            <a:avLst/>
+          </a:prstGeom>
+          <a:noFill/>
+          <a:ln/>
+        </p:spPr>
+        <p:txBody>
+          <a:bodyPr wrap="square" lIns="25400" tIns="63500" rIns="63500" bIns="25400" rtlCol="0" anchor="ctr"/>
+          <a:lstStyle/>
+          <a:p>
+            <a:pPr algn="ctr" indent="0" marL="0">
+              <a:buNone/>
+            </a:pPr>
+            <a:r>
+              <a:rPr lang="en-US" sz="1200" b="1" dirty="0">
+                <a:solidFill>
+                  <a:srgbClr val="1F2933"/>
+                </a:solidFill>
+                <a:latin typeface="Arial" pitchFamily="34" charset="0"/>
+                <a:ea typeface="Arial" pitchFamily="34" charset="-122"/>
+                <a:cs typeface="Arial" pitchFamily="34" charset="-120"/>
+              </a:rPr>
+              <a:t>EMBER   </a:t>
+            </a:r>
+            <a:pPr algn="ctr" indent="0" marL="0">
+              <a:buNone/>
+            </a:pPr>
+            <a:r>
+              <a:rPr lang="en-US" sz="1000" i="1" dirty="0">
+                <a:solidFill>
+                  <a:srgbClr val="5B6770"/>
+                </a:solidFill>
+                <a:latin typeface="Arial" pitchFamily="34" charset="0"/>
+                <a:ea typeface="Arial" pitchFamily="34" charset="-122"/>
+                <a:cs typeface="Arial" pitchFamily="34" charset="-120"/>
+              </a:rPr>
+              <a:t>accepts NWB, DANDI-layout, BIDS, and Psych-DS datasets, with privacy levels for identifiable human data</a:t>
+            </a:r>
+            <a:endParaRPr lang="en-US" sz="1000" dirty="0"/>
           </a:p>
         </p:txBody>
       </p:sp>

</xml_diff>

<commit_message>
Fig. 5: more space around the NWB and BIDS paths; format outlines in path colours
Co-Authored-By: Claude Opus 5.5 <noreply@anthropic.com>
</commit_message>
<xml_diff>
--- a/figures/fig5_bbqs_stack/fig5_bbqs_stack_design.pptx
+++ b/figures/fig5_bbqs_stack/fig5_bbqs_stack_design.pptx
@@ -1992,7 +1992,7 @@
         </p:nvSpPr>
         <p:spPr>
           <a:xfrm flipV="1">
-            <a:off x="3291840" y="4105656"/>
+            <a:off x="3314700" y="4105656"/>
             <a:ext cx="0" cy="2816352"/>
           </a:xfrm>
           <a:prstGeom prst="line">
@@ -2016,7 +2016,7 @@
         </p:nvSpPr>
         <p:spPr>
           <a:xfrm flipV="1">
-            <a:off x="3291840" y="1124712"/>
+            <a:off x="3314700" y="1124712"/>
             <a:ext cx="0" cy="2450592"/>
           </a:xfrm>
           <a:prstGeom prst="line">
@@ -2040,7 +2040,7 @@
         </p:nvSpPr>
         <p:spPr>
           <a:xfrm flipV="1">
-            <a:off x="5852160" y="1124712"/>
+            <a:off x="5897880" y="1124712"/>
             <a:ext cx="0" cy="5669280"/>
           </a:xfrm>
           <a:prstGeom prst="line">
@@ -2064,7 +2064,7 @@
         </p:nvSpPr>
         <p:spPr>
           <a:xfrm flipV="1">
-            <a:off x="7772400" y="1124712"/>
+            <a:off x="7795260" y="1124712"/>
             <a:ext cx="0" cy="5541264"/>
           </a:xfrm>
           <a:prstGeom prst="line">
@@ -2088,7 +2088,7 @@
         </p:nvSpPr>
         <p:spPr>
           <a:xfrm>
-            <a:off x="4526280" y="3840480"/>
+            <a:off x="4572000" y="3840480"/>
             <a:ext cx="1325880" cy="0"/>
           </a:xfrm>
           <a:prstGeom prst="line">
@@ -2174,7 +2174,7 @@
         </p:nvSpPr>
         <p:spPr>
           <a:xfrm>
-            <a:off x="2688336" y="5705856"/>
+            <a:off x="2711196" y="5705856"/>
             <a:ext cx="1207008" cy="365760"/>
           </a:xfrm>
           <a:prstGeom prst="roundRect">
@@ -2187,7 +2187,7 @@
           </a:solidFill>
           <a:ln w="15875">
             <a:solidFill>
-              <a:srgbClr val="E69F00"/>
+              <a:srgbClr val="D55E00"/>
             </a:solidFill>
             <a:prstDash val="solid"/>
           </a:ln>
@@ -2239,7 +2239,7 @@
         </p:nvSpPr>
         <p:spPr>
           <a:xfrm>
-            <a:off x="2688336" y="6126480"/>
+            <a:off x="2711196" y="6126480"/>
             <a:ext cx="1207008" cy="365760"/>
           </a:xfrm>
           <a:prstGeom prst="roundRect">
@@ -2252,7 +2252,7 @@
           </a:solidFill>
           <a:ln w="15875">
             <a:solidFill>
-              <a:srgbClr val="E69F00"/>
+              <a:srgbClr val="D55E00"/>
             </a:solidFill>
             <a:prstDash val="solid"/>
           </a:ln>
@@ -2304,8 +2304,8 @@
         </p:nvSpPr>
         <p:spPr>
           <a:xfrm>
-            <a:off x="4617720" y="5705856"/>
-            <a:ext cx="1188720" cy="365760"/>
+            <a:off x="4663440" y="5705856"/>
+            <a:ext cx="1143000" cy="365760"/>
           </a:xfrm>
           <a:prstGeom prst="roundRect">
             <a:avLst>
@@ -2317,13 +2317,13 @@
           </a:solidFill>
           <a:ln w="15875">
             <a:solidFill>
-              <a:srgbClr val="E69F00"/>
-            </a:solidFill>
-            <a:prstDash val="solid"/>
-          </a:ln>
-        </p:spPr>
-        <p:txBody>
-          <a:bodyPr wrap="square" lIns="19050" tIns="0" rIns="19050" bIns="0" rtlCol="0" anchor="ctr"/>
+              <a:srgbClr val="009E73"/>
+            </a:solidFill>
+            <a:prstDash val="solid"/>
+          </a:ln>
+        </p:spPr>
+        <p:txBody>
+          <a:bodyPr wrap="square" lIns="0" tIns="0" rIns="0" bIns="0" rtlCol="0" anchor="ctr"/>
           <a:lstStyle/>
           <a:p>
             <a:pPr algn="ctr" indent="0" marL="0">
@@ -2369,8 +2369,8 @@
         </p:nvSpPr>
         <p:spPr>
           <a:xfrm>
-            <a:off x="5897880" y="5705856"/>
-            <a:ext cx="1188720" cy="365760"/>
+            <a:off x="5989320" y="5705856"/>
+            <a:ext cx="1143000" cy="365760"/>
           </a:xfrm>
           <a:prstGeom prst="roundRect">
             <a:avLst>
@@ -2382,13 +2382,13 @@
           </a:solidFill>
           <a:ln w="15875">
             <a:solidFill>
-              <a:srgbClr val="E69F00"/>
-            </a:solidFill>
-            <a:prstDash val="solid"/>
-          </a:ln>
-        </p:spPr>
-        <p:txBody>
-          <a:bodyPr wrap="square" lIns="19050" tIns="0" rIns="19050" bIns="0" rtlCol="0" anchor="ctr"/>
+              <a:srgbClr val="009E73"/>
+            </a:solidFill>
+            <a:prstDash val="solid"/>
+          </a:ln>
+        </p:spPr>
+        <p:txBody>
+          <a:bodyPr wrap="square" lIns="0" tIns="0" rIns="0" bIns="0" rtlCol="0" anchor="ctr"/>
           <a:lstStyle/>
           <a:p>
             <a:pPr algn="ctr" indent="0" marL="0">
@@ -2434,8 +2434,8 @@
         </p:nvSpPr>
         <p:spPr>
           <a:xfrm>
-            <a:off x="4617720" y="6126480"/>
-            <a:ext cx="1188720" cy="365760"/>
+            <a:off x="4663440" y="6126480"/>
+            <a:ext cx="1143000" cy="365760"/>
           </a:xfrm>
           <a:prstGeom prst="roundRect">
             <a:avLst>
@@ -2447,13 +2447,13 @@
           </a:solidFill>
           <a:ln w="15875">
             <a:solidFill>
-              <a:srgbClr val="E69F00"/>
-            </a:solidFill>
-            <a:prstDash val="solid"/>
-          </a:ln>
-        </p:spPr>
-        <p:txBody>
-          <a:bodyPr wrap="square" lIns="19050" tIns="0" rIns="19050" bIns="0" rtlCol="0" anchor="ctr"/>
+              <a:srgbClr val="009E73"/>
+            </a:solidFill>
+            <a:prstDash val="solid"/>
+          </a:ln>
+        </p:spPr>
+        <p:txBody>
+          <a:bodyPr wrap="square" lIns="0" tIns="0" rIns="0" bIns="0" rtlCol="0" anchor="ctr"/>
           <a:lstStyle/>
           <a:p>
             <a:pPr algn="ctr" indent="0" marL="0">
@@ -2499,8 +2499,8 @@
         </p:nvSpPr>
         <p:spPr>
           <a:xfrm>
-            <a:off x="5897880" y="6126480"/>
-            <a:ext cx="1188720" cy="365760"/>
+            <a:off x="5989320" y="6126480"/>
+            <a:ext cx="1143000" cy="365760"/>
           </a:xfrm>
           <a:prstGeom prst="roundRect">
             <a:avLst>
@@ -2512,13 +2512,13 @@
           </a:solidFill>
           <a:ln w="15875">
             <a:solidFill>
-              <a:srgbClr val="E69F00"/>
+              <a:srgbClr val="009E73"/>
             </a:solidFill>
             <a:prstDash val="dash"/>
           </a:ln>
         </p:spPr>
         <p:txBody>
-          <a:bodyPr wrap="square" lIns="19050" tIns="0" rIns="19050" bIns="0" rtlCol="0" anchor="ctr"/>
+          <a:bodyPr wrap="square" lIns="0" tIns="0" rIns="0" bIns="0" rtlCol="0" anchor="ctr"/>
           <a:lstStyle/>
           <a:p>
             <a:pPr algn="ctr" indent="0" marL="0">
@@ -2564,8 +2564,8 @@
         </p:nvSpPr>
         <p:spPr>
           <a:xfrm>
-            <a:off x="7178040" y="5916168"/>
-            <a:ext cx="1188720" cy="365760"/>
+            <a:off x="7223760" y="5916168"/>
+            <a:ext cx="1143000" cy="365760"/>
           </a:xfrm>
           <a:prstGeom prst="roundRect">
             <a:avLst>
@@ -2577,7 +2577,7 @@
           </a:solidFill>
           <a:ln w="15875">
             <a:solidFill>
-              <a:srgbClr val="E69F00"/>
+              <a:srgbClr val="44546A"/>
             </a:solidFill>
             <a:prstDash val="solid"/>
           </a:ln>
@@ -2630,7 +2630,7 @@
         <p:spPr>
           <a:xfrm>
             <a:off x="2057400" y="3575304"/>
-            <a:ext cx="2468880" cy="530352"/>
+            <a:ext cx="2514600" cy="530352"/>
           </a:xfrm>
           <a:prstGeom prst="roundRect">
             <a:avLst>
@@ -2695,7 +2695,7 @@
         <p:spPr>
           <a:xfrm>
             <a:off x="2057400" y="4197096"/>
-            <a:ext cx="1207008" cy="256032"/>
+            <a:ext cx="1147572" cy="256032"/>
           </a:xfrm>
           <a:prstGeom prst="roundRect">
             <a:avLst>
@@ -2713,7 +2713,7 @@
           </a:ln>
         </p:spPr>
         <p:txBody>
-          <a:bodyPr wrap="square" lIns="19050" tIns="0" rIns="19050" bIns="0" rtlCol="0" anchor="ctr"/>
+          <a:bodyPr wrap="square" lIns="0" tIns="0" rIns="0" bIns="0" rtlCol="0" anchor="ctr"/>
           <a:lstStyle/>
           <a:p>
             <a:pPr algn="ctr" indent="0" marL="0">
@@ -2742,8 +2742,8 @@
         </p:nvSpPr>
         <p:spPr>
           <a:xfrm>
-            <a:off x="3319272" y="4197096"/>
-            <a:ext cx="1207008" cy="256032"/>
+            <a:off x="3424428" y="4197096"/>
+            <a:ext cx="1147572" cy="256032"/>
           </a:xfrm>
           <a:prstGeom prst="roundRect">
             <a:avLst>
@@ -2761,7 +2761,7 @@
           </a:ln>
         </p:spPr>
         <p:txBody>
-          <a:bodyPr wrap="square" lIns="19050" tIns="0" rIns="19050" bIns="0" rtlCol="0" anchor="ctr"/>
+          <a:bodyPr wrap="square" lIns="0" tIns="0" rIns="0" bIns="0" rtlCol="0" anchor="ctr"/>
           <a:lstStyle/>
           <a:p>
             <a:pPr algn="ctr" indent="0" marL="0">
@@ -2791,7 +2791,7 @@
         <p:spPr>
           <a:xfrm>
             <a:off x="2057400" y="4517136"/>
-            <a:ext cx="1207008" cy="256032"/>
+            <a:ext cx="1147572" cy="256032"/>
           </a:xfrm>
           <a:prstGeom prst="roundRect">
             <a:avLst>
@@ -2809,7 +2809,7 @@
           </a:ln>
         </p:spPr>
         <p:txBody>
-          <a:bodyPr wrap="square" lIns="19050" tIns="0" rIns="19050" bIns="0" rtlCol="0" anchor="ctr"/>
+          <a:bodyPr wrap="square" lIns="0" tIns="0" rIns="0" bIns="0" rtlCol="0" anchor="ctr"/>
           <a:lstStyle/>
           <a:p>
             <a:pPr algn="ctr" indent="0" marL="0">
@@ -2838,8 +2838,8 @@
         </p:nvSpPr>
         <p:spPr>
           <a:xfrm>
-            <a:off x="3319272" y="4517136"/>
-            <a:ext cx="1207008" cy="256032"/>
+            <a:off x="3424428" y="4517136"/>
+            <a:ext cx="1147572" cy="256032"/>
           </a:xfrm>
           <a:prstGeom prst="roundRect">
             <a:avLst>
@@ -2857,7 +2857,7 @@
           </a:ln>
         </p:spPr>
         <p:txBody>
-          <a:bodyPr wrap="square" lIns="19050" tIns="0" rIns="19050" bIns="0" rtlCol="0" anchor="ctr"/>
+          <a:bodyPr wrap="square" lIns="0" tIns="0" rIns="0" bIns="0" rtlCol="0" anchor="ctr"/>
           <a:lstStyle/>
           <a:p>
             <a:pPr algn="ctr" indent="0" marL="0">
@@ -2887,7 +2887,7 @@
         <p:spPr>
           <a:xfrm>
             <a:off x="2057400" y="4837176"/>
-            <a:ext cx="1207008" cy="256032"/>
+            <a:ext cx="1147572" cy="256032"/>
           </a:xfrm>
           <a:prstGeom prst="roundRect">
             <a:avLst>
@@ -2905,7 +2905,7 @@
           </a:ln>
         </p:spPr>
         <p:txBody>
-          <a:bodyPr wrap="square" lIns="19050" tIns="0" rIns="19050" bIns="0" rtlCol="0" anchor="ctr"/>
+          <a:bodyPr wrap="square" lIns="0" tIns="0" rIns="0" bIns="0" rtlCol="0" anchor="ctr"/>
           <a:lstStyle/>
           <a:p>
             <a:pPr algn="ctr" indent="0" marL="0">
@@ -2934,8 +2934,8 @@
         </p:nvSpPr>
         <p:spPr>
           <a:xfrm>
-            <a:off x="3319272" y="4837176"/>
-            <a:ext cx="1207008" cy="256032"/>
+            <a:off x="3424428" y="4837176"/>
+            <a:ext cx="1147572" cy="256032"/>
           </a:xfrm>
           <a:prstGeom prst="roundRect">
             <a:avLst>
@@ -2953,7 +2953,7 @@
           </a:ln>
         </p:spPr>
         <p:txBody>
-          <a:bodyPr wrap="square" lIns="19050" tIns="0" rIns="19050" bIns="0" rtlCol="0" anchor="ctr"/>
+          <a:bodyPr wrap="square" lIns="0" tIns="0" rIns="0" bIns="0" rtlCol="0" anchor="ctr"/>
           <a:lstStyle/>
           <a:p>
             <a:pPr algn="ctr" indent="0" marL="0">
@@ -2983,7 +2983,7 @@
         <p:spPr>
           <a:xfrm>
             <a:off x="2057400" y="5157216"/>
-            <a:ext cx="1207008" cy="256032"/>
+            <a:ext cx="1147572" cy="256032"/>
           </a:xfrm>
           <a:prstGeom prst="roundRect">
             <a:avLst>
@@ -3001,7 +3001,7 @@
           </a:ln>
         </p:spPr>
         <p:txBody>
-          <a:bodyPr wrap="square" lIns="19050" tIns="0" rIns="19050" bIns="0" rtlCol="0" anchor="ctr"/>
+          <a:bodyPr wrap="square" lIns="0" tIns="0" rIns="0" bIns="0" rtlCol="0" anchor="ctr"/>
           <a:lstStyle/>
           <a:p>
             <a:pPr algn="ctr" indent="0" marL="0">
@@ -3030,8 +3030,8 @@
         </p:nvSpPr>
         <p:spPr>
           <a:xfrm>
-            <a:off x="3319272" y="5157216"/>
-            <a:ext cx="1207008" cy="256032"/>
+            <a:off x="3424428" y="5157216"/>
+            <a:ext cx="1147572" cy="256032"/>
           </a:xfrm>
           <a:prstGeom prst="roundRect">
             <a:avLst>
@@ -3049,7 +3049,7 @@
           </a:ln>
         </p:spPr>
         <p:txBody>
-          <a:bodyPr wrap="square" lIns="19050" tIns="0" rIns="19050" bIns="0" rtlCol="0" anchor="ctr"/>
+          <a:bodyPr wrap="square" lIns="0" tIns="0" rIns="0" bIns="0" rtlCol="0" anchor="ctr"/>
           <a:lstStyle/>
           <a:p>
             <a:pPr algn="ctr" indent="0" marL="0">
@@ -3078,7 +3078,7 @@
         </p:nvSpPr>
         <p:spPr>
           <a:xfrm>
-            <a:off x="4617720" y="3913632"/>
+            <a:off x="4663440" y="3913632"/>
             <a:ext cx="1161288" cy="685800"/>
           </a:xfrm>
           <a:prstGeom prst="rect">
@@ -3118,7 +3118,7 @@
         <p:spPr>
           <a:xfrm>
             <a:off x="2057400" y="1517904"/>
-            <a:ext cx="2468880" cy="457200"/>
+            <a:ext cx="2514600" cy="457200"/>
           </a:xfrm>
           <a:prstGeom prst="roundRect">
             <a:avLst>
@@ -3182,7 +3182,7 @@
         </p:nvSpPr>
         <p:spPr>
           <a:xfrm>
-            <a:off x="4617720" y="1517904"/>
+            <a:off x="4663440" y="1517904"/>
             <a:ext cx="2468880" cy="749808"/>
           </a:xfrm>
           <a:prstGeom prst="roundRect">
@@ -3247,8 +3247,8 @@
         </p:nvSpPr>
         <p:spPr>
           <a:xfrm>
-            <a:off x="4617720" y="2340864"/>
-            <a:ext cx="1188720" cy="347472"/>
+            <a:off x="4663440" y="2340864"/>
+            <a:ext cx="1124712" cy="347472"/>
           </a:xfrm>
           <a:prstGeom prst="roundRect">
             <a:avLst>
@@ -3266,7 +3266,7 @@
           </a:ln>
         </p:spPr>
         <p:txBody>
-          <a:bodyPr wrap="square" lIns="19050" tIns="0" rIns="19050" bIns="0" rtlCol="0" anchor="ctr"/>
+          <a:bodyPr wrap="square" lIns="0" tIns="0" rIns="0" bIns="0" rtlCol="0" anchor="ctr"/>
           <a:lstStyle/>
           <a:p>
             <a:pPr algn="ctr" indent="0" marL="0">
@@ -3290,7 +3290,7 @@
               <a:buNone/>
             </a:pPr>
             <a:r>
-              <a:rPr lang="en-US" sz="900" i="1" dirty="0">
+              <a:rPr lang="en-US" sz="850" i="1" dirty="0">
                 <a:solidFill>
                   <a:srgbClr val="5B6770"/>
                 </a:solidFill>
@@ -3312,8 +3312,8 @@
         </p:nvSpPr>
         <p:spPr>
           <a:xfrm>
-            <a:off x="5897880" y="2340864"/>
-            <a:ext cx="1188720" cy="347472"/>
+            <a:off x="6007608" y="2340864"/>
+            <a:ext cx="1124712" cy="347472"/>
           </a:xfrm>
           <a:prstGeom prst="roundRect">
             <a:avLst>
@@ -3331,7 +3331,7 @@
           </a:ln>
         </p:spPr>
         <p:txBody>
-          <a:bodyPr wrap="square" lIns="19050" tIns="0" rIns="19050" bIns="0" rtlCol="0" anchor="ctr"/>
+          <a:bodyPr wrap="square" lIns="0" tIns="0" rIns="0" bIns="0" rtlCol="0" anchor="ctr"/>
           <a:lstStyle/>
           <a:p>
             <a:pPr algn="ctr" indent="0" marL="0">
@@ -3377,8 +3377,8 @@
         </p:nvSpPr>
         <p:spPr>
           <a:xfrm>
-            <a:off x="4617720" y="2743200"/>
-            <a:ext cx="1188720" cy="347472"/>
+            <a:off x="4663440" y="2743200"/>
+            <a:ext cx="1124712" cy="347472"/>
           </a:xfrm>
           <a:prstGeom prst="roundRect">
             <a:avLst>
@@ -3396,7 +3396,7 @@
           </a:ln>
         </p:spPr>
         <p:txBody>
-          <a:bodyPr wrap="square" lIns="19050" tIns="0" rIns="19050" bIns="0" rtlCol="0" anchor="ctr"/>
+          <a:bodyPr wrap="square" lIns="0" tIns="0" rIns="0" bIns="0" rtlCol="0" anchor="ctr"/>
           <a:lstStyle/>
           <a:p>
             <a:pPr algn="ctr" indent="0" marL="0">
@@ -3442,8 +3442,8 @@
         </p:nvSpPr>
         <p:spPr>
           <a:xfrm>
-            <a:off x="5897880" y="2743200"/>
-            <a:ext cx="1188720" cy="347472"/>
+            <a:off x="6007608" y="2743200"/>
+            <a:ext cx="1124712" cy="347472"/>
           </a:xfrm>
           <a:prstGeom prst="roundRect">
             <a:avLst>
@@ -3461,7 +3461,7 @@
           </a:ln>
         </p:spPr>
         <p:txBody>
-          <a:bodyPr wrap="square" lIns="19050" tIns="0" rIns="19050" bIns="0" rtlCol="0" anchor="ctr"/>
+          <a:bodyPr wrap="square" lIns="0" tIns="0" rIns="0" bIns="0" rtlCol="0" anchor="ctr"/>
           <a:lstStyle/>
           <a:p>
             <a:pPr algn="ctr" indent="0" marL="0">
@@ -3507,8 +3507,8 @@
         </p:nvSpPr>
         <p:spPr>
           <a:xfrm>
-            <a:off x="7178040" y="1517904"/>
-            <a:ext cx="1188720" cy="749808"/>
+            <a:off x="7223760" y="1517904"/>
+            <a:ext cx="1143000" cy="749808"/>
           </a:xfrm>
           <a:prstGeom prst="roundRect">
             <a:avLst>

</xml_diff>

<commit_message>
Fig. 5: fold in OR's PowerPoint edits (companion proposals, path-coloured outlines, EMBER on two lines)
Moves Multi-subject next to the planned multi-subject BEP with a dashed
'planned companion proposals' link, outlines DANDI layout and Psych-DS in
their path colours, shortens the NWB-in-BIDS note, and relabels the data
row. Colours snapped to the palette (009E73, 44546A); PNG re-exported with
a white background.

Co-Authored-By: Claude Opus 5.5 <noreply@anthropic.com>
</commit_message>
<xml_diff>
--- a/figures/fig5_bbqs_stack/fig5_bbqs_stack_design.pptx
+++ b/figures/fig5_bbqs_stack/fig5_bbqs_stack_design.pptx
@@ -505,7 +505,7 @@
               <a:t>Fig. 5 design draft v4 (spec: draft/12_figures_tables.md). Sources: Table 3, BBQS standards guideline, Standards4BBQS forum slides (Oct 2026).
 Stack: rows 1 data formats, 2 file organization, 3 dataset organization, 5 data archives. Ontologies &amp; terminologies (4) and schema languages (6) are side panels next to rows 2-3, which they both serve.
 Paths: NWB (orange) runs from the data through NWB to EMBER; BIDS (green) and Psych-DS (slate) run from the data to EMBER. A green arrow from NWB to the BIDS path shows that BIDS can include NWB files.
-NWB extensions are labelled by purpose: left, proposals for the core (pose estimation: ndx-pose; multi-subject data: ndx-multisubjects; microscopy: NWBEP004; HED annotation: ndx-hed); right, community extensions (fiber photometry, wearable devices, structured behavior, ethogram).
+NWB extensions and enhancement proposals are labelled by purpose: pose estimation (ndx-pose, NWBEP in preparation), structured behavior (ndx-structured-behavior), microscopy (NWBEP004), HED annotation (ndx-hed), fiber photometry, wearable devices, multi-subject (ndx-multisubjects, NWBEP in preparation), ethogram. A dashed green line joins Multi-subject to the planned multi-subject BEP (companion proposals). Standards boxes are outlined in the colour of their path (DANDI layout orange, Psych-DS slate).
 Panel 4: each terminology is its own box; arrows show the terminologies Neuro Termsets draws on (Cell Ontology is not yet a term set).
 Status: solid = recommended for BBQS today; dashed = extension or proposal in progress; grey dashed = needs a standard.
 BBQS data: each data type appears once; thin lines join it to every standard it can use (Table 3).</a:t>
@@ -2146,8 +2146,11 @@
                 <a:ea typeface="Arial" pitchFamily="34" charset="-122"/>
                 <a:cs typeface="Arial" pitchFamily="34" charset="-120"/>
               </a:rPr>
-              <a:t>EMBER   </a:t>
-            </a:r>
+              <a:t>EMBER</a:t>
+            </a:r>
+            <a:endParaRPr lang="en-US" sz="1000" dirty="0"/>
+          </a:p>
+          <a:p>
             <a:pPr algn="ctr" indent="0" marL="0">
               <a:buNone/>
             </a:pPr>
@@ -2784,7 +2787,7 @@
       </p:sp>
       <p:sp>
         <p:nvSpPr>
-          <p:cNvPr id="44" name="NWB extension: Multi-subject data"/>
+          <p:cNvPr id="44" name="NWB extension: Structured behavior"/>
           <p:cNvSpPr/>
           <p:nvPr/>
         </p:nvSpPr>
@@ -2824,7 +2827,7 @@
                 <a:ea typeface="Arial" pitchFamily="34" charset="-122"/>
                 <a:cs typeface="Arial" pitchFamily="34" charset="-120"/>
               </a:rPr>
-              <a:t>Multi-subject data</a:t>
+              <a:t>Structured behavior</a:t>
             </a:r>
             <a:endParaRPr lang="en-US" sz="1000" dirty="0"/>
           </a:p>
@@ -2928,7 +2931,7 @@
       </p:sp>
       <p:sp>
         <p:nvSpPr>
-          <p:cNvPr id="47" name="NWB extension: Structured behavior"/>
+          <p:cNvPr id="47" name="NWB extension: Multi-subject"/>
           <p:cNvSpPr/>
           <p:nvPr/>
         </p:nvSpPr>
@@ -2968,7 +2971,7 @@
                 <a:ea typeface="Arial" pitchFamily="34" charset="-122"/>
                 <a:cs typeface="Arial" pitchFamily="34" charset="-120"/>
               </a:rPr>
-              <a:t>Structured behavior</a:t>
+              <a:t>Multi-subject</a:t>
             </a:r>
             <a:endParaRPr lang="en-US" sz="1000" dirty="0"/>
           </a:p>
@@ -3078,8 +3081,8 @@
         </p:nvSpPr>
         <p:spPr>
           <a:xfrm>
-            <a:off x="4663440" y="3913632"/>
-            <a:ext cx="1161288" cy="685800"/>
+            <a:off x="4645152" y="3867912"/>
+            <a:ext cx="1197864" cy="310896"/>
           </a:xfrm>
           <a:prstGeom prst="rect">
             <a:avLst/>
@@ -3097,13 +3100,13 @@
             <a:r>
               <a:rPr lang="en-US" sz="950" i="1" dirty="0">
                 <a:solidFill>
-                  <a:srgbClr val="5B6770"/>
-                </a:solidFill>
-                <a:latin typeface="Arial" pitchFamily="34" charset="0"/>
-                <a:ea typeface="Arial" pitchFamily="34" charset="-122"/>
-                <a:cs typeface="Arial" pitchFamily="34" charset="-120"/>
-              </a:rPr>
-              <a:t>BIDS can include NWB files (iEEG; microelectrode ephys via BEP032)</a:t>
+                  <a:srgbClr val="009E73"/>
+                </a:solidFill>
+                <a:latin typeface="Arial" pitchFamily="34" charset="0"/>
+                <a:ea typeface="Arial" pitchFamily="34" charset="-122"/>
+                <a:cs typeface="Arial" pitchFamily="34" charset="-120"/>
+              </a:rPr>
+              <a:t>BIDS can contain NWB files (BEP032)</a:t>
             </a:r>
             <a:endParaRPr lang="en-US" sz="950" dirty="0"/>
           </a:p>
@@ -3130,7 +3133,7 @@
           </a:solidFill>
           <a:ln w="15875">
             <a:solidFill>
-              <a:srgbClr val="009E73"/>
+              <a:srgbClr val="D55E00"/>
             </a:solidFill>
             <a:prstDash val="solid"/>
           </a:ln>
@@ -3520,53 +3523,138 @@
           </a:solidFill>
           <a:ln w="15875">
             <a:solidFill>
+              <a:srgbClr val="44546A"/>
+            </a:solidFill>
+            <a:prstDash val="solid"/>
+          </a:ln>
+        </p:spPr>
+        <p:txBody>
+          <a:bodyPr wrap="square" lIns="19050" tIns="0" rIns="19050" bIns="0" rtlCol="0" anchor="ctr"/>
+          <a:lstStyle/>
+          <a:p>
+            <a:pPr algn="ctr" indent="0" marL="0">
+              <a:buNone/>
+            </a:pPr>
+            <a:r>
+              <a:rPr lang="en-US" sz="1200" b="1" dirty="0">
+                <a:solidFill>
+                  <a:srgbClr val="1F2933"/>
+                </a:solidFill>
+                <a:latin typeface="Arial" pitchFamily="34" charset="0"/>
+                <a:ea typeface="Arial" pitchFamily="34" charset="-122"/>
+                <a:cs typeface="Arial" pitchFamily="34" charset="-120"/>
+              </a:rPr>
+              <a:t>Psych-DS</a:t>
+            </a:r>
+            <a:endParaRPr lang="en-US" sz="1000" dirty="0"/>
+          </a:p>
+          <a:p>
+            <a:pPr algn="ctr" indent="0" marL="0">
+              <a:buNone/>
+            </a:pPr>
+            <a:r>
+              <a:rPr lang="en-US" sz="950" i="1" dirty="0">
+                <a:solidFill>
+                  <a:srgbClr val="5B6770"/>
+                </a:solidFill>
+                <a:latin typeface="Arial" pitchFamily="34" charset="0"/>
+                <a:ea typeface="Arial" pitchFamily="34" charset="-122"/>
+                <a:cs typeface="Arial" pitchFamily="34" charset="-120"/>
+              </a:rPr>
+              <a:t>every variable defined in JSON</a:t>
+            </a:r>
+            <a:endParaRPr lang="en-US" sz="1000" dirty="0"/>
+          </a:p>
+        </p:txBody>
+      </p:sp>
+      <p:sp>
+        <p:nvSpPr>
+          <p:cNvPr id="58" name="Companion proposals (horizontal)"/>
+          <p:cNvSpPr/>
+          <p:nvPr/>
+        </p:nvSpPr>
+        <p:spPr>
+          <a:xfrm>
+            <a:off x="4572000" y="4965192"/>
+            <a:ext cx="1997964" cy="0"/>
+          </a:xfrm>
+          <a:prstGeom prst="line">
+            <a:avLst/>
+          </a:prstGeom>
+          <a:noFill/>
+          <a:ln w="12700">
+            <a:solidFill>
               <a:srgbClr val="009E73"/>
             </a:solidFill>
-            <a:prstDash val="solid"/>
-          </a:ln>
-        </p:spPr>
-        <p:txBody>
-          <a:bodyPr wrap="square" lIns="19050" tIns="0" rIns="19050" bIns="0" rtlCol="0" anchor="ctr"/>
-          <a:lstStyle/>
-          <a:p>
-            <a:pPr algn="ctr" indent="0" marL="0">
-              <a:buNone/>
-            </a:pPr>
-            <a:r>
-              <a:rPr lang="en-US" sz="1200" b="1" dirty="0">
-                <a:solidFill>
-                  <a:srgbClr val="1F2933"/>
-                </a:solidFill>
-                <a:latin typeface="Arial" pitchFamily="34" charset="0"/>
-                <a:ea typeface="Arial" pitchFamily="34" charset="-122"/>
-                <a:cs typeface="Arial" pitchFamily="34" charset="-120"/>
-              </a:rPr>
-              <a:t>Psych-DS</a:t>
-            </a:r>
-            <a:endParaRPr lang="en-US" sz="1000" dirty="0"/>
-          </a:p>
-          <a:p>
-            <a:pPr algn="ctr" indent="0" marL="0">
+            <a:prstDash val="dash"/>
+          </a:ln>
+        </p:spPr>
+      </p:sp>
+      <p:sp>
+        <p:nvSpPr>
+          <p:cNvPr id="59" name="Companion proposals (vertical)"/>
+          <p:cNvSpPr/>
+          <p:nvPr/>
+        </p:nvSpPr>
+        <p:spPr>
+          <a:xfrm>
+            <a:off x="6569964" y="3090672"/>
+            <a:ext cx="0" cy="1874520"/>
+          </a:xfrm>
+          <a:prstGeom prst="line">
+            <a:avLst/>
+          </a:prstGeom>
+          <a:noFill/>
+          <a:ln w="12700">
+            <a:solidFill>
+              <a:srgbClr val="009E73"/>
+            </a:solidFill>
+            <a:prstDash val="dash"/>
+          </a:ln>
+        </p:spPr>
+      </p:sp>
+      <p:sp>
+        <p:nvSpPr>
+          <p:cNvPr id="60" name="Text 58"/>
+          <p:cNvSpPr txBox="1"/>
+          <p:nvPr/>
+        </p:nvSpPr>
+        <p:spPr>
+          <a:xfrm>
+            <a:off x="4626864" y="5001768"/>
+            <a:ext cx="1097280" cy="310896"/>
+          </a:xfrm>
+          <a:prstGeom prst="rect">
+            <a:avLst/>
+          </a:prstGeom>
+          <a:noFill/>
+          <a:ln/>
+        </p:spPr>
+        <p:txBody>
+          <a:bodyPr wrap="square" lIns="0" tIns="0" rIns="0" bIns="0" rtlCol="0" anchor="t"/>
+          <a:lstStyle/>
+          <a:p>
+            <a:pPr algn="l" indent="0" marL="0">
               <a:buNone/>
             </a:pPr>
             <a:r>
               <a:rPr lang="en-US" sz="950" i="1" dirty="0">
                 <a:solidFill>
-                  <a:srgbClr val="5B6770"/>
-                </a:solidFill>
-                <a:latin typeface="Arial" pitchFamily="34" charset="0"/>
-                <a:ea typeface="Arial" pitchFamily="34" charset="-122"/>
-                <a:cs typeface="Arial" pitchFamily="34" charset="-120"/>
-              </a:rPr>
-              <a:t>every variable defined in JSON</a:t>
-            </a:r>
-            <a:endParaRPr lang="en-US" sz="1000" dirty="0"/>
-          </a:p>
-        </p:txBody>
-      </p:sp>
-      <p:sp>
-        <p:nvSpPr>
-          <p:cNvPr id="58" name="HED"/>
+                  <a:srgbClr val="009E73"/>
+                </a:solidFill>
+                <a:latin typeface="Arial" pitchFamily="34" charset="0"/>
+                <a:ea typeface="Arial" pitchFamily="34" charset="-122"/>
+                <a:cs typeface="Arial" pitchFamily="34" charset="-120"/>
+              </a:rPr>
+              <a:t>Planned companion proposals</a:t>
+            </a:r>
+            <a:endParaRPr lang="en-US" sz="950" dirty="0"/>
+          </a:p>
+        </p:txBody>
+      </p:sp>
+      <p:sp>
+        <p:nvSpPr>
+          <p:cNvPr id="61" name="HED"/>
           <p:cNvSpPr/>
           <p:nvPr/>
         </p:nvSpPr>
@@ -3631,7 +3719,7 @@
       </p:sp>
       <p:sp>
         <p:nvSpPr>
-          <p:cNvPr id="59" name="Neuro Termsets"/>
+          <p:cNvPr id="62" name="Neuro Termsets"/>
           <p:cNvSpPr/>
           <p:nvPr/>
         </p:nvSpPr>
@@ -3696,7 +3784,7 @@
       </p:sp>
       <p:sp>
         <p:nvSpPr>
-          <p:cNvPr id="60" name="Terminology: NCBI Taxonomy"/>
+          <p:cNvPr id="63" name="Terminology: NCBI Taxonomy"/>
           <p:cNvSpPr/>
           <p:nvPr/>
         </p:nvSpPr>
@@ -3758,7 +3846,7 @@
       </p:sp>
       <p:sp>
         <p:nvSpPr>
-          <p:cNvPr id="61" name="Neuro Termsets uses NCBI Taxonomy"/>
+          <p:cNvPr id="64" name="Neuro Termsets uses NCBI Taxonomy"/>
           <p:cNvSpPr/>
           <p:nvPr/>
         </p:nvSpPr>
@@ -3782,7 +3870,7 @@
       </p:sp>
       <p:sp>
         <p:nvSpPr>
-          <p:cNvPr id="62" name="Terminology: UBERON"/>
+          <p:cNvPr id="65" name="Terminology: UBERON"/>
           <p:cNvSpPr/>
           <p:nvPr/>
         </p:nvSpPr>
@@ -3844,7 +3932,7 @@
       </p:sp>
       <p:sp>
         <p:nvSpPr>
-          <p:cNvPr id="63" name="Neuro Termsets uses UBERON"/>
+          <p:cNvPr id="66" name="Neuro Termsets uses UBERON"/>
           <p:cNvSpPr/>
           <p:nvPr/>
         </p:nvSpPr>
@@ -3868,7 +3956,7 @@
       </p:sp>
       <p:sp>
         <p:nvSpPr>
-          <p:cNvPr id="64" name="Terminology: Allen atlases"/>
+          <p:cNvPr id="67" name="Terminology: Allen atlases"/>
           <p:cNvSpPr/>
           <p:nvPr/>
         </p:nvSpPr>
@@ -3930,7 +4018,7 @@
       </p:sp>
       <p:sp>
         <p:nvSpPr>
-          <p:cNvPr id="65" name="Neuro Termsets uses Allen atlases"/>
+          <p:cNvPr id="68" name="Neuro Termsets uses Allen atlases"/>
           <p:cNvSpPr/>
           <p:nvPr/>
         </p:nvSpPr>
@@ -3954,7 +4042,7 @@
       </p:sp>
       <p:sp>
         <p:nvSpPr>
-          <p:cNvPr id="66" name="Terminology: RRID"/>
+          <p:cNvPr id="69" name="Terminology: RRID"/>
           <p:cNvSpPr/>
           <p:nvPr/>
         </p:nvSpPr>
@@ -4016,7 +4104,7 @@
       </p:sp>
       <p:sp>
         <p:nvSpPr>
-          <p:cNvPr id="67" name="Neuro Termsets uses RRID"/>
+          <p:cNvPr id="70" name="Neuro Termsets uses RRID"/>
           <p:cNvSpPr/>
           <p:nvPr/>
         </p:nvSpPr>
@@ -4040,7 +4128,7 @@
       </p:sp>
       <p:sp>
         <p:nvSpPr>
-          <p:cNvPr id="68" name="Terminology: ORCID · ROR"/>
+          <p:cNvPr id="71" name="Terminology: ORCID · ROR"/>
           <p:cNvSpPr/>
           <p:nvPr/>
         </p:nvSpPr>
@@ -4102,7 +4190,7 @@
       </p:sp>
       <p:sp>
         <p:nvSpPr>
-          <p:cNvPr id="69" name="Neuro Termsets uses ORCID · ROR"/>
+          <p:cNvPr id="72" name="Neuro Termsets uses ORCID · ROR"/>
           <p:cNvSpPr/>
           <p:nvPr/>
         </p:nvSpPr>
@@ -4126,7 +4214,7 @@
       </p:sp>
       <p:sp>
         <p:nvSpPr>
-          <p:cNvPr id="70" name="Terminology: Cell Ontology"/>
+          <p:cNvPr id="73" name="Terminology: Cell Ontology"/>
           <p:cNvSpPr/>
           <p:nvPr/>
         </p:nvSpPr>
@@ -4188,7 +4276,7 @@
       </p:sp>
       <p:sp>
         <p:nvSpPr>
-          <p:cNvPr id="71" name="Neuro Termsets references"/>
+          <p:cNvPr id="74" name="Neuro Termsets references"/>
           <p:cNvSpPr/>
           <p:nvPr/>
         </p:nvSpPr>
@@ -4211,7 +4299,7 @@
       </p:sp>
       <p:sp>
         <p:nvSpPr>
-          <p:cNvPr id="72" name="Behavior labels"/>
+          <p:cNvPr id="75" name="Behavior labels"/>
           <p:cNvSpPr/>
           <p:nvPr/>
         </p:nvSpPr>
@@ -4278,7 +4366,7 @@
       </p:sp>
       <p:sp>
         <p:nvSpPr>
-          <p:cNvPr id="73" name="HDMF"/>
+          <p:cNvPr id="76" name="HDMF"/>
           <p:cNvSpPr/>
           <p:nvPr/>
         </p:nvSpPr>
@@ -4343,7 +4431,7 @@
       </p:sp>
       <p:sp>
         <p:nvSpPr>
-          <p:cNvPr id="74" name="BIDS schema"/>
+          <p:cNvPr id="77" name="BIDS schema"/>
           <p:cNvSpPr/>
           <p:nvPr/>
         </p:nvSpPr>
@@ -4408,7 +4496,7 @@
       </p:sp>
       <p:sp>
         <p:nvSpPr>
-          <p:cNvPr id="75" name="LinkML"/>
+          <p:cNvPr id="78" name="LinkML"/>
           <p:cNvSpPr/>
           <p:nvPr/>
         </p:nvSpPr>
@@ -4473,7 +4561,7 @@
       </p:sp>
       <p:sp>
         <p:nvSpPr>
-          <p:cNvPr id="76" name="Text 74"/>
+          <p:cNvPr id="79" name="Text 77"/>
           <p:cNvSpPr txBox="1"/>
           <p:nvPr/>
         </p:nvSpPr>
@@ -4504,32 +4592,15 @@
                 <a:ea typeface="Arial" pitchFamily="34" charset="-122"/>
                 <a:cs typeface="Arial" pitchFamily="34" charset="-120"/>
               </a:rPr>
-              <a:t>BBQS data</a:t>
+              <a:t>BBQS data types:</a:t>
             </a:r>
             <a:endParaRPr lang="en-US" sz="1150" dirty="0"/>
           </a:p>
-          <a:p>
-            <a:pPr indent="0" marL="0">
-              <a:buNone/>
-            </a:pPr>
-            <a:r>
-              <a:rPr lang="en-US" sz="1000" i="1" dirty="0">
-                <a:solidFill>
-                  <a:srgbClr val="5B6770"/>
-                </a:solidFill>
-                <a:latin typeface="Arial" pitchFamily="34" charset="0"/>
-                <a:ea typeface="Arial" pitchFamily="34" charset="-122"/>
-                <a:cs typeface="Arial" pitchFamily="34" charset="-120"/>
-              </a:rPr>
-              <a:t>Lines show the standards each data type can use (Table 3)</a:t>
-            </a:r>
-            <a:endParaRPr lang="en-US" sz="1150" dirty="0"/>
-          </a:p>
-        </p:txBody>
-      </p:sp>
-      <p:sp>
-        <p:nvSpPr>
-          <p:cNvPr id="77" name="Data: Electro- and optical physiology · stimulation"/>
+        </p:txBody>
+      </p:sp>
+      <p:sp>
+        <p:nvSpPr>
+          <p:cNvPr id="80" name="Data: Electro- and optical physiology · stimulation"/>
           <p:cNvSpPr/>
           <p:nvPr/>
         </p:nvSpPr>
@@ -4578,7 +4649,7 @@
       </p:sp>
       <p:sp>
         <p:nvSpPr>
-          <p:cNvPr id="78" name="Data: Video · audio · pose · eye tracking · task events"/>
+          <p:cNvPr id="81" name="Data: Video · audio · pose · eye tracking · task events"/>
           <p:cNvSpPr/>
           <p:nvPr/>
         </p:nvSpPr>
@@ -4627,7 +4698,7 @@
       </p:sp>
       <p:sp>
         <p:nvSpPr>
-          <p:cNvPr id="79" name="Data: EEG · MEG · iEEG"/>
+          <p:cNvPr id="82" name="Data: EEG · MEG · iEEG"/>
           <p:cNvSpPr/>
           <p:nvPr/>
         </p:nvSpPr>
@@ -4676,7 +4747,7 @@
       </p:sp>
       <p:sp>
         <p:nvSpPr>
-          <p:cNvPr id="80" name="Data: MRI · fMRI · PET"/>
+          <p:cNvPr id="83" name="Data: MRI · fMRI · PET"/>
           <p:cNvSpPr/>
           <p:nvPr/>
         </p:nvSpPr>
@@ -4725,7 +4796,7 @@
       </p:sp>
       <p:sp>
         <p:nvSpPr>
-          <p:cNvPr id="81" name="Data: Wearables"/>
+          <p:cNvPr id="84" name="Data: Wearables"/>
           <p:cNvSpPr/>
           <p:nvPr/>
         </p:nvSpPr>
@@ -4774,7 +4845,7 @@
       </p:sp>
       <p:sp>
         <p:nvSpPr>
-          <p:cNvPr id="82" name="Data: Questionnaires surveys"/>
+          <p:cNvPr id="85" name="Data: Questionnaires surveys"/>
           <p:cNvSpPr/>
           <p:nvPr/>
         </p:nvSpPr>
@@ -4840,7 +4911,7 @@
       </p:sp>
       <p:sp>
         <p:nvSpPr>
-          <p:cNvPr id="83" name="Bus A"/>
+          <p:cNvPr id="86" name="Bus A"/>
           <p:cNvSpPr/>
           <p:nvPr/>
         </p:nvSpPr>
@@ -4863,7 +4934,7 @@
       </p:sp>
       <p:sp>
         <p:nvSpPr>
-          <p:cNvPr id="84" name="Bus B"/>
+          <p:cNvPr id="87" name="Bus B"/>
           <p:cNvSpPr/>
           <p:nvPr/>
         </p:nvSpPr>
@@ -4886,7 +4957,7 @@
       </p:sp>
       <p:sp>
         <p:nvSpPr>
-          <p:cNvPr id="85" name="Bus C"/>
+          <p:cNvPr id="88" name="Bus C"/>
           <p:cNvSpPr/>
           <p:nvPr/>
         </p:nvSpPr>
@@ -4909,7 +4980,7 @@
       </p:sp>
       <p:sp>
         <p:nvSpPr>
-          <p:cNvPr id="86" name="Feed A"/>
+          <p:cNvPr id="89" name="Feed A"/>
           <p:cNvSpPr/>
           <p:nvPr/>
         </p:nvSpPr>
@@ -4932,7 +5003,7 @@
       </p:sp>
       <p:sp>
         <p:nvSpPr>
-          <p:cNvPr id="87" name="Join A"/>
+          <p:cNvPr id="90" name="Join A"/>
           <p:cNvSpPr/>
           <p:nvPr/>
         </p:nvSpPr>
@@ -4957,7 +5028,7 @@
       </p:sp>
       <p:sp>
         <p:nvSpPr>
-          <p:cNvPr id="88" name="Feed A"/>
+          <p:cNvPr id="91" name="Feed A"/>
           <p:cNvSpPr/>
           <p:nvPr/>
         </p:nvSpPr>
@@ -4980,7 +5051,7 @@
       </p:sp>
       <p:sp>
         <p:nvSpPr>
-          <p:cNvPr id="89" name="Join A"/>
+          <p:cNvPr id="92" name="Join A"/>
           <p:cNvSpPr/>
           <p:nvPr/>
         </p:nvSpPr>
@@ -5005,7 +5076,7 @@
       </p:sp>
       <p:sp>
         <p:nvSpPr>
-          <p:cNvPr id="90" name="Feed B"/>
+          <p:cNvPr id="93" name="Feed B"/>
           <p:cNvSpPr/>
           <p:nvPr/>
         </p:nvSpPr>
@@ -5028,7 +5099,7 @@
       </p:sp>
       <p:sp>
         <p:nvSpPr>
-          <p:cNvPr id="91" name="Join B"/>
+          <p:cNvPr id="94" name="Join B"/>
           <p:cNvSpPr/>
           <p:nvPr/>
         </p:nvSpPr>
@@ -5053,7 +5124,7 @@
       </p:sp>
       <p:sp>
         <p:nvSpPr>
-          <p:cNvPr id="92" name="Feed A"/>
+          <p:cNvPr id="95" name="Feed A"/>
           <p:cNvSpPr/>
           <p:nvPr/>
         </p:nvSpPr>
@@ -5076,7 +5147,7 @@
       </p:sp>
       <p:sp>
         <p:nvSpPr>
-          <p:cNvPr id="93" name="Join A"/>
+          <p:cNvPr id="96" name="Join A"/>
           <p:cNvSpPr/>
           <p:nvPr/>
         </p:nvSpPr>
@@ -5101,7 +5172,7 @@
       </p:sp>
       <p:sp>
         <p:nvSpPr>
-          <p:cNvPr id="94" name="Feed B"/>
+          <p:cNvPr id="97" name="Feed B"/>
           <p:cNvSpPr/>
           <p:nvPr/>
         </p:nvSpPr>
@@ -5124,7 +5195,7 @@
       </p:sp>
       <p:sp>
         <p:nvSpPr>
-          <p:cNvPr id="95" name="Join B"/>
+          <p:cNvPr id="98" name="Join B"/>
           <p:cNvSpPr/>
           <p:nvPr/>
         </p:nvSpPr>
@@ -5149,7 +5220,7 @@
       </p:sp>
       <p:sp>
         <p:nvSpPr>
-          <p:cNvPr id="96" name="Feed B"/>
+          <p:cNvPr id="99" name="Feed B"/>
           <p:cNvSpPr/>
           <p:nvPr/>
         </p:nvSpPr>
@@ -5172,7 +5243,7 @@
       </p:sp>
       <p:sp>
         <p:nvSpPr>
-          <p:cNvPr id="97" name="Join B"/>
+          <p:cNvPr id="100" name="Join B"/>
           <p:cNvSpPr/>
           <p:nvPr/>
         </p:nvSpPr>
@@ -5197,7 +5268,7 @@
       </p:sp>
       <p:sp>
         <p:nvSpPr>
-          <p:cNvPr id="98" name="Feed A"/>
+          <p:cNvPr id="101" name="Feed A"/>
           <p:cNvSpPr/>
           <p:nvPr/>
         </p:nvSpPr>
@@ -5220,7 +5291,7 @@
       </p:sp>
       <p:sp>
         <p:nvSpPr>
-          <p:cNvPr id="99" name="Join A"/>
+          <p:cNvPr id="102" name="Join A"/>
           <p:cNvSpPr/>
           <p:nvPr/>
         </p:nvSpPr>
@@ -5245,7 +5316,7 @@
       </p:sp>
       <p:sp>
         <p:nvSpPr>
-          <p:cNvPr id="100" name="Feed B"/>
+          <p:cNvPr id="103" name="Feed B"/>
           <p:cNvSpPr/>
           <p:nvPr/>
         </p:nvSpPr>
@@ -5268,7 +5339,7 @@
       </p:sp>
       <p:sp>
         <p:nvSpPr>
-          <p:cNvPr id="101" name="Join B"/>
+          <p:cNvPr id="104" name="Join B"/>
           <p:cNvSpPr/>
           <p:nvPr/>
         </p:nvSpPr>
@@ -5293,7 +5364,7 @@
       </p:sp>
       <p:sp>
         <p:nvSpPr>
-          <p:cNvPr id="102" name="Feed C"/>
+          <p:cNvPr id="105" name="Feed C"/>
           <p:cNvSpPr/>
           <p:nvPr/>
         </p:nvSpPr>
@@ -5316,7 +5387,7 @@
       </p:sp>
       <p:sp>
         <p:nvSpPr>
-          <p:cNvPr id="103" name="Join C"/>
+          <p:cNvPr id="106" name="Join C"/>
           <p:cNvSpPr/>
           <p:nvPr/>
         </p:nvSpPr>
@@ -5341,7 +5412,7 @@
       </p:sp>
       <p:sp>
         <p:nvSpPr>
-          <p:cNvPr id="104" name="Feed B"/>
+          <p:cNvPr id="107" name="Feed B"/>
           <p:cNvSpPr/>
           <p:nvPr/>
         </p:nvSpPr>
@@ -5364,7 +5435,7 @@
       </p:sp>
       <p:sp>
         <p:nvSpPr>
-          <p:cNvPr id="105" name="Join B"/>
+          <p:cNvPr id="108" name="Join B"/>
           <p:cNvSpPr/>
           <p:nvPr/>
         </p:nvSpPr>
@@ -5389,7 +5460,7 @@
       </p:sp>
       <p:sp>
         <p:nvSpPr>
-          <p:cNvPr id="106" name="Feed C"/>
+          <p:cNvPr id="109" name="Feed C"/>
           <p:cNvSpPr/>
           <p:nvPr/>
         </p:nvSpPr>
@@ -5412,7 +5483,7 @@
       </p:sp>
       <p:sp>
         <p:nvSpPr>
-          <p:cNvPr id="107" name="Join C"/>
+          <p:cNvPr id="110" name="Join C"/>
           <p:cNvSpPr/>
           <p:nvPr/>
         </p:nvSpPr>
@@ -5437,7 +5508,7 @@
       </p:sp>
       <p:sp>
         <p:nvSpPr>
-          <p:cNvPr id="108" name="Data without a standard"/>
+          <p:cNvPr id="111" name="Data without a standard"/>
           <p:cNvSpPr/>
           <p:nvPr/>
         </p:nvSpPr>

</xml_diff>

<commit_message>
Fig. 5: JSON Schema (Pydantic) for DANDI metadata; planned LinkML translations
Co-Authored-By: Claude Opus 5.5 <noreply@anthropic.com>
</commit_message>
<xml_diff>
--- a/figures/fig5_bbqs_stack/fig5_bbqs_stack_design.pptx
+++ b/figures/fig5_bbqs_stack/fig5_bbqs_stack_design.pptx
@@ -506,6 +506,7 @@
 Stack: rows 1 data formats, 2 file organization, 3 dataset organization, 5 data archives. Ontologies &amp; terminologies (4) and schema languages (6) are side panels next to rows 2-3, which they both serve.
 Paths: NWB (orange) runs from the data through NWB to EMBER; BIDS (green) and Psych-DS (slate) run from the data to EMBER. A green arrow from NWB to the BIDS path shows that BIDS can include NWB files.
 NWB extensions and enhancement proposals are labelled by purpose: pose estimation (ndx-pose, NWBEP in preparation), structured behavior (ndx-structured-behavior), microscopy (NWBEP004), HED annotation (ndx-hed), fiber photometry, wearable devices, multi-subject (ndx-multisubjects, NWBEP in preparation), ethogram. A dashed green line joins Multi-subject to the planned multi-subject BEP (companion proposals). Standards boxes are outlined in the colour of their path (DANDI layout orange, Psych-DS slate).
+Panel 6: HDMF defines NWB, the BIDS schema defines BIDS, LinkML defines Psych-DS and Neuro Termsets (translations of the Dandiset and NWB schemas to LinkML are planned), and JSON Schema generated from Pydantic models (dandi-schema; published in dandi/schema) defines DANDI layout and EMBER archive metadata.
 Panel 4: each terminology is its own box; arrows show the terminologies Neuro Termsets draws on (Cell Ontology is not yet a term set).
 Status: solid = recommended for BBQS today; dashed = extension or proposal in progress; grey dashed = needs a standard.
 BBQS data: each data type appears once; thin lines join it to every standard it can use (Table 3).</a:t>
@@ -4503,11 +4504,11 @@
         <p:spPr>
           <a:xfrm>
             <a:off x="10698480" y="3383280"/>
-            <a:ext cx="1124712" cy="566928"/>
+            <a:ext cx="1124712" cy="896112"/>
           </a:xfrm>
           <a:prstGeom prst="roundRect">
             <a:avLst>
-              <a:gd name="adj" fmla="val 9677"/>
+              <a:gd name="adj" fmla="val 6122"/>
             </a:avLst>
           </a:prstGeom>
           <a:solidFill>
@@ -4557,11 +4558,93 @@
             </a:r>
             <a:endParaRPr lang="en-US" sz="1000" dirty="0"/>
           </a:p>
-        </p:txBody>
-      </p:sp>
-      <p:sp>
-        <p:nvSpPr>
-          <p:cNvPr id="79" name="Text 77"/>
+          <a:p>
+            <a:pPr algn="ctr" indent="0" marL="0">
+              <a:buNone/>
+            </a:pPr>
+            <a:r>
+              <a:rPr lang="en-US" sz="850" i="1" dirty="0">
+                <a:solidFill>
+                  <a:srgbClr val="5B6770"/>
+                </a:solidFill>
+                <a:latin typeface="Arial" pitchFamily="34" charset="0"/>
+                <a:ea typeface="Arial" pitchFamily="34" charset="-122"/>
+                <a:cs typeface="Arial" pitchFamily="34" charset="-120"/>
+              </a:rPr>
+              <a:t>(Dandiset and NWB schema translations planned)</a:t>
+            </a:r>
+            <a:endParaRPr lang="en-US" sz="1000" dirty="0"/>
+          </a:p>
+        </p:txBody>
+      </p:sp>
+      <p:sp>
+        <p:nvSpPr>
+          <p:cNvPr id="79" name="JSON Schema (Pydantic)"/>
+          <p:cNvSpPr/>
+          <p:nvPr/>
+        </p:nvSpPr>
+        <p:spPr>
+          <a:xfrm>
+            <a:off x="10698480" y="4370832"/>
+            <a:ext cx="1124712" cy="731520"/>
+          </a:xfrm>
+          <a:prstGeom prst="roundRect">
+            <a:avLst>
+              <a:gd name="adj" fmla="val 7500"/>
+            </a:avLst>
+          </a:prstGeom>
+          <a:solidFill>
+            <a:srgbClr val="FFFFFF"/>
+          </a:solidFill>
+          <a:ln w="15875">
+            <a:solidFill>
+              <a:srgbClr val="56B4E9"/>
+            </a:solidFill>
+            <a:prstDash val="solid"/>
+          </a:ln>
+        </p:spPr>
+        <p:txBody>
+          <a:bodyPr wrap="square" lIns="19050" tIns="0" rIns="19050" bIns="0" rtlCol="0" anchor="ctr"/>
+          <a:lstStyle/>
+          <a:p>
+            <a:pPr algn="ctr" indent="0" marL="0">
+              <a:buNone/>
+            </a:pPr>
+            <a:r>
+              <a:rPr lang="en-US" sz="1000" b="1" dirty="0">
+                <a:solidFill>
+                  <a:srgbClr val="1F2933"/>
+                </a:solidFill>
+                <a:latin typeface="Arial" pitchFamily="34" charset="0"/>
+                <a:ea typeface="Arial" pitchFamily="34" charset="-122"/>
+                <a:cs typeface="Arial" pitchFamily="34" charset="-120"/>
+              </a:rPr>
+              <a:t>JSON Schema (Pydantic)</a:t>
+            </a:r>
+            <a:endParaRPr lang="en-US" sz="1000" dirty="0"/>
+          </a:p>
+          <a:p>
+            <a:pPr algn="ctr" indent="0" marL="0">
+              <a:buNone/>
+            </a:pPr>
+            <a:r>
+              <a:rPr lang="en-US" sz="900" i="1" dirty="0">
+                <a:solidFill>
+                  <a:srgbClr val="5B6770"/>
+                </a:solidFill>
+                <a:latin typeface="Arial" pitchFamily="34" charset="0"/>
+                <a:ea typeface="Arial" pitchFamily="34" charset="-122"/>
+                <a:cs typeface="Arial" pitchFamily="34" charset="-120"/>
+              </a:rPr>
+              <a:t>defines DANDI layout, EMBER archive metadata</a:t>
+            </a:r>
+            <a:endParaRPr lang="en-US" sz="1000" dirty="0"/>
+          </a:p>
+        </p:txBody>
+      </p:sp>
+      <p:sp>
+        <p:nvSpPr>
+          <p:cNvPr id="80" name="Text 78"/>
           <p:cNvSpPr txBox="1"/>
           <p:nvPr/>
         </p:nvSpPr>
@@ -4600,7 +4683,7 @@
       </p:sp>
       <p:sp>
         <p:nvSpPr>
-          <p:cNvPr id="80" name="Data: Electro- and optical physiology · stimulation"/>
+          <p:cNvPr id="81" name="Data: Electro- and optical physiology · stimulation"/>
           <p:cNvSpPr/>
           <p:nvPr/>
         </p:nvSpPr>
@@ -4649,7 +4732,7 @@
       </p:sp>
       <p:sp>
         <p:nvSpPr>
-          <p:cNvPr id="81" name="Data: Video · audio · pose · eye tracking · task events"/>
+          <p:cNvPr id="82" name="Data: Video · audio · pose · eye tracking · task events"/>
           <p:cNvSpPr/>
           <p:nvPr/>
         </p:nvSpPr>
@@ -4698,7 +4781,7 @@
       </p:sp>
       <p:sp>
         <p:nvSpPr>
-          <p:cNvPr id="82" name="Data: EEG · MEG · iEEG"/>
+          <p:cNvPr id="83" name="Data: EEG · MEG · iEEG"/>
           <p:cNvSpPr/>
           <p:nvPr/>
         </p:nvSpPr>
@@ -4747,7 +4830,7 @@
       </p:sp>
       <p:sp>
         <p:nvSpPr>
-          <p:cNvPr id="83" name="Data: MRI · fMRI · PET"/>
+          <p:cNvPr id="84" name="Data: MRI · fMRI · PET"/>
           <p:cNvSpPr/>
           <p:nvPr/>
         </p:nvSpPr>
@@ -4796,7 +4879,7 @@
       </p:sp>
       <p:sp>
         <p:nvSpPr>
-          <p:cNvPr id="84" name="Data: Wearables"/>
+          <p:cNvPr id="85" name="Data: Wearables"/>
           <p:cNvSpPr/>
           <p:nvPr/>
         </p:nvSpPr>
@@ -4845,7 +4928,7 @@
       </p:sp>
       <p:sp>
         <p:nvSpPr>
-          <p:cNvPr id="85" name="Data: Questionnaires surveys"/>
+          <p:cNvPr id="86" name="Data: Questionnaires surveys"/>
           <p:cNvSpPr/>
           <p:nvPr/>
         </p:nvSpPr>
@@ -4911,7 +4994,7 @@
       </p:sp>
       <p:sp>
         <p:nvSpPr>
-          <p:cNvPr id="86" name="Bus A"/>
+          <p:cNvPr id="87" name="Bus A"/>
           <p:cNvSpPr/>
           <p:nvPr/>
         </p:nvSpPr>
@@ -4934,7 +5017,7 @@
       </p:sp>
       <p:sp>
         <p:nvSpPr>
-          <p:cNvPr id="87" name="Bus B"/>
+          <p:cNvPr id="88" name="Bus B"/>
           <p:cNvSpPr/>
           <p:nvPr/>
         </p:nvSpPr>
@@ -4957,7 +5040,7 @@
       </p:sp>
       <p:sp>
         <p:nvSpPr>
-          <p:cNvPr id="88" name="Bus C"/>
+          <p:cNvPr id="89" name="Bus C"/>
           <p:cNvSpPr/>
           <p:nvPr/>
         </p:nvSpPr>
@@ -4980,7 +5063,7 @@
       </p:sp>
       <p:sp>
         <p:nvSpPr>
-          <p:cNvPr id="89" name="Feed A"/>
+          <p:cNvPr id="90" name="Feed A"/>
           <p:cNvSpPr/>
           <p:nvPr/>
         </p:nvSpPr>
@@ -5003,7 +5086,7 @@
       </p:sp>
       <p:sp>
         <p:nvSpPr>
-          <p:cNvPr id="90" name="Join A"/>
+          <p:cNvPr id="91" name="Join A"/>
           <p:cNvSpPr/>
           <p:nvPr/>
         </p:nvSpPr>
@@ -5028,7 +5111,7 @@
       </p:sp>
       <p:sp>
         <p:nvSpPr>
-          <p:cNvPr id="91" name="Feed A"/>
+          <p:cNvPr id="92" name="Feed A"/>
           <p:cNvSpPr/>
           <p:nvPr/>
         </p:nvSpPr>
@@ -5051,7 +5134,7 @@
       </p:sp>
       <p:sp>
         <p:nvSpPr>
-          <p:cNvPr id="92" name="Join A"/>
+          <p:cNvPr id="93" name="Join A"/>
           <p:cNvSpPr/>
           <p:nvPr/>
         </p:nvSpPr>
@@ -5076,7 +5159,7 @@
       </p:sp>
       <p:sp>
         <p:nvSpPr>
-          <p:cNvPr id="93" name="Feed B"/>
+          <p:cNvPr id="94" name="Feed B"/>
           <p:cNvSpPr/>
           <p:nvPr/>
         </p:nvSpPr>
@@ -5099,7 +5182,7 @@
       </p:sp>
       <p:sp>
         <p:nvSpPr>
-          <p:cNvPr id="94" name="Join B"/>
+          <p:cNvPr id="95" name="Join B"/>
           <p:cNvSpPr/>
           <p:nvPr/>
         </p:nvSpPr>
@@ -5124,7 +5207,7 @@
       </p:sp>
       <p:sp>
         <p:nvSpPr>
-          <p:cNvPr id="95" name="Feed A"/>
+          <p:cNvPr id="96" name="Feed A"/>
           <p:cNvSpPr/>
           <p:nvPr/>
         </p:nvSpPr>
@@ -5147,7 +5230,7 @@
       </p:sp>
       <p:sp>
         <p:nvSpPr>
-          <p:cNvPr id="96" name="Join A"/>
+          <p:cNvPr id="97" name="Join A"/>
           <p:cNvSpPr/>
           <p:nvPr/>
         </p:nvSpPr>
@@ -5172,7 +5255,7 @@
       </p:sp>
       <p:sp>
         <p:nvSpPr>
-          <p:cNvPr id="97" name="Feed B"/>
+          <p:cNvPr id="98" name="Feed B"/>
           <p:cNvSpPr/>
           <p:nvPr/>
         </p:nvSpPr>
@@ -5195,7 +5278,7 @@
       </p:sp>
       <p:sp>
         <p:nvSpPr>
-          <p:cNvPr id="98" name="Join B"/>
+          <p:cNvPr id="99" name="Join B"/>
           <p:cNvSpPr/>
           <p:nvPr/>
         </p:nvSpPr>
@@ -5220,7 +5303,7 @@
       </p:sp>
       <p:sp>
         <p:nvSpPr>
-          <p:cNvPr id="99" name="Feed B"/>
+          <p:cNvPr id="100" name="Feed B"/>
           <p:cNvSpPr/>
           <p:nvPr/>
         </p:nvSpPr>
@@ -5243,7 +5326,7 @@
       </p:sp>
       <p:sp>
         <p:nvSpPr>
-          <p:cNvPr id="100" name="Join B"/>
+          <p:cNvPr id="101" name="Join B"/>
           <p:cNvSpPr/>
           <p:nvPr/>
         </p:nvSpPr>
@@ -5268,7 +5351,7 @@
       </p:sp>
       <p:sp>
         <p:nvSpPr>
-          <p:cNvPr id="101" name="Feed A"/>
+          <p:cNvPr id="102" name="Feed A"/>
           <p:cNvSpPr/>
           <p:nvPr/>
         </p:nvSpPr>
@@ -5291,7 +5374,7 @@
       </p:sp>
       <p:sp>
         <p:nvSpPr>
-          <p:cNvPr id="102" name="Join A"/>
+          <p:cNvPr id="103" name="Join A"/>
           <p:cNvSpPr/>
           <p:nvPr/>
         </p:nvSpPr>
@@ -5316,7 +5399,7 @@
       </p:sp>
       <p:sp>
         <p:nvSpPr>
-          <p:cNvPr id="103" name="Feed B"/>
+          <p:cNvPr id="104" name="Feed B"/>
           <p:cNvSpPr/>
           <p:nvPr/>
         </p:nvSpPr>
@@ -5339,7 +5422,7 @@
       </p:sp>
       <p:sp>
         <p:nvSpPr>
-          <p:cNvPr id="104" name="Join B"/>
+          <p:cNvPr id="105" name="Join B"/>
           <p:cNvSpPr/>
           <p:nvPr/>
         </p:nvSpPr>
@@ -5364,7 +5447,7 @@
       </p:sp>
       <p:sp>
         <p:nvSpPr>
-          <p:cNvPr id="105" name="Feed C"/>
+          <p:cNvPr id="106" name="Feed C"/>
           <p:cNvSpPr/>
           <p:nvPr/>
         </p:nvSpPr>
@@ -5387,7 +5470,7 @@
       </p:sp>
       <p:sp>
         <p:nvSpPr>
-          <p:cNvPr id="106" name="Join C"/>
+          <p:cNvPr id="107" name="Join C"/>
           <p:cNvSpPr/>
           <p:nvPr/>
         </p:nvSpPr>
@@ -5412,7 +5495,7 @@
       </p:sp>
       <p:sp>
         <p:nvSpPr>
-          <p:cNvPr id="107" name="Feed B"/>
+          <p:cNvPr id="108" name="Feed B"/>
           <p:cNvSpPr/>
           <p:nvPr/>
         </p:nvSpPr>
@@ -5435,7 +5518,7 @@
       </p:sp>
       <p:sp>
         <p:nvSpPr>
-          <p:cNvPr id="108" name="Join B"/>
+          <p:cNvPr id="109" name="Join B"/>
           <p:cNvSpPr/>
           <p:nvPr/>
         </p:nvSpPr>
@@ -5460,7 +5543,7 @@
       </p:sp>
       <p:sp>
         <p:nvSpPr>
-          <p:cNvPr id="109" name="Feed C"/>
+          <p:cNvPr id="110" name="Feed C"/>
           <p:cNvSpPr/>
           <p:nvPr/>
         </p:nvSpPr>
@@ -5483,7 +5566,7 @@
       </p:sp>
       <p:sp>
         <p:nvSpPr>
-          <p:cNvPr id="110" name="Join C"/>
+          <p:cNvPr id="111" name="Join C"/>
           <p:cNvSpPr/>
           <p:nvPr/>
         </p:nvSpPr>
@@ -5508,7 +5591,7 @@
       </p:sp>
       <p:sp>
         <p:nvSpPr>
-          <p:cNvPr id="111" name="Data without a standard"/>
+          <p:cNvPr id="112" name="Data without a standard"/>
           <p:cNvSpPr/>
           <p:nvPr/>
         </p:nvSpPr>

</xml_diff>

<commit_message>
Fix colors of text in labels in Figure 5
</commit_message>
<xml_diff>
--- a/figures/fig5_bbqs_stack/fig5_bbqs_stack_design.pptx
+++ b/figures/fig5_bbqs_stack/fig5_bbqs_stack_design.pptx
@@ -4,14 +4,14 @@
   <p:sldMasterIdLst>
     <p:sldMasterId id="2147483648" r:id="rId1"/>
   </p:sldMasterIdLst>
+  <p:notesMasterIdLst>
+    <p:notesMasterId r:id="rId3"/>
+  </p:notesMasterIdLst>
   <p:sldIdLst>
     <p:sldId id="256" r:id="rId2"/>
   </p:sldIdLst>
-  <p:notesMasterIdLst>
-    <p:notesMasterId r:id="rId3"/>
-  </p:notesMasterIdLst>
-  <p:sldSz cx="12191695" cy="7863840"/>
-  <p:notesSz cx="7863840" cy="12191695"/>
+  <p:sldSz cx="12192000" cy="7864475"/>
+  <p:notesSz cx="7864475" cy="12192000"/>
   <p:defaultTextStyle>
     <a:lvl1pPr marL="0" algn="l" defTabSz="914400" rtl="0" eaLnBrk="1" latinLnBrk="0" hangingPunct="1">
       <a:defRPr sz="1800" kern="1200">
@@ -104,6 +104,11 @@
       </a:defRPr>
     </a:lvl9pPr>
   </p:defaultTextStyle>
+  <p:extLst>
+    <p:ext uri="{EFAFB233-063F-42B5-8137-9DF3F51BA10A}">
+      <p15:sldGuideLst xmlns:p15="http://schemas.microsoft.com/office/powerpoint/2012/main"/>
+    </p:ext>
+  </p:extLst>
 </p:presentation>
 </file>
 
@@ -129,234 +134,10 @@
           <a:chExt cx="0" cy="0"/>
         </a:xfrm>
       </p:grpSpPr>
-      <p:sp>
-        <p:nvSpPr>
-          <p:cNvPr id="2" name="Header Placeholder 1"/>
-          <p:cNvSpPr>
-            <a:spLocks noGrp="1"/>
-          </p:cNvSpPr>
-          <p:nvPr>
-            <p:ph type="hdr" sz="quarter"/>
-          </p:nvPr>
-        </p:nvSpPr>
-        <p:spPr>
-          <a:xfrm>
-            <a:off x="0" y="0"/>
-            <a:ext cx="2971800" cy="458788"/>
-          </a:xfrm>
-          <a:prstGeom prst="rect">
-            <a:avLst/>
-          </a:prstGeom>
-        </p:spPr>
-        <p:txBody>
-          <a:bodyPr vert="horz" lIns="91440" tIns="45720" rIns="91440" bIns="45720" rtlCol="0"/>
-          <a:lstStyle>
-            <a:lvl1pPr algn="l">
-              <a:defRPr sz="1200"/>
-            </a:lvl1pPr>
-          </a:lstStyle>
-          <a:p>
-            <a:endParaRPr lang="en-US"/>
-          </a:p>
-        </p:txBody>
-      </p:sp>
-      <p:sp>
-        <p:nvSpPr>
-          <p:cNvPr id="3" name="Date Placeholder 2"/>
-          <p:cNvSpPr>
-            <a:spLocks noGrp="1"/>
-          </p:cNvSpPr>
-          <p:nvPr>
-            <p:ph type="dt" idx="1"/>
-          </p:nvPr>
-        </p:nvSpPr>
-        <p:spPr>
-          <a:xfrm>
-            <a:off x="3884613" y="0"/>
-            <a:ext cx="2971800" cy="458788"/>
-          </a:xfrm>
-          <a:prstGeom prst="rect">
-            <a:avLst/>
-          </a:prstGeom>
-        </p:spPr>
-        <p:txBody>
-          <a:bodyPr vert="horz" lIns="91440" tIns="45720" rIns="91440" bIns="45720" rtlCol="0"/>
-          <a:lstStyle>
-            <a:lvl1pPr algn="r">
-              <a:defRPr sz="1200"/>
-            </a:lvl1pPr>
-          </a:lstStyle>
-          <a:p>
-            <a:fld id="{5282F153-3F37-0F45-9E97-73ACFA13230C}" type="datetimeFigureOut">
-              <a:rPr lang="en-US"/>
-              <a:t>7/23/19</a:t>
-            </a:fld>
-            <a:endParaRPr lang="en-US"/>
-          </a:p>
-        </p:txBody>
-      </p:sp>
-      <p:sp>
-        <p:nvSpPr>
-          <p:cNvPr id="4" name="Slide Image Placeholder 3"/>
-          <p:cNvSpPr>
-            <a:spLocks noGrp="1" noRot="1" noChangeAspect="1"/>
-          </p:cNvSpPr>
-          <p:nvPr>
-            <p:ph type="sldImg" idx="2"/>
-          </p:nvPr>
-        </p:nvSpPr>
-        <p:spPr>
-          <a:xfrm>
-            <a:off x="685800" y="1143000"/>
-            <a:ext cx="5486400" cy="3086100"/>
-          </a:xfrm>
-          <a:prstGeom prst="rect">
-            <a:avLst/>
-          </a:prstGeom>
-          <a:noFill/>
-          <a:ln w="12700">
-            <a:solidFill>
-              <a:prstClr val="black"/>
-            </a:solidFill>
-          </a:ln>
-        </p:spPr>
-        <p:txBody>
-          <a:bodyPr vert="horz" lIns="91440" tIns="45720" rIns="91440" bIns="45720" rtlCol="0" anchor="ctr"/>
-          <a:lstStyle/>
-          <a:p>
-            <a:endParaRPr lang="en-US"/>
-          </a:p>
-        </p:txBody>
-      </p:sp>
-      <p:sp>
-        <p:nvSpPr>
-          <p:cNvPr id="5" name="Notes Placeholder 4"/>
-          <p:cNvSpPr>
-            <a:spLocks noGrp="1"/>
-          </p:cNvSpPr>
-          <p:nvPr>
-            <p:ph type="body" sz="quarter" idx="3"/>
-          </p:nvPr>
-        </p:nvSpPr>
-        <p:spPr>
-          <a:xfrm>
-            <a:off x="685800" y="4400550"/>
-            <a:ext cx="5486400" cy="3600450"/>
-          </a:xfrm>
-          <a:prstGeom prst="rect">
-            <a:avLst/>
-          </a:prstGeom>
-        </p:spPr>
-        <p:txBody>
-          <a:bodyPr vert="horz" lIns="91440" tIns="45720" rIns="91440" bIns="45720" rtlCol="0"/>
-          <a:lstStyle/>
-          <a:p>
-            <a:pPr lvl="0"/>
-            <a:r>
-              <a:rPr lang="en-US"/>
-              <a:t>Click to edit Master text styles</a:t>
-            </a:r>
-          </a:p>
-          <a:p>
-            <a:pPr lvl="1"/>
-            <a:r>
-              <a:rPr lang="en-US"/>
-              <a:t>Second level</a:t>
-            </a:r>
-          </a:p>
-          <a:p>
-            <a:pPr lvl="2"/>
-            <a:r>
-              <a:rPr lang="en-US"/>
-              <a:t>Third level</a:t>
-            </a:r>
-          </a:p>
-          <a:p>
-            <a:pPr lvl="3"/>
-            <a:r>
-              <a:rPr lang="en-US"/>
-              <a:t>Fourth level</a:t>
-            </a:r>
-          </a:p>
-          <a:p>
-            <a:pPr lvl="4"/>
-            <a:r>
-              <a:rPr lang="en-US"/>
-              <a:t>Fifth level</a:t>
-            </a:r>
-          </a:p>
-        </p:txBody>
-      </p:sp>
-      <p:sp>
-        <p:nvSpPr>
-          <p:cNvPr id="6" name="Footer Placeholder 5"/>
-          <p:cNvSpPr>
-            <a:spLocks noGrp="1"/>
-          </p:cNvSpPr>
-          <p:nvPr>
-            <p:ph type="ftr" sz="quarter" idx="4"/>
-          </p:nvPr>
-        </p:nvSpPr>
-        <p:spPr>
-          <a:xfrm>
-            <a:off x="0" y="8685213"/>
-            <a:ext cx="2971800" cy="458787"/>
-          </a:xfrm>
-          <a:prstGeom prst="rect">
-            <a:avLst/>
-          </a:prstGeom>
-        </p:spPr>
-        <p:txBody>
-          <a:bodyPr vert="horz" lIns="91440" tIns="45720" rIns="91440" bIns="45720" rtlCol="0" anchor="b"/>
-          <a:lstStyle>
-            <a:lvl1pPr algn="l">
-              <a:defRPr sz="1200"/>
-            </a:lvl1pPr>
-          </a:lstStyle>
-          <a:p>
-            <a:endParaRPr lang="en-US"/>
-          </a:p>
-        </p:txBody>
-      </p:sp>
-      <p:sp>
-        <p:nvSpPr>
-          <p:cNvPr id="7" name="Slide Number Placeholder 6"/>
-          <p:cNvSpPr>
-            <a:spLocks noGrp="1"/>
-          </p:cNvSpPr>
-          <p:nvPr>
-            <p:ph type="sldNum" sz="quarter" idx="5"/>
-          </p:nvPr>
-        </p:nvSpPr>
-        <p:spPr>
-          <a:xfrm>
-            <a:off x="3884613" y="8685213"/>
-            <a:ext cx="2971800" cy="458787"/>
-          </a:xfrm>
-          <a:prstGeom prst="rect">
-            <a:avLst/>
-          </a:prstGeom>
-        </p:spPr>
-        <p:txBody>
-          <a:bodyPr vert="horz" lIns="91440" tIns="45720" rIns="91440" bIns="45720" rtlCol="0" anchor="b"/>
-          <a:lstStyle>
-            <a:lvl1pPr algn="r">
-              <a:defRPr sz="1200"/>
-            </a:lvl1pPr>
-          </a:lstStyle>
-          <a:p>
-            <a:fld id="{CE5E9CC1-C706-0F49-92D6-E571CC5EEA8F}" type="slidenum">
-              <a:rPr lang="en-US"/>
-              <a:t>‹#›</a:t>
-            </a:fld>
-            <a:endParaRPr lang="en-US"/>
-          </a:p>
-        </p:txBody>
-      </p:sp>
     </p:spTree>
     <p:extLst>
       <p:ext uri="{BB962C8B-B14F-4D97-AF65-F5344CB8AC3E}">
-        <p14:creationId xmlns:p14="http://schemas.microsoft.com/office/powerpoint/2010/main" val="1024086991"/>
+        <p14:creationId xmlns:p14="http://schemas.microsoft.com/office/powerpoint/2010/main" val="3555784051"/>
       </p:ext>
     </p:extLst>
   </p:cSld>
@@ -511,7 +292,6 @@
 Status: solid = recommended for BBQS today; dashed = extension or proposal in progress; grey dashed = needs a standard.
 BBQS data: each data type appears once; thin lines join it to every standard it can use (Table 3).</a:t>
             </a:r>
-            <a:endParaRPr lang="en-US" dirty="0"/>
           </a:p>
         </p:txBody>
       </p:sp>
@@ -584,6 +364,11 @@
 <file path=ppt/slideMasters/slideMaster1.xml><?xml version="1.0" encoding="utf-8"?>
 <p:sldMaster xmlns:a="http://schemas.openxmlformats.org/drawingml/2006/main" xmlns:r="http://schemas.openxmlformats.org/officeDocument/2006/relationships" xmlns:p="http://schemas.openxmlformats.org/presentationml/2006/main">
   <p:cSld>
+    <p:bg>
+      <p:bgRef idx="1001">
+        <a:schemeClr val="bg1"/>
+      </p:bgRef>
+    </p:bg>
     <p:spTree>
       <p:nvGrpSpPr>
         <p:cNvPr id="1" name=""/>
@@ -866,6 +651,7 @@
         <a:solidFill>
           <a:srgbClr val="FFFFFF"/>
         </a:solidFill>
+        <a:effectLst/>
       </p:bgPr>
     </p:bg>
     <p:spTree>
@@ -908,6 +694,13 @@
             <a:prstDash val="solid"/>
           </a:ln>
         </p:spPr>
+        <p:txBody>
+          <a:bodyPr/>
+          <a:lstStyle/>
+          <a:p>
+            <a:endParaRPr lang="en-US"/>
+          </a:p>
+        </p:txBody>
       </p:sp>
       <p:sp>
         <p:nvSpPr>
@@ -930,7 +723,7 @@
           <a:bodyPr wrap="square" lIns="0" tIns="0" rIns="0" bIns="0" rtlCol="0" anchor="ctr"/>
           <a:lstStyle/>
           <a:p>
-            <a:pPr indent="0" marL="0">
+            <a:pPr marL="0" indent="0">
               <a:buNone/>
             </a:pPr>
             <a:r>
@@ -974,6 +767,13 @@
             <a:prstDash val="dash"/>
           </a:ln>
         </p:spPr>
+        <p:txBody>
+          <a:bodyPr/>
+          <a:lstStyle/>
+          <a:p>
+            <a:endParaRPr lang="en-US"/>
+          </a:p>
+        </p:txBody>
       </p:sp>
       <p:sp>
         <p:nvSpPr>
@@ -996,7 +796,7 @@
           <a:bodyPr wrap="square" lIns="0" tIns="0" rIns="0" bIns="0" rtlCol="0" anchor="ctr"/>
           <a:lstStyle/>
           <a:p>
-            <a:pPr indent="0" marL="0">
+            <a:pPr marL="0" indent="0">
               <a:buNone/>
             </a:pPr>
             <a:r>
@@ -1042,6 +842,13 @@
             <a:prstDash val="dash"/>
           </a:ln>
         </p:spPr>
+        <p:txBody>
+          <a:bodyPr/>
+          <a:lstStyle/>
+          <a:p>
+            <a:endParaRPr lang="en-US"/>
+          </a:p>
+        </p:txBody>
       </p:sp>
       <p:sp>
         <p:nvSpPr>
@@ -1064,7 +871,7 @@
           <a:bodyPr wrap="square" lIns="0" tIns="0" rIns="0" bIns="0" rtlCol="0" anchor="ctr"/>
           <a:lstStyle/>
           <a:p>
-            <a:pPr indent="0" marL="0">
+            <a:pPr marL="0" indent="0">
               <a:buNone/>
             </a:pPr>
             <a:r>
@@ -1105,6 +912,13 @@
             <a:tailEnd type="triangle"/>
           </a:ln>
         </p:spPr>
+        <p:txBody>
+          <a:bodyPr/>
+          <a:lstStyle/>
+          <a:p>
+            <a:endParaRPr lang="en-US"/>
+          </a:p>
+        </p:txBody>
       </p:sp>
       <p:sp>
         <p:nvSpPr>
@@ -1127,7 +941,7 @@
           <a:bodyPr wrap="square" lIns="0" tIns="0" rIns="0" bIns="0" rtlCol="0" anchor="ctr"/>
           <a:lstStyle/>
           <a:p>
-            <a:pPr indent="0" marL="0">
+            <a:pPr marL="0" indent="0">
               <a:buNone/>
             </a:pPr>
             <a:r>
@@ -1174,7 +988,7 @@
           <a:bodyPr wrap="square" lIns="566928" tIns="182880" rIns="9884664" bIns="45720" rtlCol="0" anchor="t"/>
           <a:lstStyle/>
           <a:p>
-            <a:pPr algn="l" indent="0" marL="0">
+            <a:pPr marL="0" indent="0" algn="l">
               <a:spcAft>
                 <a:spcPts val="300"/>
               </a:spcAft>
@@ -1194,7 +1008,7 @@
             <a:endParaRPr lang="en-US" sz="1150" dirty="0"/>
           </a:p>
           <a:p>
-            <a:pPr algn="l" indent="0" marL="0">
+            <a:pPr marL="0" indent="0" algn="l">
               <a:spcAft>
                 <a:spcPts val="300"/>
               </a:spcAft>
@@ -1239,6 +1053,13 @@
             <a:prstDash val="solid"/>
           </a:ln>
         </p:spPr>
+        <p:txBody>
+          <a:bodyPr/>
+          <a:lstStyle/>
+          <a:p>
+            <a:endParaRPr lang="en-US"/>
+          </a:p>
+        </p:txBody>
       </p:sp>
       <p:sp>
         <p:nvSpPr>
@@ -1267,7 +1088,7 @@
           <a:bodyPr wrap="square" lIns="0" tIns="0" rIns="0" bIns="0" rtlCol="0" anchor="ctr"/>
           <a:lstStyle/>
           <a:p>
-            <a:pPr algn="ctr" indent="0" marL="0">
+            <a:pPr marL="0" indent="0" algn="ctr">
               <a:buNone/>
             </a:pPr>
             <a:r>
@@ -1314,7 +1135,7 @@
           <a:bodyPr wrap="square" lIns="566928" tIns="182880" rIns="6400800" bIns="45720" rtlCol="0" anchor="t"/>
           <a:lstStyle/>
           <a:p>
-            <a:pPr algn="l" indent="0" marL="0">
+            <a:pPr marL="0" indent="0" algn="l">
               <a:spcAft>
                 <a:spcPts val="300"/>
               </a:spcAft>
@@ -1334,7 +1155,7 @@
             <a:endParaRPr lang="en-US" sz="1150" dirty="0"/>
           </a:p>
           <a:p>
-            <a:pPr algn="l" indent="0" marL="0">
+            <a:pPr marL="0" indent="0" algn="l">
               <a:spcAft>
                 <a:spcPts val="300"/>
               </a:spcAft>
@@ -1379,6 +1200,13 @@
             <a:prstDash val="solid"/>
           </a:ln>
         </p:spPr>
+        <p:txBody>
+          <a:bodyPr/>
+          <a:lstStyle/>
+          <a:p>
+            <a:endParaRPr lang="en-US"/>
+          </a:p>
+        </p:txBody>
       </p:sp>
       <p:sp>
         <p:nvSpPr>
@@ -1407,7 +1235,7 @@
           <a:bodyPr wrap="square" lIns="0" tIns="0" rIns="0" bIns="0" rtlCol="0" anchor="ctr"/>
           <a:lstStyle/>
           <a:p>
-            <a:pPr algn="ctr" indent="0" marL="0">
+            <a:pPr marL="0" indent="0" algn="ctr">
               <a:buNone/>
             </a:pPr>
             <a:r>
@@ -1454,7 +1282,7 @@
           <a:bodyPr wrap="square" lIns="566928" tIns="182880" rIns="6400800" bIns="45720" rtlCol="0" anchor="t"/>
           <a:lstStyle/>
           <a:p>
-            <a:pPr algn="l" indent="0" marL="0">
+            <a:pPr marL="0" indent="0" algn="l">
               <a:spcAft>
                 <a:spcPts val="300"/>
               </a:spcAft>
@@ -1474,7 +1302,7 @@
             <a:endParaRPr lang="en-US" sz="1150" dirty="0"/>
           </a:p>
           <a:p>
-            <a:pPr algn="l" indent="0" marL="0">
+            <a:pPr marL="0" indent="0" algn="l">
               <a:spcAft>
                 <a:spcPts val="300"/>
               </a:spcAft>
@@ -1519,6 +1347,13 @@
             <a:prstDash val="solid"/>
           </a:ln>
         </p:spPr>
+        <p:txBody>
+          <a:bodyPr/>
+          <a:lstStyle/>
+          <a:p>
+            <a:endParaRPr lang="en-US"/>
+          </a:p>
+        </p:txBody>
       </p:sp>
       <p:sp>
         <p:nvSpPr>
@@ -1547,7 +1382,7 @@
           <a:bodyPr wrap="square" lIns="0" tIns="0" rIns="0" bIns="0" rtlCol="0" anchor="ctr"/>
           <a:lstStyle/>
           <a:p>
-            <a:pPr algn="ctr" indent="0" marL="0">
+            <a:pPr marL="0" indent="0" algn="ctr">
               <a:buNone/>
             </a:pPr>
             <a:r>
@@ -1594,7 +1429,7 @@
           <a:bodyPr wrap="square" lIns="566928" tIns="182880" rIns="9884664" bIns="45720" rtlCol="0" anchor="t"/>
           <a:lstStyle/>
           <a:p>
-            <a:pPr algn="l" indent="0" marL="0">
+            <a:pPr marL="0" indent="0" algn="l">
               <a:spcAft>
                 <a:spcPts val="300"/>
               </a:spcAft>
@@ -1614,7 +1449,7 @@
             <a:endParaRPr lang="en-US" sz="1150" dirty="0"/>
           </a:p>
           <a:p>
-            <a:pPr algn="l" indent="0" marL="0">
+            <a:pPr marL="0" indent="0" algn="l">
               <a:spcAft>
                 <a:spcPts val="300"/>
               </a:spcAft>
@@ -1659,6 +1494,13 @@
             <a:prstDash val="solid"/>
           </a:ln>
         </p:spPr>
+        <p:txBody>
+          <a:bodyPr/>
+          <a:lstStyle/>
+          <a:p>
+            <a:endParaRPr lang="en-US"/>
+          </a:p>
+        </p:txBody>
       </p:sp>
       <p:sp>
         <p:nvSpPr>
@@ -1687,13 +1529,13 @@
           <a:bodyPr wrap="square" lIns="0" tIns="0" rIns="0" bIns="0" rtlCol="0" anchor="ctr"/>
           <a:lstStyle/>
           <a:p>
-            <a:pPr algn="ctr" indent="0" marL="0">
+            <a:pPr marL="0" indent="0" algn="ctr">
               <a:buNone/>
             </a:pPr>
             <a:r>
               <a:rPr lang="en-US" sz="1150" b="1" dirty="0">
                 <a:solidFill>
-                  <a:srgbClr val="1A1A1A"/>
+                  <a:schemeClr val="bg1"/>
                 </a:solidFill>
                 <a:latin typeface="Arial" pitchFamily="34" charset="0"/>
                 <a:ea typeface="Arial" pitchFamily="34" charset="-122"/>
@@ -1701,7 +1543,11 @@
               </a:rPr>
               <a:t>1</a:t>
             </a:r>
-            <a:endParaRPr lang="en-US" sz="1150" dirty="0"/>
+            <a:endParaRPr lang="en-US" sz="1150" dirty="0">
+              <a:solidFill>
+                <a:schemeClr val="bg1"/>
+              </a:solidFill>
+            </a:endParaRPr>
           </a:p>
         </p:txBody>
       </p:sp>
@@ -1734,7 +1580,7 @@
           <a:bodyPr wrap="square" lIns="475488" tIns="182880" rIns="54864" bIns="45720" rtlCol="0" anchor="t"/>
           <a:lstStyle/>
           <a:p>
-            <a:pPr algn="l" indent="0" marL="0">
+            <a:pPr marL="0" indent="0" algn="l">
               <a:spcAft>
                 <a:spcPts val="300"/>
               </a:spcAft>
@@ -1754,7 +1600,7 @@
             <a:endParaRPr lang="en-US" sz="1150" dirty="0"/>
           </a:p>
           <a:p>
-            <a:pPr algn="l" indent="0" marL="0">
+            <a:pPr marL="0" indent="0" algn="l">
               <a:spcAft>
                 <a:spcPts val="300"/>
               </a:spcAft>
@@ -1799,6 +1645,13 @@
             <a:prstDash val="solid"/>
           </a:ln>
         </p:spPr>
+        <p:txBody>
+          <a:bodyPr/>
+          <a:lstStyle/>
+          <a:p>
+            <a:endParaRPr lang="en-US"/>
+          </a:p>
+        </p:txBody>
       </p:sp>
       <p:sp>
         <p:nvSpPr>
@@ -1827,7 +1680,7 @@
           <a:bodyPr wrap="square" lIns="0" tIns="0" rIns="0" bIns="0" rtlCol="0" anchor="ctr"/>
           <a:lstStyle/>
           <a:p>
-            <a:pPr algn="ctr" indent="0" marL="0">
+            <a:pPr marL="0" indent="0" algn="ctr">
               <a:buNone/>
             </a:pPr>
             <a:r>
@@ -1874,7 +1727,7 @@
           <a:bodyPr wrap="square" lIns="475488" tIns="182880" rIns="54864" bIns="45720" rtlCol="0" anchor="t"/>
           <a:lstStyle/>
           <a:p>
-            <a:pPr algn="l" indent="0" marL="0">
+            <a:pPr marL="0" indent="0" algn="l">
               <a:spcAft>
                 <a:spcPts val="300"/>
               </a:spcAft>
@@ -1894,7 +1747,7 @@
             <a:endParaRPr lang="en-US" sz="1150" dirty="0"/>
           </a:p>
           <a:p>
-            <a:pPr algn="l" indent="0" marL="0">
+            <a:pPr marL="0" indent="0" algn="l">
               <a:spcAft>
                 <a:spcPts val="300"/>
               </a:spcAft>
@@ -1939,6 +1792,13 @@
             <a:prstDash val="solid"/>
           </a:ln>
         </p:spPr>
+        <p:txBody>
+          <a:bodyPr/>
+          <a:lstStyle/>
+          <a:p>
+            <a:endParaRPr lang="en-US"/>
+          </a:p>
+        </p:txBody>
       </p:sp>
       <p:sp>
         <p:nvSpPr>
@@ -1967,13 +1827,13 @@
           <a:bodyPr wrap="square" lIns="0" tIns="0" rIns="0" bIns="0" rtlCol="0" anchor="ctr"/>
           <a:lstStyle/>
           <a:p>
-            <a:pPr algn="ctr" indent="0" marL="0">
+            <a:pPr marL="0" indent="0" algn="ctr">
               <a:buNone/>
             </a:pPr>
             <a:r>
               <a:rPr lang="en-US" sz="1150" b="1" dirty="0">
                 <a:solidFill>
-                  <a:srgbClr val="1A1A1A"/>
+                  <a:schemeClr val="bg1"/>
                 </a:solidFill>
                 <a:latin typeface="Arial" pitchFamily="34" charset="0"/>
                 <a:ea typeface="Arial" pitchFamily="34" charset="-122"/>
@@ -1981,7 +1841,11 @@
               </a:rPr>
               <a:t>6</a:t>
             </a:r>
-            <a:endParaRPr lang="en-US" sz="1150" dirty="0"/>
+            <a:endParaRPr lang="en-US" sz="1150" dirty="0">
+              <a:solidFill>
+                <a:schemeClr val="bg1"/>
+              </a:solidFill>
+            </a:endParaRPr>
           </a:p>
         </p:txBody>
       </p:sp>
@@ -2008,6 +1872,13 @@
             <a:tailEnd type="triangle"/>
           </a:ln>
         </p:spPr>
+        <p:txBody>
+          <a:bodyPr/>
+          <a:lstStyle/>
+          <a:p>
+            <a:endParaRPr lang="en-US"/>
+          </a:p>
+        </p:txBody>
       </p:sp>
       <p:sp>
         <p:nvSpPr>
@@ -2032,6 +1903,13 @@
             <a:tailEnd type="triangle"/>
           </a:ln>
         </p:spPr>
+        <p:txBody>
+          <a:bodyPr/>
+          <a:lstStyle/>
+          <a:p>
+            <a:endParaRPr lang="en-US"/>
+          </a:p>
+        </p:txBody>
       </p:sp>
       <p:sp>
         <p:nvSpPr>
@@ -2056,6 +1934,13 @@
             <a:tailEnd type="triangle"/>
           </a:ln>
         </p:spPr>
+        <p:txBody>
+          <a:bodyPr/>
+          <a:lstStyle/>
+          <a:p>
+            <a:endParaRPr lang="en-US"/>
+          </a:p>
+        </p:txBody>
       </p:sp>
       <p:sp>
         <p:nvSpPr>
@@ -2080,6 +1965,13 @@
             <a:tailEnd type="triangle"/>
           </a:ln>
         </p:spPr>
+        <p:txBody>
+          <a:bodyPr/>
+          <a:lstStyle/>
+          <a:p>
+            <a:endParaRPr lang="en-US"/>
+          </a:p>
+        </p:txBody>
       </p:sp>
       <p:sp>
         <p:nvSpPr>
@@ -2104,6 +1996,13 @@
             <a:tailEnd type="triangle"/>
           </a:ln>
         </p:spPr>
+        <p:txBody>
+          <a:bodyPr/>
+          <a:lstStyle/>
+          <a:p>
+            <a:endParaRPr lang="en-US"/>
+          </a:p>
+        </p:txBody>
       </p:sp>
       <p:sp>
         <p:nvSpPr>
@@ -2135,7 +2034,7 @@
           <a:bodyPr wrap="square" lIns="19050" tIns="0" rIns="19050" bIns="0" rtlCol="0" anchor="ctr"/>
           <a:lstStyle/>
           <a:p>
-            <a:pPr algn="ctr" indent="0" marL="0">
+            <a:pPr marL="0" indent="0" algn="ctr">
               <a:buNone/>
             </a:pPr>
             <a:r>
@@ -2152,7 +2051,7 @@
             <a:endParaRPr lang="en-US" sz="1000" dirty="0"/>
           </a:p>
           <a:p>
-            <a:pPr algn="ctr" indent="0" marL="0">
+            <a:pPr marL="0" indent="0" algn="ctr">
               <a:buNone/>
             </a:pPr>
             <a:r>
@@ -2200,7 +2099,7 @@
           <a:bodyPr wrap="square" lIns="19050" tIns="0" rIns="19050" bIns="0" rtlCol="0" anchor="ctr"/>
           <a:lstStyle/>
           <a:p>
-            <a:pPr algn="ctr" indent="0" marL="0">
+            <a:pPr marL="0" indent="0" algn="ctr">
               <a:buNone/>
             </a:pPr>
             <a:r>
@@ -2217,7 +2116,7 @@
             <a:endParaRPr lang="en-US" sz="1000" dirty="0"/>
           </a:p>
           <a:p>
-            <a:pPr algn="ctr" indent="0" marL="0">
+            <a:pPr marL="0" indent="0" algn="ctr">
               <a:buNone/>
             </a:pPr>
             <a:r>
@@ -2265,7 +2164,7 @@
           <a:bodyPr wrap="square" lIns="19050" tIns="0" rIns="19050" bIns="0" rtlCol="0" anchor="ctr"/>
           <a:lstStyle/>
           <a:p>
-            <a:pPr algn="ctr" indent="0" marL="0">
+            <a:pPr marL="0" indent="0" algn="ctr">
               <a:buNone/>
             </a:pPr>
             <a:r>
@@ -2282,7 +2181,7 @@
             <a:endParaRPr lang="en-US" sz="1000" dirty="0"/>
           </a:p>
           <a:p>
-            <a:pPr algn="ctr" indent="0" marL="0">
+            <a:pPr marL="0" indent="0" algn="ctr">
               <a:buNone/>
             </a:pPr>
             <a:r>
@@ -2330,7 +2229,7 @@
           <a:bodyPr wrap="square" lIns="0" tIns="0" rIns="0" bIns="0" rtlCol="0" anchor="ctr"/>
           <a:lstStyle/>
           <a:p>
-            <a:pPr algn="ctr" indent="0" marL="0">
+            <a:pPr marL="0" indent="0" algn="ctr">
               <a:buNone/>
             </a:pPr>
             <a:r>
@@ -2347,7 +2246,7 @@
             <a:endParaRPr lang="en-US" sz="1000" dirty="0"/>
           </a:p>
           <a:p>
-            <a:pPr algn="ctr" indent="0" marL="0">
+            <a:pPr marL="0" indent="0" algn="ctr">
               <a:buNone/>
             </a:pPr>
             <a:r>
@@ -2395,7 +2294,7 @@
           <a:bodyPr wrap="square" lIns="0" tIns="0" rIns="0" bIns="0" rtlCol="0" anchor="ctr"/>
           <a:lstStyle/>
           <a:p>
-            <a:pPr algn="ctr" indent="0" marL="0">
+            <a:pPr marL="0" indent="0" algn="ctr">
               <a:buNone/>
             </a:pPr>
             <a:r>
@@ -2412,7 +2311,7 @@
             <a:endParaRPr lang="en-US" sz="1000" dirty="0"/>
           </a:p>
           <a:p>
-            <a:pPr algn="ctr" indent="0" marL="0">
+            <a:pPr marL="0" indent="0" algn="ctr">
               <a:buNone/>
             </a:pPr>
             <a:r>
@@ -2460,7 +2359,7 @@
           <a:bodyPr wrap="square" lIns="0" tIns="0" rIns="0" bIns="0" rtlCol="0" anchor="ctr"/>
           <a:lstStyle/>
           <a:p>
-            <a:pPr algn="ctr" indent="0" marL="0">
+            <a:pPr marL="0" indent="0" algn="ctr">
               <a:buNone/>
             </a:pPr>
             <a:r>
@@ -2477,7 +2376,7 @@
             <a:endParaRPr lang="en-US" sz="1000" dirty="0"/>
           </a:p>
           <a:p>
-            <a:pPr algn="ctr" indent="0" marL="0">
+            <a:pPr marL="0" indent="0" algn="ctr">
               <a:buNone/>
             </a:pPr>
             <a:r>
@@ -2525,7 +2424,7 @@
           <a:bodyPr wrap="square" lIns="0" tIns="0" rIns="0" bIns="0" rtlCol="0" anchor="ctr"/>
           <a:lstStyle/>
           <a:p>
-            <a:pPr algn="ctr" indent="0" marL="0">
+            <a:pPr marL="0" indent="0" algn="ctr">
               <a:buNone/>
             </a:pPr>
             <a:r>
@@ -2542,7 +2441,7 @@
             <a:endParaRPr lang="en-US" sz="1000" dirty="0"/>
           </a:p>
           <a:p>
-            <a:pPr algn="ctr" indent="0" marL="0">
+            <a:pPr marL="0" indent="0" algn="ctr">
               <a:buNone/>
             </a:pPr>
             <a:r>
@@ -2590,7 +2489,7 @@
           <a:bodyPr wrap="square" lIns="19050" tIns="0" rIns="19050" bIns="0" rtlCol="0" anchor="ctr"/>
           <a:lstStyle/>
           <a:p>
-            <a:pPr algn="ctr" indent="0" marL="0">
+            <a:pPr marL="0" indent="0" algn="ctr">
               <a:buNone/>
             </a:pPr>
             <a:r>
@@ -2607,7 +2506,7 @@
             <a:endParaRPr lang="en-US" sz="1000" dirty="0"/>
           </a:p>
           <a:p>
-            <a:pPr algn="ctr" indent="0" marL="0">
+            <a:pPr marL="0" indent="0" algn="ctr">
               <a:buNone/>
             </a:pPr>
             <a:r>
@@ -2655,7 +2554,7 @@
           <a:bodyPr wrap="square" lIns="19050" tIns="0" rIns="19050" bIns="0" rtlCol="0" anchor="ctr"/>
           <a:lstStyle/>
           <a:p>
-            <a:pPr algn="ctr" indent="0" marL="0">
+            <a:pPr marL="0" indent="0" algn="ctr">
               <a:buNone/>
             </a:pPr>
             <a:r>
@@ -2672,7 +2571,7 @@
             <a:endParaRPr lang="en-US" sz="1000" dirty="0"/>
           </a:p>
           <a:p>
-            <a:pPr algn="ctr" indent="0" marL="0">
+            <a:pPr marL="0" indent="0" algn="ctr">
               <a:buNone/>
             </a:pPr>
             <a:r>
@@ -2720,7 +2619,7 @@
           <a:bodyPr wrap="square" lIns="0" tIns="0" rIns="0" bIns="0" rtlCol="0" anchor="ctr"/>
           <a:lstStyle/>
           <a:p>
-            <a:pPr algn="ctr" indent="0" marL="0">
+            <a:pPr marL="0" indent="0" algn="ctr">
               <a:buNone/>
             </a:pPr>
             <a:r>
@@ -2768,7 +2667,7 @@
           <a:bodyPr wrap="square" lIns="0" tIns="0" rIns="0" bIns="0" rtlCol="0" anchor="ctr"/>
           <a:lstStyle/>
           <a:p>
-            <a:pPr algn="ctr" indent="0" marL="0">
+            <a:pPr marL="0" indent="0" algn="ctr">
               <a:buNone/>
             </a:pPr>
             <a:r>
@@ -2816,7 +2715,7 @@
           <a:bodyPr wrap="square" lIns="0" tIns="0" rIns="0" bIns="0" rtlCol="0" anchor="ctr"/>
           <a:lstStyle/>
           <a:p>
-            <a:pPr algn="ctr" indent="0" marL="0">
+            <a:pPr marL="0" indent="0" algn="ctr">
               <a:buNone/>
             </a:pPr>
             <a:r>
@@ -2864,7 +2763,7 @@
           <a:bodyPr wrap="square" lIns="0" tIns="0" rIns="0" bIns="0" rtlCol="0" anchor="ctr"/>
           <a:lstStyle/>
           <a:p>
-            <a:pPr algn="ctr" indent="0" marL="0">
+            <a:pPr marL="0" indent="0" algn="ctr">
               <a:buNone/>
             </a:pPr>
             <a:r>
@@ -2912,7 +2811,7 @@
           <a:bodyPr wrap="square" lIns="0" tIns="0" rIns="0" bIns="0" rtlCol="0" anchor="ctr"/>
           <a:lstStyle/>
           <a:p>
-            <a:pPr algn="ctr" indent="0" marL="0">
+            <a:pPr marL="0" indent="0" algn="ctr">
               <a:buNone/>
             </a:pPr>
             <a:r>
@@ -2960,7 +2859,7 @@
           <a:bodyPr wrap="square" lIns="0" tIns="0" rIns="0" bIns="0" rtlCol="0" anchor="ctr"/>
           <a:lstStyle/>
           <a:p>
-            <a:pPr algn="ctr" indent="0" marL="0">
+            <a:pPr marL="0" indent="0" algn="ctr">
               <a:buNone/>
             </a:pPr>
             <a:r>
@@ -3008,7 +2907,7 @@
           <a:bodyPr wrap="square" lIns="0" tIns="0" rIns="0" bIns="0" rtlCol="0" anchor="ctr"/>
           <a:lstStyle/>
           <a:p>
-            <a:pPr algn="ctr" indent="0" marL="0">
+            <a:pPr marL="0" indent="0" algn="ctr">
               <a:buNone/>
             </a:pPr>
             <a:r>
@@ -3056,7 +2955,7 @@
           <a:bodyPr wrap="square" lIns="0" tIns="0" rIns="0" bIns="0" rtlCol="0" anchor="ctr"/>
           <a:lstStyle/>
           <a:p>
-            <a:pPr algn="ctr" indent="0" marL="0">
+            <a:pPr marL="0" indent="0" algn="ctr">
               <a:buNone/>
             </a:pPr>
             <a:r>
@@ -3095,7 +2994,7 @@
           <a:bodyPr wrap="square" lIns="0" tIns="0" rIns="0" bIns="0" rtlCol="0" anchor="t"/>
           <a:lstStyle/>
           <a:p>
-            <a:pPr algn="l" indent="0" marL="0">
+            <a:pPr marL="0" indent="0" algn="l">
               <a:buNone/>
             </a:pPr>
             <a:r>
@@ -3143,7 +3042,7 @@
           <a:bodyPr wrap="square" lIns="19050" tIns="0" rIns="19050" bIns="0" rtlCol="0" anchor="ctr"/>
           <a:lstStyle/>
           <a:p>
-            <a:pPr algn="ctr" indent="0" marL="0">
+            <a:pPr marL="0" indent="0" algn="ctr">
               <a:buNone/>
             </a:pPr>
             <a:r>
@@ -3160,7 +3059,7 @@
             <a:endParaRPr lang="en-US" sz="1000" dirty="0"/>
           </a:p>
           <a:p>
-            <a:pPr algn="ctr" indent="0" marL="0">
+            <a:pPr marL="0" indent="0" algn="ctr">
               <a:buNone/>
             </a:pPr>
             <a:r>
@@ -3208,7 +3107,7 @@
           <a:bodyPr wrap="square" lIns="19050" tIns="0" rIns="19050" bIns="0" rtlCol="0" anchor="ctr"/>
           <a:lstStyle/>
           <a:p>
-            <a:pPr algn="ctr" indent="0" marL="0">
+            <a:pPr marL="0" indent="0" algn="ctr">
               <a:buNone/>
             </a:pPr>
             <a:r>
@@ -3225,7 +3124,7 @@
             <a:endParaRPr lang="en-US" sz="1000" dirty="0"/>
           </a:p>
           <a:p>
-            <a:pPr algn="ctr" indent="0" marL="0">
+            <a:pPr marL="0" indent="0" algn="ctr">
               <a:buNone/>
             </a:pPr>
             <a:r>
@@ -3273,7 +3172,7 @@
           <a:bodyPr wrap="square" lIns="0" tIns="0" rIns="0" bIns="0" rtlCol="0" anchor="ctr"/>
           <a:lstStyle/>
           <a:p>
-            <a:pPr algn="ctr" indent="0" marL="0">
+            <a:pPr marL="0" indent="0" algn="ctr">
               <a:buNone/>
             </a:pPr>
             <a:r>
@@ -3290,7 +3189,7 @@
             <a:endParaRPr lang="en-US" sz="1000" dirty="0"/>
           </a:p>
           <a:p>
-            <a:pPr algn="ctr" indent="0" marL="0">
+            <a:pPr marL="0" indent="0" algn="ctr">
               <a:buNone/>
             </a:pPr>
             <a:r>
@@ -3338,7 +3237,7 @@
           <a:bodyPr wrap="square" lIns="0" tIns="0" rIns="0" bIns="0" rtlCol="0" anchor="ctr"/>
           <a:lstStyle/>
           <a:p>
-            <a:pPr algn="ctr" indent="0" marL="0">
+            <a:pPr marL="0" indent="0" algn="ctr">
               <a:buNone/>
             </a:pPr>
             <a:r>
@@ -3355,7 +3254,7 @@
             <a:endParaRPr lang="en-US" sz="1000" dirty="0"/>
           </a:p>
           <a:p>
-            <a:pPr algn="ctr" indent="0" marL="0">
+            <a:pPr marL="0" indent="0" algn="ctr">
               <a:buNone/>
             </a:pPr>
             <a:r>
@@ -3403,7 +3302,7 @@
           <a:bodyPr wrap="square" lIns="0" tIns="0" rIns="0" bIns="0" rtlCol="0" anchor="ctr"/>
           <a:lstStyle/>
           <a:p>
-            <a:pPr algn="ctr" indent="0" marL="0">
+            <a:pPr marL="0" indent="0" algn="ctr">
               <a:buNone/>
             </a:pPr>
             <a:r>
@@ -3420,7 +3319,7 @@
             <a:endParaRPr lang="en-US" sz="1000" dirty="0"/>
           </a:p>
           <a:p>
-            <a:pPr algn="ctr" indent="0" marL="0">
+            <a:pPr marL="0" indent="0" algn="ctr">
               <a:buNone/>
             </a:pPr>
             <a:r>
@@ -3468,7 +3367,7 @@
           <a:bodyPr wrap="square" lIns="0" tIns="0" rIns="0" bIns="0" rtlCol="0" anchor="ctr"/>
           <a:lstStyle/>
           <a:p>
-            <a:pPr algn="ctr" indent="0" marL="0">
+            <a:pPr marL="0" indent="0" algn="ctr">
               <a:buNone/>
             </a:pPr>
             <a:r>
@@ -3485,7 +3384,7 @@
             <a:endParaRPr lang="en-US" sz="1000" dirty="0"/>
           </a:p>
           <a:p>
-            <a:pPr algn="ctr" indent="0" marL="0">
+            <a:pPr marL="0" indent="0" algn="ctr">
               <a:buNone/>
             </a:pPr>
             <a:r>
@@ -3533,7 +3432,7 @@
           <a:bodyPr wrap="square" lIns="19050" tIns="0" rIns="19050" bIns="0" rtlCol="0" anchor="ctr"/>
           <a:lstStyle/>
           <a:p>
-            <a:pPr algn="ctr" indent="0" marL="0">
+            <a:pPr marL="0" indent="0" algn="ctr">
               <a:buNone/>
             </a:pPr>
             <a:r>
@@ -3550,7 +3449,7 @@
             <a:endParaRPr lang="en-US" sz="1000" dirty="0"/>
           </a:p>
           <a:p>
-            <a:pPr algn="ctr" indent="0" marL="0">
+            <a:pPr marL="0" indent="0" algn="ctr">
               <a:buNone/>
             </a:pPr>
             <a:r>
@@ -3590,6 +3489,13 @@
             <a:prstDash val="dash"/>
           </a:ln>
         </p:spPr>
+        <p:txBody>
+          <a:bodyPr/>
+          <a:lstStyle/>
+          <a:p>
+            <a:endParaRPr lang="en-US"/>
+          </a:p>
+        </p:txBody>
       </p:sp>
       <p:sp>
         <p:nvSpPr>
@@ -3613,6 +3519,13 @@
             <a:prstDash val="dash"/>
           </a:ln>
         </p:spPr>
+        <p:txBody>
+          <a:bodyPr/>
+          <a:lstStyle/>
+          <a:p>
+            <a:endParaRPr lang="en-US"/>
+          </a:p>
+        </p:txBody>
       </p:sp>
       <p:sp>
         <p:nvSpPr>
@@ -3635,7 +3548,7 @@
           <a:bodyPr wrap="square" lIns="0" tIns="0" rIns="0" bIns="0" rtlCol="0" anchor="t"/>
           <a:lstStyle/>
           <a:p>
-            <a:pPr algn="l" indent="0" marL="0">
+            <a:pPr marL="0" indent="0" algn="l">
               <a:buNone/>
             </a:pPr>
             <a:r>
@@ -3683,7 +3596,7 @@
           <a:bodyPr wrap="square" lIns="19050" tIns="0" rIns="19050" bIns="0" rtlCol="0" anchor="ctr"/>
           <a:lstStyle/>
           <a:p>
-            <a:pPr algn="ctr" indent="0" marL="0">
+            <a:pPr marL="0" indent="0" algn="ctr">
               <a:buNone/>
             </a:pPr>
             <a:r>
@@ -3700,7 +3613,7 @@
             <a:endParaRPr lang="en-US" sz="1000" dirty="0"/>
           </a:p>
           <a:p>
-            <a:pPr algn="ctr" indent="0" marL="0">
+            <a:pPr marL="0" indent="0" algn="ctr">
               <a:buNone/>
             </a:pPr>
             <a:r>
@@ -3748,7 +3661,7 @@
           <a:bodyPr wrap="square" lIns="19050" tIns="0" rIns="19050" bIns="0" rtlCol="0" anchor="ctr"/>
           <a:lstStyle/>
           <a:p>
-            <a:pPr algn="ctr" indent="0" marL="0">
+            <a:pPr marL="0" indent="0" algn="ctr">
               <a:buNone/>
             </a:pPr>
             <a:r>
@@ -3765,7 +3678,7 @@
             <a:endParaRPr lang="en-US" sz="1000" dirty="0"/>
           </a:p>
           <a:p>
-            <a:pPr algn="ctr" indent="0" marL="0">
+            <a:pPr marL="0" indent="0" algn="ctr">
               <a:buNone/>
             </a:pPr>
             <a:r>
@@ -3813,7 +3726,7 @@
           <a:bodyPr wrap="square" lIns="19050" tIns="0" rIns="19050" bIns="0" rtlCol="0" anchor="ctr"/>
           <a:lstStyle/>
           <a:p>
-            <a:pPr algn="ctr" indent="0" marL="0">
+            <a:pPr marL="0" indent="0" algn="ctr">
               <a:buNone/>
             </a:pPr>
             <a:r>
@@ -3827,9 +3740,6 @@
               </a:rPr>
               <a:t>NCBI Taxonomy  </a:t>
             </a:r>
-            <a:pPr algn="ctr" indent="0" marL="0">
-              <a:buNone/>
-            </a:pPr>
             <a:r>
               <a:rPr lang="en-US" sz="900" i="1" dirty="0">
                 <a:solidFill>
@@ -3868,6 +3778,13 @@
             <a:tailEnd type="triangle"/>
           </a:ln>
         </p:spPr>
+        <p:txBody>
+          <a:bodyPr/>
+          <a:lstStyle/>
+          <a:p>
+            <a:endParaRPr lang="en-US"/>
+          </a:p>
+        </p:txBody>
       </p:sp>
       <p:sp>
         <p:nvSpPr>
@@ -3899,7 +3816,7 @@
           <a:bodyPr wrap="square" lIns="19050" tIns="0" rIns="19050" bIns="0" rtlCol="0" anchor="ctr"/>
           <a:lstStyle/>
           <a:p>
-            <a:pPr algn="ctr" indent="0" marL="0">
+            <a:pPr marL="0" indent="0" algn="ctr">
               <a:buNone/>
             </a:pPr>
             <a:r>
@@ -3913,9 +3830,6 @@
               </a:rPr>
               <a:t>UBERON  </a:t>
             </a:r>
-            <a:pPr algn="ctr" indent="0" marL="0">
-              <a:buNone/>
-            </a:pPr>
             <a:r>
               <a:rPr lang="en-US" sz="900" i="1" dirty="0">
                 <a:solidFill>
@@ -3954,6 +3868,13 @@
             <a:tailEnd type="triangle"/>
           </a:ln>
         </p:spPr>
+        <p:txBody>
+          <a:bodyPr/>
+          <a:lstStyle/>
+          <a:p>
+            <a:endParaRPr lang="en-US"/>
+          </a:p>
+        </p:txBody>
       </p:sp>
       <p:sp>
         <p:nvSpPr>
@@ -3985,7 +3906,7 @@
           <a:bodyPr wrap="square" lIns="19050" tIns="0" rIns="19050" bIns="0" rtlCol="0" anchor="ctr"/>
           <a:lstStyle/>
           <a:p>
-            <a:pPr algn="ctr" indent="0" marL="0">
+            <a:pPr marL="0" indent="0" algn="ctr">
               <a:buNone/>
             </a:pPr>
             <a:r>
@@ -3999,9 +3920,6 @@
               </a:rPr>
               <a:t>Allen atlases  </a:t>
             </a:r>
-            <a:pPr algn="ctr" indent="0" marL="0">
-              <a:buNone/>
-            </a:pPr>
             <a:r>
               <a:rPr lang="en-US" sz="900" i="1" dirty="0">
                 <a:solidFill>
@@ -4040,6 +3958,13 @@
             <a:tailEnd type="triangle"/>
           </a:ln>
         </p:spPr>
+        <p:txBody>
+          <a:bodyPr/>
+          <a:lstStyle/>
+          <a:p>
+            <a:endParaRPr lang="en-US"/>
+          </a:p>
+        </p:txBody>
       </p:sp>
       <p:sp>
         <p:nvSpPr>
@@ -4071,7 +3996,7 @@
           <a:bodyPr wrap="square" lIns="19050" tIns="0" rIns="19050" bIns="0" rtlCol="0" anchor="ctr"/>
           <a:lstStyle/>
           <a:p>
-            <a:pPr algn="ctr" indent="0" marL="0">
+            <a:pPr marL="0" indent="0" algn="ctr">
               <a:buNone/>
             </a:pPr>
             <a:r>
@@ -4085,9 +4010,6 @@
               </a:rPr>
               <a:t>RRID  </a:t>
             </a:r>
-            <a:pPr algn="ctr" indent="0" marL="0">
-              <a:buNone/>
-            </a:pPr>
             <a:r>
               <a:rPr lang="en-US" sz="900" i="1" dirty="0">
                 <a:solidFill>
@@ -4126,6 +4048,13 @@
             <a:tailEnd type="triangle"/>
           </a:ln>
         </p:spPr>
+        <p:txBody>
+          <a:bodyPr/>
+          <a:lstStyle/>
+          <a:p>
+            <a:endParaRPr lang="en-US"/>
+          </a:p>
+        </p:txBody>
       </p:sp>
       <p:sp>
         <p:nvSpPr>
@@ -4157,7 +4086,7 @@
           <a:bodyPr wrap="square" lIns="19050" tIns="0" rIns="19050" bIns="0" rtlCol="0" anchor="ctr"/>
           <a:lstStyle/>
           <a:p>
-            <a:pPr algn="ctr" indent="0" marL="0">
+            <a:pPr marL="0" indent="0" algn="ctr">
               <a:buNone/>
             </a:pPr>
             <a:r>
@@ -4171,9 +4100,6 @@
               </a:rPr>
               <a:t>ORCID · ROR  </a:t>
             </a:r>
-            <a:pPr algn="ctr" indent="0" marL="0">
-              <a:buNone/>
-            </a:pPr>
             <a:r>
               <a:rPr lang="en-US" sz="900" i="1" dirty="0">
                 <a:solidFill>
@@ -4212,6 +4138,13 @@
             <a:tailEnd type="triangle"/>
           </a:ln>
         </p:spPr>
+        <p:txBody>
+          <a:bodyPr/>
+          <a:lstStyle/>
+          <a:p>
+            <a:endParaRPr lang="en-US"/>
+          </a:p>
+        </p:txBody>
       </p:sp>
       <p:sp>
         <p:nvSpPr>
@@ -4243,7 +4176,7 @@
           <a:bodyPr wrap="square" lIns="19050" tIns="0" rIns="19050" bIns="0" rtlCol="0" anchor="ctr"/>
           <a:lstStyle/>
           <a:p>
-            <a:pPr algn="ctr" indent="0" marL="0">
+            <a:pPr marL="0" indent="0" algn="ctr">
               <a:buNone/>
             </a:pPr>
             <a:r>
@@ -4257,9 +4190,6 @@
               </a:rPr>
               <a:t>Cell Ontology  </a:t>
             </a:r>
-            <a:pPr algn="ctr" indent="0" marL="0">
-              <a:buNone/>
-            </a:pPr>
             <a:r>
               <a:rPr lang="en-US" sz="900" i="1" dirty="0">
                 <a:solidFill>
@@ -4297,6 +4227,13 @@
             <a:prstDash val="solid"/>
           </a:ln>
         </p:spPr>
+        <p:txBody>
+          <a:bodyPr/>
+          <a:lstStyle/>
+          <a:p>
+            <a:endParaRPr lang="en-US"/>
+          </a:p>
+        </p:txBody>
       </p:sp>
       <p:sp>
         <p:nvSpPr>
@@ -4330,7 +4267,7 @@
           <a:bodyPr wrap="square" lIns="19050" tIns="0" rIns="19050" bIns="0" rtlCol="0" anchor="ctr"/>
           <a:lstStyle/>
           <a:p>
-            <a:pPr algn="ctr" indent="0" marL="0">
+            <a:pPr marL="0" indent="0" algn="ctr">
               <a:buNone/>
             </a:pPr>
             <a:r>
@@ -4347,7 +4284,7 @@
             <a:endParaRPr lang="en-US" sz="1000" dirty="0"/>
           </a:p>
           <a:p>
-            <a:pPr algn="ctr" indent="0" marL="0">
+            <a:pPr marL="0" indent="0" algn="ctr">
               <a:buNone/>
             </a:pPr>
             <a:r>
@@ -4395,7 +4332,7 @@
           <a:bodyPr wrap="square" lIns="19050" tIns="0" rIns="19050" bIns="0" rtlCol="0" anchor="ctr"/>
           <a:lstStyle/>
           <a:p>
-            <a:pPr algn="ctr" indent="0" marL="0">
+            <a:pPr marL="0" indent="0" algn="ctr">
               <a:buNone/>
             </a:pPr>
             <a:r>
@@ -4412,7 +4349,7 @@
             <a:endParaRPr lang="en-US" sz="1000" dirty="0"/>
           </a:p>
           <a:p>
-            <a:pPr algn="ctr" indent="0" marL="0">
+            <a:pPr marL="0" indent="0" algn="ctr">
               <a:buNone/>
             </a:pPr>
             <a:r>
@@ -4460,7 +4397,7 @@
           <a:bodyPr wrap="square" lIns="19050" tIns="0" rIns="19050" bIns="0" rtlCol="0" anchor="ctr"/>
           <a:lstStyle/>
           <a:p>
-            <a:pPr algn="ctr" indent="0" marL="0">
+            <a:pPr marL="0" indent="0" algn="ctr">
               <a:buNone/>
             </a:pPr>
             <a:r>
@@ -4477,7 +4414,7 @@
             <a:endParaRPr lang="en-US" sz="1000" dirty="0"/>
           </a:p>
           <a:p>
-            <a:pPr algn="ctr" indent="0" marL="0">
+            <a:pPr marL="0" indent="0" algn="ctr">
               <a:buNone/>
             </a:pPr>
             <a:r>
@@ -4525,7 +4462,7 @@
           <a:bodyPr wrap="square" lIns="19050" tIns="0" rIns="19050" bIns="0" rtlCol="0" anchor="ctr"/>
           <a:lstStyle/>
           <a:p>
-            <a:pPr algn="ctr" indent="0" marL="0">
+            <a:pPr marL="0" indent="0" algn="ctr">
               <a:buNone/>
             </a:pPr>
             <a:r>
@@ -4542,7 +4479,7 @@
             <a:endParaRPr lang="en-US" sz="1000" dirty="0"/>
           </a:p>
           <a:p>
-            <a:pPr algn="ctr" indent="0" marL="0">
+            <a:pPr marL="0" indent="0" algn="ctr">
               <a:buNone/>
             </a:pPr>
             <a:r>
@@ -4559,7 +4496,7 @@
             <a:endParaRPr lang="en-US" sz="1000" dirty="0"/>
           </a:p>
           <a:p>
-            <a:pPr algn="ctr" indent="0" marL="0">
+            <a:pPr marL="0" indent="0" algn="ctr">
               <a:buNone/>
             </a:pPr>
             <a:r>
@@ -4607,7 +4544,7 @@
           <a:bodyPr wrap="square" lIns="19050" tIns="0" rIns="19050" bIns="0" rtlCol="0" anchor="ctr"/>
           <a:lstStyle/>
           <a:p>
-            <a:pPr algn="ctr" indent="0" marL="0">
+            <a:pPr marL="0" indent="0" algn="ctr">
               <a:buNone/>
             </a:pPr>
             <a:r>
@@ -4624,7 +4561,7 @@
             <a:endParaRPr lang="en-US" sz="1000" dirty="0"/>
           </a:p>
           <a:p>
-            <a:pPr algn="ctr" indent="0" marL="0">
+            <a:pPr marL="0" indent="0" algn="ctr">
               <a:buNone/>
             </a:pPr>
             <a:r>
@@ -4663,7 +4600,7 @@
           <a:bodyPr wrap="square" lIns="0" tIns="0" rIns="0" bIns="0" rtlCol="0" anchor="ctr"/>
           <a:lstStyle/>
           <a:p>
-            <a:pPr indent="0" marL="0">
+            <a:pPr marL="0" indent="0">
               <a:buNone/>
             </a:pPr>
             <a:r>
@@ -4693,9 +4630,7 @@
             <a:ext cx="1188720" cy="713232"/>
           </a:xfrm>
           <a:prstGeom prst="rect">
-            <a:avLst>
-              <a:gd name="adj" fmla="val 7692"/>
-            </a:avLst>
+            <a:avLst/>
           </a:prstGeom>
           <a:solidFill>
             <a:srgbClr val="8A96A3">
@@ -4712,7 +4647,7 @@
           <a:bodyPr wrap="square" lIns="19050" tIns="0" rIns="19050" bIns="0" rtlCol="0" anchor="ctr"/>
           <a:lstStyle/>
           <a:p>
-            <a:pPr algn="ctr" indent="0" marL="0">
+            <a:pPr marL="0" indent="0" algn="ctr">
               <a:buNone/>
             </a:pPr>
             <a:r>
@@ -4742,9 +4677,7 @@
             <a:ext cx="1325880" cy="713232"/>
           </a:xfrm>
           <a:prstGeom prst="rect">
-            <a:avLst>
-              <a:gd name="adj" fmla="val 7692"/>
-            </a:avLst>
+            <a:avLst/>
           </a:prstGeom>
           <a:solidFill>
             <a:srgbClr val="8A96A3">
@@ -4761,7 +4694,7 @@
           <a:bodyPr wrap="square" lIns="19050" tIns="0" rIns="19050" bIns="0" rtlCol="0" anchor="ctr"/>
           <a:lstStyle/>
           <a:p>
-            <a:pPr algn="ctr" indent="0" marL="0">
+            <a:pPr marL="0" indent="0" algn="ctr">
               <a:buNone/>
             </a:pPr>
             <a:r>
@@ -4791,9 +4724,7 @@
             <a:ext cx="868680" cy="713232"/>
           </a:xfrm>
           <a:prstGeom prst="rect">
-            <a:avLst>
-              <a:gd name="adj" fmla="val 7692"/>
-            </a:avLst>
+            <a:avLst/>
           </a:prstGeom>
           <a:solidFill>
             <a:srgbClr val="8A96A3">
@@ -4810,7 +4741,7 @@
           <a:bodyPr wrap="square" lIns="19050" tIns="0" rIns="19050" bIns="0" rtlCol="0" anchor="ctr"/>
           <a:lstStyle/>
           <a:p>
-            <a:pPr algn="ctr" indent="0" marL="0">
+            <a:pPr marL="0" indent="0" algn="ctr">
               <a:buNone/>
             </a:pPr>
             <a:r>
@@ -4840,9 +4771,7 @@
             <a:ext cx="822960" cy="713232"/>
           </a:xfrm>
           <a:prstGeom prst="rect">
-            <a:avLst>
-              <a:gd name="adj" fmla="val 7692"/>
-            </a:avLst>
+            <a:avLst/>
           </a:prstGeom>
           <a:solidFill>
             <a:srgbClr val="8A96A3">
@@ -4859,7 +4788,7 @@
           <a:bodyPr wrap="square" lIns="19050" tIns="0" rIns="19050" bIns="0" rtlCol="0" anchor="ctr"/>
           <a:lstStyle/>
           <a:p>
-            <a:pPr algn="ctr" indent="0" marL="0">
+            <a:pPr marL="0" indent="0" algn="ctr">
               <a:buNone/>
             </a:pPr>
             <a:r>
@@ -4889,9 +4818,7 @@
             <a:ext cx="777240" cy="713232"/>
           </a:xfrm>
           <a:prstGeom prst="rect">
-            <a:avLst>
-              <a:gd name="adj" fmla="val 7692"/>
-            </a:avLst>
+            <a:avLst/>
           </a:prstGeom>
           <a:solidFill>
             <a:srgbClr val="8A96A3">
@@ -4908,7 +4835,7 @@
           <a:bodyPr wrap="square" lIns="19050" tIns="0" rIns="19050" bIns="0" rtlCol="0" anchor="ctr"/>
           <a:lstStyle/>
           <a:p>
-            <a:pPr algn="ctr" indent="0" marL="0">
+            <a:pPr marL="0" indent="0" algn="ctr">
               <a:buNone/>
             </a:pPr>
             <a:r>
@@ -4938,9 +4865,7 @@
             <a:ext cx="1051560" cy="713232"/>
           </a:xfrm>
           <a:prstGeom prst="rect">
-            <a:avLst>
-              <a:gd name="adj" fmla="val 7692"/>
-            </a:avLst>
+            <a:avLst/>
           </a:prstGeom>
           <a:solidFill>
             <a:srgbClr val="8A96A3">
@@ -4957,7 +4882,7 @@
           <a:bodyPr wrap="square" lIns="19050" tIns="0" rIns="19050" bIns="0" rtlCol="0" anchor="ctr"/>
           <a:lstStyle/>
           <a:p>
-            <a:pPr algn="ctr" indent="0" marL="0">
+            <a:pPr marL="0" indent="0" algn="ctr">
               <a:buNone/>
             </a:pPr>
             <a:r>
@@ -4974,7 +4899,7 @@
             <a:endParaRPr lang="en-US" sz="1000" dirty="0"/>
           </a:p>
           <a:p>
-            <a:pPr algn="ctr" indent="0" marL="0">
+            <a:pPr marL="0" indent="0" algn="ctr">
               <a:buNone/>
             </a:pPr>
             <a:r>
@@ -5014,6 +4939,13 @@
             <a:prstDash val="solid"/>
           </a:ln>
         </p:spPr>
+        <p:txBody>
+          <a:bodyPr/>
+          <a:lstStyle/>
+          <a:p>
+            <a:endParaRPr lang="en-US"/>
+          </a:p>
+        </p:txBody>
       </p:sp>
       <p:sp>
         <p:nvSpPr>
@@ -5037,6 +4969,13 @@
             <a:prstDash val="solid"/>
           </a:ln>
         </p:spPr>
+        <p:txBody>
+          <a:bodyPr/>
+          <a:lstStyle/>
+          <a:p>
+            <a:endParaRPr lang="en-US"/>
+          </a:p>
+        </p:txBody>
       </p:sp>
       <p:sp>
         <p:nvSpPr>
@@ -5060,6 +4999,13 @@
             <a:prstDash val="solid"/>
           </a:ln>
         </p:spPr>
+        <p:txBody>
+          <a:bodyPr/>
+          <a:lstStyle/>
+          <a:p>
+            <a:endParaRPr lang="en-US"/>
+          </a:p>
+        </p:txBody>
       </p:sp>
       <p:sp>
         <p:nvSpPr>
@@ -5083,6 +5029,13 @@
             <a:prstDash val="solid"/>
           </a:ln>
         </p:spPr>
+        <p:txBody>
+          <a:bodyPr/>
+          <a:lstStyle/>
+          <a:p>
+            <a:endParaRPr lang="en-US"/>
+          </a:p>
+        </p:txBody>
       </p:sp>
       <p:sp>
         <p:nvSpPr>
@@ -5108,6 +5061,13 @@
             <a:prstDash val="solid"/>
           </a:ln>
         </p:spPr>
+        <p:txBody>
+          <a:bodyPr/>
+          <a:lstStyle/>
+          <a:p>
+            <a:endParaRPr lang="en-US"/>
+          </a:p>
+        </p:txBody>
       </p:sp>
       <p:sp>
         <p:nvSpPr>
@@ -5131,6 +5091,13 @@
             <a:prstDash val="solid"/>
           </a:ln>
         </p:spPr>
+        <p:txBody>
+          <a:bodyPr/>
+          <a:lstStyle/>
+          <a:p>
+            <a:endParaRPr lang="en-US"/>
+          </a:p>
+        </p:txBody>
       </p:sp>
       <p:sp>
         <p:nvSpPr>
@@ -5156,6 +5123,13 @@
             <a:prstDash val="solid"/>
           </a:ln>
         </p:spPr>
+        <p:txBody>
+          <a:bodyPr/>
+          <a:lstStyle/>
+          <a:p>
+            <a:endParaRPr lang="en-US"/>
+          </a:p>
+        </p:txBody>
       </p:sp>
       <p:sp>
         <p:nvSpPr>
@@ -5179,6 +5153,13 @@
             <a:prstDash val="solid"/>
           </a:ln>
         </p:spPr>
+        <p:txBody>
+          <a:bodyPr/>
+          <a:lstStyle/>
+          <a:p>
+            <a:endParaRPr lang="en-US"/>
+          </a:p>
+        </p:txBody>
       </p:sp>
       <p:sp>
         <p:nvSpPr>
@@ -5204,6 +5185,13 @@
             <a:prstDash val="solid"/>
           </a:ln>
         </p:spPr>
+        <p:txBody>
+          <a:bodyPr/>
+          <a:lstStyle/>
+          <a:p>
+            <a:endParaRPr lang="en-US"/>
+          </a:p>
+        </p:txBody>
       </p:sp>
       <p:sp>
         <p:nvSpPr>
@@ -5227,6 +5215,13 @@
             <a:prstDash val="solid"/>
           </a:ln>
         </p:spPr>
+        <p:txBody>
+          <a:bodyPr/>
+          <a:lstStyle/>
+          <a:p>
+            <a:endParaRPr lang="en-US"/>
+          </a:p>
+        </p:txBody>
       </p:sp>
       <p:sp>
         <p:nvSpPr>
@@ -5252,6 +5247,13 @@
             <a:prstDash val="solid"/>
           </a:ln>
         </p:spPr>
+        <p:txBody>
+          <a:bodyPr/>
+          <a:lstStyle/>
+          <a:p>
+            <a:endParaRPr lang="en-US"/>
+          </a:p>
+        </p:txBody>
       </p:sp>
       <p:sp>
         <p:nvSpPr>
@@ -5275,6 +5277,13 @@
             <a:prstDash val="solid"/>
           </a:ln>
         </p:spPr>
+        <p:txBody>
+          <a:bodyPr/>
+          <a:lstStyle/>
+          <a:p>
+            <a:endParaRPr lang="en-US"/>
+          </a:p>
+        </p:txBody>
       </p:sp>
       <p:sp>
         <p:nvSpPr>
@@ -5300,6 +5309,13 @@
             <a:prstDash val="solid"/>
           </a:ln>
         </p:spPr>
+        <p:txBody>
+          <a:bodyPr/>
+          <a:lstStyle/>
+          <a:p>
+            <a:endParaRPr lang="en-US"/>
+          </a:p>
+        </p:txBody>
       </p:sp>
       <p:sp>
         <p:nvSpPr>
@@ -5323,6 +5339,13 @@
             <a:prstDash val="solid"/>
           </a:ln>
         </p:spPr>
+        <p:txBody>
+          <a:bodyPr/>
+          <a:lstStyle/>
+          <a:p>
+            <a:endParaRPr lang="en-US"/>
+          </a:p>
+        </p:txBody>
       </p:sp>
       <p:sp>
         <p:nvSpPr>
@@ -5348,6 +5371,13 @@
             <a:prstDash val="solid"/>
           </a:ln>
         </p:spPr>
+        <p:txBody>
+          <a:bodyPr/>
+          <a:lstStyle/>
+          <a:p>
+            <a:endParaRPr lang="en-US"/>
+          </a:p>
+        </p:txBody>
       </p:sp>
       <p:sp>
         <p:nvSpPr>
@@ -5371,6 +5401,13 @@
             <a:prstDash val="solid"/>
           </a:ln>
         </p:spPr>
+        <p:txBody>
+          <a:bodyPr/>
+          <a:lstStyle/>
+          <a:p>
+            <a:endParaRPr lang="en-US"/>
+          </a:p>
+        </p:txBody>
       </p:sp>
       <p:sp>
         <p:nvSpPr>
@@ -5396,6 +5433,13 @@
             <a:prstDash val="solid"/>
           </a:ln>
         </p:spPr>
+        <p:txBody>
+          <a:bodyPr/>
+          <a:lstStyle/>
+          <a:p>
+            <a:endParaRPr lang="en-US"/>
+          </a:p>
+        </p:txBody>
       </p:sp>
       <p:sp>
         <p:nvSpPr>
@@ -5419,6 +5463,13 @@
             <a:prstDash val="solid"/>
           </a:ln>
         </p:spPr>
+        <p:txBody>
+          <a:bodyPr/>
+          <a:lstStyle/>
+          <a:p>
+            <a:endParaRPr lang="en-US"/>
+          </a:p>
+        </p:txBody>
       </p:sp>
       <p:sp>
         <p:nvSpPr>
@@ -5444,6 +5495,13 @@
             <a:prstDash val="solid"/>
           </a:ln>
         </p:spPr>
+        <p:txBody>
+          <a:bodyPr/>
+          <a:lstStyle/>
+          <a:p>
+            <a:endParaRPr lang="en-US"/>
+          </a:p>
+        </p:txBody>
       </p:sp>
       <p:sp>
         <p:nvSpPr>
@@ -5467,6 +5525,13 @@
             <a:prstDash val="solid"/>
           </a:ln>
         </p:spPr>
+        <p:txBody>
+          <a:bodyPr/>
+          <a:lstStyle/>
+          <a:p>
+            <a:endParaRPr lang="en-US"/>
+          </a:p>
+        </p:txBody>
       </p:sp>
       <p:sp>
         <p:nvSpPr>
@@ -5492,6 +5557,13 @@
             <a:prstDash val="solid"/>
           </a:ln>
         </p:spPr>
+        <p:txBody>
+          <a:bodyPr/>
+          <a:lstStyle/>
+          <a:p>
+            <a:endParaRPr lang="en-US"/>
+          </a:p>
+        </p:txBody>
       </p:sp>
       <p:sp>
         <p:nvSpPr>
@@ -5515,6 +5587,13 @@
             <a:prstDash val="solid"/>
           </a:ln>
         </p:spPr>
+        <p:txBody>
+          <a:bodyPr/>
+          <a:lstStyle/>
+          <a:p>
+            <a:endParaRPr lang="en-US"/>
+          </a:p>
+        </p:txBody>
       </p:sp>
       <p:sp>
         <p:nvSpPr>
@@ -5540,6 +5619,13 @@
             <a:prstDash val="solid"/>
           </a:ln>
         </p:spPr>
+        <p:txBody>
+          <a:bodyPr/>
+          <a:lstStyle/>
+          <a:p>
+            <a:endParaRPr lang="en-US"/>
+          </a:p>
+        </p:txBody>
       </p:sp>
       <p:sp>
         <p:nvSpPr>
@@ -5563,6 +5649,13 @@
             <a:prstDash val="solid"/>
           </a:ln>
         </p:spPr>
+        <p:txBody>
+          <a:bodyPr/>
+          <a:lstStyle/>
+          <a:p>
+            <a:endParaRPr lang="en-US"/>
+          </a:p>
+        </p:txBody>
       </p:sp>
       <p:sp>
         <p:nvSpPr>
@@ -5588,6 +5681,13 @@
             <a:prstDash val="solid"/>
           </a:ln>
         </p:spPr>
+        <p:txBody>
+          <a:bodyPr/>
+          <a:lstStyle/>
+          <a:p>
+            <a:endParaRPr lang="en-US"/>
+          </a:p>
+        </p:txBody>
       </p:sp>
       <p:sp>
         <p:nvSpPr>
@@ -5601,9 +5701,7 @@
             <a:ext cx="3300984" cy="713232"/>
           </a:xfrm>
           <a:prstGeom prst="rect">
-            <a:avLst>
-              <a:gd name="adj" fmla="val 7692"/>
-            </a:avLst>
+            <a:avLst/>
           </a:prstGeom>
           <a:solidFill>
             <a:srgbClr val="8A96A3">
@@ -5621,7 +5719,7 @@
           <a:bodyPr wrap="square" lIns="63500" tIns="12700" rIns="63500" bIns="12700" rtlCol="0" anchor="ctr"/>
           <a:lstStyle/>
           <a:p>
-            <a:pPr algn="ctr" indent="0" marL="0">
+            <a:pPr marL="0" indent="0" algn="ctr">
               <a:buNone/>
             </a:pPr>
             <a:r>
@@ -5638,7 +5736,7 @@
             <a:endParaRPr lang="en-US" sz="1000" dirty="0"/>
           </a:p>
           <a:p>
-            <a:pPr algn="ctr" indent="0" marL="0">
+            <a:pPr marL="0" indent="0" algn="ctr">
               <a:buNone/>
             </a:pPr>
             <a:r>
@@ -5957,4 +6055,319 @@
     </a:ext>
   </a:extLst>
 </a:theme>
+</file>
+
+<file path=ppt/theme/theme2.xml><?xml version="1.0" encoding="utf-8"?>
+<a:theme xmlns:a="http://schemas.openxmlformats.org/drawingml/2006/main" name="Office Theme">
+  <a:themeElements>
+    <a:clrScheme name="Office">
+      <a:dk1>
+        <a:sysClr val="windowText" lastClr="000000"/>
+      </a:dk1>
+      <a:lt1>
+        <a:sysClr val="window" lastClr="FFFFFF"/>
+      </a:lt1>
+      <a:dk2>
+        <a:srgbClr val="0E2841"/>
+      </a:dk2>
+      <a:lt2>
+        <a:srgbClr val="E8E8E8"/>
+      </a:lt2>
+      <a:accent1>
+        <a:srgbClr val="156082"/>
+      </a:accent1>
+      <a:accent2>
+        <a:srgbClr val="E97132"/>
+      </a:accent2>
+      <a:accent3>
+        <a:srgbClr val="196B24"/>
+      </a:accent3>
+      <a:accent4>
+        <a:srgbClr val="0F9ED5"/>
+      </a:accent4>
+      <a:accent5>
+        <a:srgbClr val="A02B93"/>
+      </a:accent5>
+      <a:accent6>
+        <a:srgbClr val="4EA72E"/>
+      </a:accent6>
+      <a:hlink>
+        <a:srgbClr val="467886"/>
+      </a:hlink>
+      <a:folHlink>
+        <a:srgbClr val="96607D"/>
+      </a:folHlink>
+    </a:clrScheme>
+    <a:fontScheme name="Office">
+      <a:majorFont>
+        <a:latin typeface="Aptos Display" panose="02110004020202020204"/>
+        <a:ea typeface=""/>
+        <a:cs typeface=""/>
+        <a:font script="Jpan" typeface="游ゴシック Light"/>
+        <a:font script="Hang" typeface="맑은 고딕"/>
+        <a:font script="Hans" typeface="等线 Light"/>
+        <a:font script="Hant" typeface="新細明體"/>
+        <a:font script="Arab" typeface="Times New Roman"/>
+        <a:font script="Hebr" typeface="Times New Roman"/>
+        <a:font script="Thai" typeface="Angsana New"/>
+        <a:font script="Ethi" typeface="Nyala"/>
+        <a:font script="Beng" typeface="Vrinda"/>
+        <a:font script="Gujr" typeface="Shruti"/>
+        <a:font script="Khmr" typeface="MoolBoran"/>
+        <a:font script="Knda" typeface="Tunga"/>
+        <a:font script="Guru" typeface="Raavi"/>
+        <a:font script="Cans" typeface="Euphemia"/>
+        <a:font script="Cher" typeface="Plantagenet Cherokee"/>
+        <a:font script="Yiii" typeface="Microsoft Yi Baiti"/>
+        <a:font script="Tibt" typeface="Microsoft Himalaya"/>
+        <a:font script="Thaa" typeface="MV Boli"/>
+        <a:font script="Deva" typeface="Mangal"/>
+        <a:font script="Telu" typeface="Gautami"/>
+        <a:font script="Taml" typeface="Latha"/>
+        <a:font script="Syrc" typeface="Estrangelo Edessa"/>
+        <a:font script="Orya" typeface="Kalinga"/>
+        <a:font script="Mlym" typeface="Kartika"/>
+        <a:font script="Laoo" typeface="DokChampa"/>
+        <a:font script="Sinh" typeface="Iskoola Pota"/>
+        <a:font script="Mong" typeface="Mongolian Baiti"/>
+        <a:font script="Viet" typeface="Times New Roman"/>
+        <a:font script="Uigh" typeface="Microsoft Uighur"/>
+        <a:font script="Geor" typeface="Sylfaen"/>
+        <a:font script="Armn" typeface="Arial"/>
+        <a:font script="Bugi" typeface="Leelawadee UI"/>
+        <a:font script="Bopo" typeface="Microsoft JhengHei"/>
+        <a:font script="Java" typeface="Javanese Text"/>
+        <a:font script="Lisu" typeface="Segoe UI"/>
+        <a:font script="Mymr" typeface="Myanmar Text"/>
+        <a:font script="Nkoo" typeface="Ebrima"/>
+        <a:font script="Olck" typeface="Nirmala UI"/>
+        <a:font script="Osma" typeface="Ebrima"/>
+        <a:font script="Phag" typeface="Phagspa"/>
+        <a:font script="Syrn" typeface="Estrangelo Edessa"/>
+        <a:font script="Syrj" typeface="Estrangelo Edessa"/>
+        <a:font script="Syre" typeface="Estrangelo Edessa"/>
+        <a:font script="Sora" typeface="Nirmala UI"/>
+        <a:font script="Tale" typeface="Microsoft Tai Le"/>
+        <a:font script="Talu" typeface="Microsoft New Tai Lue"/>
+        <a:font script="Tfng" typeface="Ebrima"/>
+      </a:majorFont>
+      <a:minorFont>
+        <a:latin typeface="Aptos" panose="02110004020202020204"/>
+        <a:ea typeface=""/>
+        <a:cs typeface=""/>
+        <a:font script="Jpan" typeface="游ゴシック"/>
+        <a:font script="Hang" typeface="맑은 고딕"/>
+        <a:font script="Hans" typeface="等线"/>
+        <a:font script="Hant" typeface="新細明體"/>
+        <a:font script="Arab" typeface="Arial"/>
+        <a:font script="Hebr" typeface="Arial"/>
+        <a:font script="Thai" typeface="Cordia New"/>
+        <a:font script="Ethi" typeface="Nyala"/>
+        <a:font script="Beng" typeface="Vrinda"/>
+        <a:font script="Gujr" typeface="Shruti"/>
+        <a:font script="Khmr" typeface="DaunPenh"/>
+        <a:font script="Knda" typeface="Tunga"/>
+        <a:font script="Guru" typeface="Raavi"/>
+        <a:font script="Cans" typeface="Euphemia"/>
+        <a:font script="Cher" typeface="Plantagenet Cherokee"/>
+        <a:font script="Yiii" typeface="Microsoft Yi Baiti"/>
+        <a:font script="Tibt" typeface="Microsoft Himalaya"/>
+        <a:font script="Thaa" typeface="MV Boli"/>
+        <a:font script="Deva" typeface="Mangal"/>
+        <a:font script="Telu" typeface="Gautami"/>
+        <a:font script="Taml" typeface="Latha"/>
+        <a:font script="Syrc" typeface="Estrangelo Edessa"/>
+        <a:font script="Orya" typeface="Kalinga"/>
+        <a:font script="Mlym" typeface="Kartika"/>
+        <a:font script="Laoo" typeface="DokChampa"/>
+        <a:font script="Sinh" typeface="Iskoola Pota"/>
+        <a:font script="Mong" typeface="Mongolian Baiti"/>
+        <a:font script="Viet" typeface="Arial"/>
+        <a:font script="Uigh" typeface="Microsoft Uighur"/>
+        <a:font script="Geor" typeface="Sylfaen"/>
+        <a:font script="Armn" typeface="Arial"/>
+        <a:font script="Bugi" typeface="Leelawadee UI"/>
+        <a:font script="Bopo" typeface="Microsoft JhengHei"/>
+        <a:font script="Java" typeface="Javanese Text"/>
+        <a:font script="Lisu" typeface="Segoe UI"/>
+        <a:font script="Mymr" typeface="Myanmar Text"/>
+        <a:font script="Nkoo" typeface="Ebrima"/>
+        <a:font script="Olck" typeface="Nirmala UI"/>
+        <a:font script="Osma" typeface="Ebrima"/>
+        <a:font script="Phag" typeface="Phagspa"/>
+        <a:font script="Syrn" typeface="Estrangelo Edessa"/>
+        <a:font script="Syrj" typeface="Estrangelo Edessa"/>
+        <a:font script="Syre" typeface="Estrangelo Edessa"/>
+        <a:font script="Sora" typeface="Nirmala UI"/>
+        <a:font script="Tale" typeface="Microsoft Tai Le"/>
+        <a:font script="Talu" typeface="Microsoft New Tai Lue"/>
+        <a:font script="Tfng" typeface="Ebrima"/>
+      </a:minorFont>
+    </a:fontScheme>
+    <a:fmtScheme name="Office">
+      <a:fillStyleLst>
+        <a:solidFill>
+          <a:schemeClr val="phClr"/>
+        </a:solidFill>
+        <a:gradFill rotWithShape="1">
+          <a:gsLst>
+            <a:gs pos="0">
+              <a:schemeClr val="phClr">
+                <a:lumMod val="110000"/>
+                <a:satMod val="105000"/>
+                <a:tint val="67000"/>
+              </a:schemeClr>
+            </a:gs>
+            <a:gs pos="50000">
+              <a:schemeClr val="phClr">
+                <a:lumMod val="105000"/>
+                <a:satMod val="103000"/>
+                <a:tint val="73000"/>
+              </a:schemeClr>
+            </a:gs>
+            <a:gs pos="100000">
+              <a:schemeClr val="phClr">
+                <a:lumMod val="105000"/>
+                <a:satMod val="109000"/>
+                <a:tint val="81000"/>
+              </a:schemeClr>
+            </a:gs>
+          </a:gsLst>
+          <a:lin ang="5400000" scaled="0"/>
+        </a:gradFill>
+        <a:gradFill rotWithShape="1">
+          <a:gsLst>
+            <a:gs pos="0">
+              <a:schemeClr val="phClr">
+                <a:satMod val="103000"/>
+                <a:lumMod val="102000"/>
+                <a:tint val="94000"/>
+              </a:schemeClr>
+            </a:gs>
+            <a:gs pos="50000">
+              <a:schemeClr val="phClr">
+                <a:satMod val="110000"/>
+                <a:lumMod val="100000"/>
+                <a:shade val="100000"/>
+              </a:schemeClr>
+            </a:gs>
+            <a:gs pos="100000">
+              <a:schemeClr val="phClr">
+                <a:lumMod val="99000"/>
+                <a:satMod val="120000"/>
+                <a:shade val="78000"/>
+              </a:schemeClr>
+            </a:gs>
+          </a:gsLst>
+          <a:lin ang="5400000" scaled="0"/>
+        </a:gradFill>
+      </a:fillStyleLst>
+      <a:lnStyleLst>
+        <a:ln w="12700" cap="flat" cmpd="sng" algn="ctr">
+          <a:solidFill>
+            <a:schemeClr val="phClr"/>
+          </a:solidFill>
+          <a:prstDash val="solid"/>
+          <a:miter lim="800000"/>
+        </a:ln>
+        <a:ln w="19050" cap="flat" cmpd="sng" algn="ctr">
+          <a:solidFill>
+            <a:schemeClr val="phClr"/>
+          </a:solidFill>
+          <a:prstDash val="solid"/>
+          <a:miter lim="800000"/>
+        </a:ln>
+        <a:ln w="25400" cap="flat" cmpd="sng" algn="ctr">
+          <a:solidFill>
+            <a:schemeClr val="phClr"/>
+          </a:solidFill>
+          <a:prstDash val="solid"/>
+          <a:miter lim="800000"/>
+        </a:ln>
+      </a:lnStyleLst>
+      <a:effectStyleLst>
+        <a:effectStyle>
+          <a:effectLst/>
+        </a:effectStyle>
+        <a:effectStyle>
+          <a:effectLst/>
+        </a:effectStyle>
+        <a:effectStyle>
+          <a:effectLst>
+            <a:outerShdw blurRad="57150" dist="19050" dir="5400000" algn="ctr" rotWithShape="0">
+              <a:srgbClr val="000000">
+                <a:alpha val="63000"/>
+              </a:srgbClr>
+            </a:outerShdw>
+          </a:effectLst>
+        </a:effectStyle>
+      </a:effectStyleLst>
+      <a:bgFillStyleLst>
+        <a:solidFill>
+          <a:schemeClr val="phClr"/>
+        </a:solidFill>
+        <a:solidFill>
+          <a:schemeClr val="phClr">
+            <a:tint val="95000"/>
+            <a:satMod val="170000"/>
+          </a:schemeClr>
+        </a:solidFill>
+        <a:gradFill rotWithShape="1">
+          <a:gsLst>
+            <a:gs pos="0">
+              <a:schemeClr val="phClr">
+                <a:tint val="93000"/>
+                <a:satMod val="150000"/>
+                <a:shade val="98000"/>
+                <a:lumMod val="102000"/>
+              </a:schemeClr>
+            </a:gs>
+            <a:gs pos="50000">
+              <a:schemeClr val="phClr">
+                <a:tint val="98000"/>
+                <a:satMod val="130000"/>
+                <a:shade val="90000"/>
+                <a:lumMod val="103000"/>
+              </a:schemeClr>
+            </a:gs>
+            <a:gs pos="100000">
+              <a:schemeClr val="phClr">
+                <a:shade val="63000"/>
+                <a:satMod val="120000"/>
+              </a:schemeClr>
+            </a:gs>
+          </a:gsLst>
+          <a:lin ang="5400000" scaled="0"/>
+        </a:gradFill>
+      </a:bgFillStyleLst>
+    </a:fmtScheme>
+  </a:themeElements>
+  <a:objectDefaults>
+    <a:lnDef>
+      <a:spPr/>
+      <a:bodyPr/>
+      <a:lstStyle/>
+      <a:style>
+        <a:lnRef idx="2">
+          <a:schemeClr val="accent1"/>
+        </a:lnRef>
+        <a:fillRef idx="0">
+          <a:schemeClr val="accent1"/>
+        </a:fillRef>
+        <a:effectRef idx="1">
+          <a:schemeClr val="accent1"/>
+        </a:effectRef>
+        <a:fontRef idx="minor">
+          <a:schemeClr val="tx1"/>
+        </a:fontRef>
+      </a:style>
+    </a:lnDef>
+  </a:objectDefaults>
+  <a:extraClrSchemeLst/>
+  <a:extLst>
+    <a:ext uri="{05A4C25C-085E-4340-85A3-A5531E510DB2}">
+      <thm15:themeFamily xmlns:thm15="http://schemas.microsoft.com/office/thememl/2012/main" name="Office Theme" id="{2E142A2C-CD16-42D6-873A-C26D2A0506FA}" vid="{1BDDFF52-6CD6-40A5-AB3C-68EB2F1E4D0A}"/>
+    </a:ext>
+  </a:extLst>
+</a:theme>
 </file>
</xml_diff>

<commit_message>
Fig. 5: linked, layered SVG from the .pptx, svgtune walkthrough; PR #8 facts, BEP044
- tools/pptx2svg.py: one-slide .pptx -> SVG keeping editable text and the
  slide's z-order, adding links and build steps (Inkscape layers) from a
  YAML file (figures/fig5_bbqs_stack/fig5_bbqs_stack.yaml); make fig5
- fig5_bbqs_stack.svgtune: walkthrough stack -> data -> NWB path -> BIDS
  path (NWB dimmed) -> companion proposals -> Psych-DS path -> ontologies -> gaps
- .pptx: eye tracking and EMG are in BIDS since v1.11 (BEP020/BEP042 chip
  replaced by BEP044 stimuli); EMG is its own data type on the BIDS path, not
  a gap; NWB in BIDS: allowed for iEEG, BEP032 adds microelectrode ephys
- PNG preview rendered from the SVG at 300 dpi

Co-Authored-By: Claude Opus 5.5 <noreply@anthropic.com>
Claude-Session: https://claude.ai/code/session_01PvaGRZJaUPtEPToH7V7Xjs
</commit_message>
<xml_diff>
--- a/figures/fig5_bbqs_stack/fig5_bbqs_stack_design.pptx
+++ b/figures/fig5_bbqs_stack/fig5_bbqs_stack_design.pptx
@@ -285,7 +285,7 @@
               <a:rPr lang="en-US" dirty="0"/>
               <a:t>Fig. 5 design draft v4 (spec: draft/12_figures_tables.md). Sources: Table 3, BBQS standards guideline, Standards4BBQS forum slides (Oct 2026).
 Stack: rows 1 data formats, 2 file organization, 3 dataset organization, 5 data archives. Ontologies &amp; terminologies (4) and schema languages (6) are side panels next to rows 2-3, which they both serve.
-Paths: NWB (orange) runs from the data through NWB to EMBER; BIDS (green) and Psych-DS (slate) run from the data to EMBER. A green arrow from NWB to the BIDS path shows that BIDS can include NWB files.
+Paths: NWB (orange) runs from the data through NWB to EMBER; BIDS (green) and Psych-DS (slate) run from the data to EMBER. A green arrow from NWB to the BIDS path shows that BIDS allows NWB files for iEEG; BEP032 would add microelectrode ephys. Eye tracking and EMG are in BIDS since v1.11; EMG is a data type on the BIDS path only. BEP044 (stimuli) is in progress next to BEP047.
 NWB extensions and enhancement proposals are labelled by purpose: pose estimation (ndx-pose, NWBEP in preparation), structured behavior (ndx-structured-behavior), microscopy (NWBEP004), HED annotation (ndx-hed), fiber photometry, wearable devices, multi-subject (ndx-multisubjects, NWBEP in preparation), ethogram. A dashed green line joins Multi-subject to the planned multi-subject BEP (companion proposals). Standards boxes are outlined in the colour of their path (DANDI layout orange, Psych-DS slate).
 Panel 6: HDMF defines NWB, the BIDS schema defines BIDS, LinkML defines Psych-DS and Neuro Termsets (translations of the Dandiset and NWB schemas to LinkML are planned), and JSON Schema generated from Pydantic models (dandi-schema; published in dandi/schema) defines DANDI layout and EMBER archive metadata.
 Panel 4: each terminology is its own box; arrows show the terminologies Neuro Termsets draws on (Cell Ontology is not yet a term set).
@@ -2323,7 +2323,7 @@
                 <a:ea typeface="Arial" pitchFamily="34" charset="-122"/>
                 <a:cs typeface="Arial" pitchFamily="34" charset="-120"/>
               </a:rPr>
-              <a:t>EEG, iEEG</a:t>
+              <a:t>EEG, iEEG, EMG</a:t>
             </a:r>
             <a:endParaRPr lang="en-US" sz="1000" dirty="0"/>
           </a:p>
@@ -2982,7 +2982,7 @@
         <p:spPr>
           <a:xfrm>
             <a:off x="4645152" y="3867912"/>
-            <a:ext cx="1197864" cy="310896"/>
+            <a:ext cx="1216152" cy="475488"/>
           </a:xfrm>
           <a:prstGeom prst="rect">
             <a:avLst/>
@@ -3006,7 +3006,7 @@
                 <a:ea typeface="Arial" pitchFamily="34" charset="-122"/>
                 <a:cs typeface="Arial" pitchFamily="34" charset="-120"/>
               </a:rPr>
-              <a:t>BIDS can contain NWB files (BEP032)</a:t>
+              <a:t>BIDS allows NWB for iEEG; BEP032 adds microelectrode ephys</a:t>
             </a:r>
             <a:endParaRPr lang="en-US" sz="950" dirty="0"/>
           </a:p>
@@ -3136,7 +3136,7 @@
                 <a:ea typeface="Arial" pitchFamily="34" charset="-122"/>
                 <a:cs typeface="Arial" pitchFamily="34" charset="-120"/>
               </a:rPr>
-              <a:t>MRI · PET · EEG / MEG / iEEG · microscopy · motion · physiology · behavior and task events · stimuli</a:t>
+              <a:t>MRI · PET · EEG / MEG / iEEG · microscopy · motion · physiology · eye tracking · EMG · behavior and task events · stimuli</a:t>
             </a:r>
             <a:endParaRPr lang="en-US" sz="1000" dirty="0"/>
           </a:p>
@@ -3274,7 +3274,7 @@
       </p:sp>
       <p:sp>
         <p:nvSpPr>
-          <p:cNvPr id="55" name="BIDS BEP020 · BEP042"/>
+          <p:cNvPr id="55" name="BIDS BEP044"/>
           <p:cNvSpPr/>
           <p:nvPr/>
         </p:nvSpPr>
@@ -3314,7 +3314,7 @@
                 <a:ea typeface="Arial" pitchFamily="34" charset="-122"/>
                 <a:cs typeface="Arial" pitchFamily="34" charset="-120"/>
               </a:rPr>
-              <a:t>BEP020 · BEP042</a:t>
+              <a:t>BEP044</a:t>
             </a:r>
             <a:endParaRPr lang="en-US" sz="1000" dirty="0"/>
           </a:p>
@@ -3331,7 +3331,7 @@
                 <a:ea typeface="Arial" pitchFamily="34" charset="-122"/>
                 <a:cs typeface="Arial" pitchFamily="34" charset="-120"/>
               </a:rPr>
-              <a:t>eye tracking · EMG</a:t>
+              <a:t>stimuli</a:t>
             </a:r>
             <a:endParaRPr lang="en-US" sz="1000" dirty="0"/>
           </a:p>
@@ -4956,7 +4956,7 @@
         <p:spPr>
           <a:xfrm>
             <a:off x="4184904" y="6793992"/>
-            <a:ext cx="3480816" cy="0"/>
+            <a:ext cx="4593336" cy="0"/>
           </a:xfrm>
           <a:prstGeom prst="line">
             <a:avLst/>
@@ -5691,14 +5691,123 @@
       </p:sp>
       <p:sp>
         <p:nvSpPr>
+          <p:cNvPr id="113" name="Data: EMG"/>
+          <p:cNvSpPr/>
+          <p:nvPr/>
+        </p:nvSpPr>
+        <p:spPr>
+          <a:xfrm>
+            <a:off x="8503920" y="7040880"/>
+            <a:ext cx="548640" cy="713232"/>
+          </a:xfrm>
+          <a:prstGeom prst="rect">
+            <a:avLst/>
+          </a:prstGeom>
+          <a:solidFill>
+            <a:srgbClr val="8A96A3">
+              <a:alpha val="15000"/>
+            </a:srgbClr>
+          </a:solidFill>
+          <a:ln w="12700">
+            <a:solidFill>
+              <a:srgbClr val="8A96A3"/>
+            </a:solidFill>
+          </a:ln>
+        </p:spPr>
+        <p:txBody>
+          <a:bodyPr wrap="square" lIns="19050" tIns="0" rIns="19050" bIns="0" rtlCol="0" anchor="ctr"/>
+          <a:lstStyle/>
+          <a:p>
+            <a:pPr marL="0" indent="0" algn="ctr">
+              <a:buNone/>
+            </a:pPr>
+            <a:r>
+              <a:rPr lang="en-US" sz="950" b="1" dirty="0">
+                <a:solidFill>
+                  <a:srgbClr val="1F2933"/>
+                </a:solidFill>
+                <a:latin typeface="Arial" pitchFamily="34" charset="0"/>
+                <a:ea typeface="Arial" pitchFamily="34" charset="-122"/>
+                <a:cs typeface="Arial" pitchFamily="34" charset="-120"/>
+              </a:rPr>
+              <a:t>EMG</a:t>
+            </a:r>
+            <a:endParaRPr lang="en-US" sz="1000" dirty="0"/>
+          </a:p>
+        </p:txBody>
+      </p:sp>
+      <p:sp>
+        <p:nvSpPr>
+          <p:cNvPr id="114" name="Feed B"/>
+          <p:cNvSpPr/>
+          <p:nvPr/>
+        </p:nvSpPr>
+        <p:spPr>
+          <a:xfrm>
+            <a:off x="8778240" y="6793992"/>
+            <a:ext cx="0" cy="246888"/>
+          </a:xfrm>
+          <a:prstGeom prst="line">
+            <a:avLst/>
+          </a:prstGeom>
+          <a:noFill/>
+          <a:ln w="15875">
+            <a:solidFill>
+              <a:srgbClr val="009E73"/>
+            </a:solidFill>
+            <a:prstDash val="solid"/>
+          </a:ln>
+        </p:spPr>
+        <p:txBody>
+          <a:bodyPr/>
+          <a:lstStyle/>
+          <a:p>
+            <a:endParaRPr lang="en-US"/>
+          </a:p>
+        </p:txBody>
+      </p:sp>
+      <p:sp>
+        <p:nvSpPr>
+          <p:cNvPr id="115" name="Join B"/>
+          <p:cNvSpPr/>
+          <p:nvPr/>
+        </p:nvSpPr>
+        <p:spPr>
+          <a:xfrm>
+            <a:off x="8741664" y="6757416"/>
+            <a:ext cx="73152" cy="73152"/>
+          </a:xfrm>
+          <a:prstGeom prst="ellipse">
+            <a:avLst/>
+          </a:prstGeom>
+          <a:solidFill>
+            <a:srgbClr val="009E73"/>
+          </a:solidFill>
+          <a:ln w="6350">
+            <a:solidFill>
+              <a:srgbClr val="009E73"/>
+            </a:solidFill>
+            <a:prstDash val="solid"/>
+          </a:ln>
+        </p:spPr>
+        <p:txBody>
+          <a:bodyPr/>
+          <a:lstStyle/>
+          <a:p>
+            <a:endParaRPr lang="en-US"/>
+          </a:p>
+        </p:txBody>
+      </p:sp>
+      <p:sp>
+        <p:nvSpPr>
           <p:cNvPr id="112" name="Data without a standard"/>
           <p:cNvSpPr/>
           <p:nvPr/>
         </p:nvSpPr>
         <p:spPr>
           <a:xfrm>
-            <a:off x="8503920" y="7040880"/>
-            <a:ext cx="3300984" cy="713232"/>
+            <a:off x="9107424" y="7040880"/>
+            <a:ext cx="2697480" cy="713232"/>
           </a:xfrm>
           <a:prstGeom prst="rect">
             <a:avLst/>
@@ -5748,7 +5857,7 @@
                 <a:ea typeface="Arial" pitchFamily="34" charset="-122"/>
                 <a:cs typeface="Arial" pitchFamily="34" charset="-120"/>
               </a:rPr>
-              <a:t>Social interactions · feeding · facial expressions · home-cage monitoring · VR · force plates · EMG</a:t>
+              <a:t>Social interactions · feeding · facial expressions · home-cage monitoring · VR · force plates</a:t>
             </a:r>
             <a:endParaRPr lang="en-US" sz="1000" dirty="0"/>
           </a:p>

</xml_diff>